<commit_message>
deck_dyson_record: summary table (spectrometer / telescope / together, specification beside), the telescope as a first design with its open items, alternatives to the Dyson at the 3k slit, three asks of Jim
Co-Authored-By: Claude Fable 5.1 <noreply@anthropic.com>
</commit_message>
<xml_diff>
--- a/demo_session/deck_dyson_record.pptx
+++ b/demo_session/deck_dyson_record.pptx
@@ -25,6 +25,8 @@
     <p:sldId id="273" r:id="rId24"/>
     <p:sldId id="274" r:id="rId25"/>
     <p:sldId id="275" r:id="rId26"/>
+    <p:sldId id="276" r:id="rId27"/>
+    <p:sldId id="277" r:id="rId28"/>
   </p:sldIdLst>
   <p:sldSz cx="12191695" cy="6858000" type="screen4x3"/>
   <p:notesSz cx="6858000" cy="9144000"/>
@@ -3228,7 +3230,7 @@
                 </a:solidFill>
                 <a:latin typeface="Arial"/>
               </a:rPr>
-              <a:t>DRAFT for review, 2026-10-06.  The 1.5k module (1500 cross-track pixels, a 27 mm slit) has a telescope and a spectrometer of record that image at the pixel end to end: smile 0.51, keystone 0.01, CRF 1.22, SRF 2.20 pixels, every clearance positive; four such modules carry 6000 pixels in 6.6 kg of fused silica.  The 3k module's telescope is not yet at the pixel (CRF 4.2 pixels), so the two-module CaF2 option waits on it.</a:t>
+              <a:t>DRAFT for review, 2026-10-06.  The 1.5k module (1500 cross-track pixels, a 27 mm slit) has a spectrometer of record and a first telescope that together image at the pixel end to end: smile 0.51, keystone 0.01, CRF 1.22, SRF 2.20 pixels, every clearance positive; four such modules carry 6000 pixels in 6.6 kg of fused silica.  The telescope is not finished and the 3k module's is not yet at the pixel (CRF 4.2 pixels); the deck asks Jim's help with both.</a:t>
             </a:r>
           </a:p>
         </p:txBody>
@@ -3285,7 +3287,7 @@
                 </a:solidFill>
                 <a:latin typeface="Arial"/>
               </a:rPr>
-              <a:t>Next steps</a:t>
+              <a:t>Alternatives to the Dyson for the 3k slit</a:t>
             </a:r>
           </a:p>
           <a:p>
@@ -3301,7 +3303,7 @@
                 </a:solidFill>
                 <a:latin typeface="Arial"/>
               </a:rPr>
-              <a:t>The 3k telescope, the cold window, the radiometric chain</a:t>
+              <a:t>The Dyson was assumed for this challenge; at a 54 mm slit the literature offers three other forms, and the record's own result points at a fourth</a:t>
             </a:r>
           </a:p>
         </p:txBody>
@@ -3384,7 +3386,7 @@
                 </a:solidFill>
                 <a:latin typeface="Arial"/>
               </a:rPr>
-              <a:t>•  The 3k telescope: the stop at M2; an asphere-only solve from the freeform seed; a merit written on the response-function width for the final step; the field weighting across the strip as a ruling.</a:t>
+              <a:t>•  The Offner (concave sphere used twice, convex grating at the stop).  All-reflective: no CaF2, no air-glass crossings, every leg in air, so a cold shield costs nothing.  The review's long-slit example is F/2.8 with a 48 mm slit at 30 µm pixels (smile 0.3 %, keystone 2 % of a pixel, 0.76 in a pixel).  The record's Offner at F/2.8 and 0.22 R, with the classical corrections, reaches keystone 0.028 px and CRF 1.20 px but SRF 3.69 px and 0.23 in a pixel; an F/1.8 Offner at a 54 mm slit has not been tried here.</a:t>
             </a:r>
           </a:p>
           <a:p>
@@ -3400,7 +3402,7 @@
                 </a:solidFill>
                 <a:latin typeface="Arial"/>
               </a:rPr>
-              <a:t>•  The 1.5k module's package: the cold window cemented as the block's exit face with the shield as the detector housing behind it, under the same clearance check; the 1.5 mm of working distance the 130 mm module tolerates is where it goes.</a:t>
+              <a:t>•  The prism Dyson (the review's BPDS, 3200 px, 18 µm, F/2, 57.6 mm slit): a freeform prism in place of the grating, 54 cm long with a 19 cm prism; achieved smile 3 % and keystone 1 % of a pixel.  It is the published answer in this regime, and its size is the price.</a:t>
             </a:r>
           </a:p>
           <a:p>
@@ -3416,7 +3418,7 @@
                 </a:solidFill>
                 <a:latin typeface="Arial"/>
               </a:rPr>
-              <a:t>•  The radiometric chain against the band: throughput, grating efficiency, detector quantum efficiency and the slit's diffraction loss (0.3 % at 380 nm to 1.8 % at 2500 nm past the grating, before the telescope's cone).</a:t>
+              <a:t>•  A long-slit Dyson with a separate mirror and a meniscus (the review's compact variant, about 60 % of the BPDS's size, six more air-glass faces): the family the 220 mm meniscus design belongs to.</a:t>
             </a:r>
           </a:p>
         </p:txBody>
@@ -3455,7 +3457,7 @@
                 </a:solidFill>
                 <a:latin typeface="Arial"/>
               </a:rPr>
-              <a:t>•  In the engine: a fixed-station reference sphere for the wavefront merit on telecentric designs; an asphere-plus-Zernike surface in one declaration; a short-line guard for every multi-value prescription keyword.</a:t>
+              <a:t>•  Split the slit, keep one telescope.  The record's own finding is that at 3k the spectrometer closes (CaF2 at 240 mm, or silica with the meniscus) and the telescope does not.  A 3k telescope feeding two 1.5k Dysons through a split slit keeps two telescopes and four small silica blocks, but it needs the 3k telescope, which is the open item.</a:t>
             </a:r>
           </a:p>
           <a:p>
@@ -3471,7 +3473,46 @@
                 </a:solidFill>
                 <a:latin typeface="Arial"/>
               </a:rPr>
-              <a:t>•  Later, once the design of record is stable: full diffraction from the slit through the grating to the detector (the slit's truncation of the telescope's image, about 10 % on the response functions in the literature); polarization sensitivity of the Dyson against the Offner; a surface-by-surface tour of the prescription.</a:t>
+              <a:t>•  What the ray trace can settle quickly: the Offner has a layout solver in the chain (offner_solve), so an F/1.8, 54 mm Offner can be laid out, emitted and scored on the same scorer in about a day; the prism Dyson needs a dispersing prism added to the chain first (the engine traces it already).  Which is worth the time is a question for Jim and Joe.</a:t>
+            </a:r>
+          </a:p>
+        </p:txBody>
+      </p:sp>
+      <p:sp>
+        <p:nvSpPr>
+          <p:cNvPr id="6" name="TextBox 5"/>
+          <p:cNvSpPr txBox="1"/>
+          <p:nvPr/>
+        </p:nvSpPr>
+        <p:spPr>
+          <a:xfrm>
+            <a:off x="6400800" y="3596639"/>
+            <a:ext cx="5394960" cy="274320"/>
+          </a:xfrm>
+          <a:prstGeom prst="rect">
+            <a:avLst/>
+          </a:prstGeom>
+          <a:noFill/>
+        </p:spPr>
+        <p:txBody>
+          <a:bodyPr wrap="square">
+            <a:spAutoFit/>
+          </a:bodyPr>
+          <a:lstStyle/>
+          <a:p>
+            <a:pPr>
+              <a:spcAft>
+                <a:spcPts val="600"/>
+              </a:spcAft>
+            </a:pPr>
+            <a:r>
+              <a:rPr sz="1050" b="0">
+                <a:solidFill>
+                  <a:srgbClr val="6E6E6E"/>
+                </a:solidFill>
+                <a:latin typeface="Arial"/>
+              </a:rPr>
+              <a:t>Review: Mouroulis &amp; Green, Opt. Eng. 57(4) 040901 (2018), Table 2 and Table 5.  The Offner numbers are the record's dyson5_s1_offner (dyson5_s2.txt).  Nothing on this slide has been traced at the 3k slit except the Dyson rows of slide 8.</a:t>
             </a:r>
           </a:p>
         </p:txBody>
@@ -3485,6 +3526,476 @@
 </file>
 
 <file path=ppt/slides/slide11.xml><?xml version="1.0" encoding="utf-8"?>
+<p:sld xmlns:a="http://schemas.openxmlformats.org/drawingml/2006/main" xmlns:p="http://schemas.openxmlformats.org/presentationml/2006/main" xmlns:r="http://schemas.openxmlformats.org/officeDocument/2006/relationships">
+  <p:cSld>
+    <p:spTree>
+      <p:nvGrpSpPr>
+        <p:cNvPr id="1" name=""/>
+        <p:cNvGrpSpPr/>
+        <p:nvPr/>
+      </p:nvGrpSpPr>
+      <p:grpSpPr/>
+      <p:sp>
+        <p:nvSpPr>
+          <p:cNvPr id="2" name="TextBox 1"/>
+          <p:cNvSpPr txBox="1"/>
+          <p:nvPr/>
+        </p:nvSpPr>
+        <p:spPr>
+          <a:xfrm>
+            <a:off x="411480" y="201168"/>
+            <a:ext cx="11368735" cy="914400"/>
+          </a:xfrm>
+          <a:prstGeom prst="rect">
+            <a:avLst/>
+          </a:prstGeom>
+          <a:noFill/>
+        </p:spPr>
+        <p:txBody>
+          <a:bodyPr wrap="square">
+            <a:spAutoFit/>
+          </a:bodyPr>
+          <a:lstStyle/>
+          <a:p>
+            <a:pPr>
+              <a:spcAft>
+                <a:spcPts val="400"/>
+              </a:spcAft>
+            </a:pPr>
+            <a:r>
+              <a:rPr sz="2400" b="1">
+                <a:solidFill>
+                  <a:srgbClr val="1F4E79"/>
+                </a:solidFill>
+                <a:latin typeface="Arial"/>
+              </a:rPr>
+              <a:t>Three asks of Jim</a:t>
+            </a:r>
+          </a:p>
+          <a:p>
+            <a:pPr>
+              <a:spcAft>
+                <a:spcPts val="0"/>
+              </a:spcAft>
+            </a:pPr>
+            <a:r>
+              <a:rPr sz="1250" b="0">
+                <a:solidFill>
+                  <a:srgbClr val="6E6E6E"/>
+                </a:solidFill>
+                <a:latin typeface="Arial"/>
+              </a:rPr>
+              <a:t>Two decisions the ray trace cannot make, and help with the part that is not done</a:t>
+            </a:r>
+          </a:p>
+        </p:txBody>
+      </p:sp>
+      <p:sp>
+        <p:nvSpPr>
+          <p:cNvPr id="3" name="Rectangle 2"/>
+          <p:cNvSpPr/>
+          <p:nvPr/>
+        </p:nvSpPr>
+        <p:spPr>
+          <a:xfrm>
+            <a:off x="411480" y="1133856"/>
+            <a:ext cx="11368735" cy="20320"/>
+          </a:xfrm>
+          <a:prstGeom prst="rect">
+            <a:avLst/>
+          </a:prstGeom>
+          <a:solidFill>
+            <a:srgbClr val="B8C6D4"/>
+          </a:solidFill>
+          <a:ln>
+            <a:noFill/>
+          </a:ln>
+          <a:effectLst/>
+        </p:spPr>
+        <p:style>
+          <a:lnRef idx="1">
+            <a:schemeClr val="accent1"/>
+          </a:lnRef>
+          <a:fillRef idx="3">
+            <a:schemeClr val="accent1"/>
+          </a:fillRef>
+          <a:effectRef idx="2">
+            <a:schemeClr val="accent1"/>
+          </a:effectRef>
+          <a:fontRef idx="minor">
+            <a:schemeClr val="lt1"/>
+          </a:fontRef>
+        </p:style>
+        <p:txBody>
+          <a:bodyPr rtlCol="0" anchor="ctr"/>
+          <a:lstStyle/>
+          <a:p>
+            <a:pPr algn="ctr"/>
+          </a:p>
+        </p:txBody>
+      </p:sp>
+      <p:sp>
+        <p:nvSpPr>
+          <p:cNvPr id="4" name="TextBox 3"/>
+          <p:cNvSpPr txBox="1"/>
+          <p:nvPr/>
+        </p:nvSpPr>
+        <p:spPr>
+          <a:xfrm>
+            <a:off x="411480" y="1298448"/>
+            <a:ext cx="11368735" cy="274320"/>
+          </a:xfrm>
+          <a:prstGeom prst="rect">
+            <a:avLst/>
+          </a:prstGeom>
+          <a:noFill/>
+        </p:spPr>
+        <p:txBody>
+          <a:bodyPr wrap="square">
+            <a:spAutoFit/>
+          </a:bodyPr>
+          <a:lstStyle/>
+          <a:p>
+            <a:pPr>
+              <a:spcAft>
+                <a:spcPts val="600"/>
+              </a:spcAft>
+            </a:pPr>
+            <a:r>
+              <a:rPr sz="1500" b="0">
+                <a:solidFill>
+                  <a:srgbClr val="282828"/>
+                </a:solidFill>
+                <a:latin typeface="Arial"/>
+              </a:rPr>
+              <a:t>•  Two modules or four.  The 1.5k module now has a telescope at the pixel end to end (slides 4–6); the 3k module does not yet (slide 9).  At the same 6000 cross-track pixels, four telescopes, spectrometers and detectors in 6.6 kg of fused silica against two in 28.5 kg of CaF2: is four a packaging the project would entertain?</a:t>
+            </a:r>
+          </a:p>
+          <a:p>
+            <a:pPr>
+              <a:spcAft>
+                <a:spcPts val="600"/>
+              </a:spcAft>
+            </a:pPr>
+            <a:r>
+              <a:rPr sz="1500" b="0">
+                <a:solidFill>
+                  <a:srgbClr val="282828"/>
+                </a:solidFill>
+                <a:latin typeface="Arial"/>
+              </a:rPr>
+              <a:t>•  The CaF2 volume.  Two 240 mm blocks need 12.4 L of single-crystal CaF2 to carve from (6.2 L each, clear aperture + 20 mm each way; 19.6 L at the 300 mm blocks that put all the energy in a pixel).  What does that cost against two to four fused-silica blocks of 0.75 L?</a:t>
+            </a:r>
+          </a:p>
+          <a:p>
+            <a:pPr>
+              <a:spcAft>
+                <a:spcPts val="600"/>
+              </a:spcAft>
+            </a:pPr>
+            <a:r>
+              <a:rPr sz="1500" b="0">
+                <a:solidFill>
+                  <a:srgbClr val="282828"/>
+                </a:solidFill>
+                <a:latin typeface="Arial"/>
+              </a:rPr>
+              <a:t>•  The telescope, and the tricks.  The telescope is a first design: the strip ends at 0.8 px, 2 mm of aspheric departure on M1, no tolerancing.  Help in bringing it home is asked for: the forms that have worked at 183 mm, F/1.8 and a 4.7–9.4° strip into a telecentric slit; and, more generally, the tricks for throughput (beyond cementing the window and a two-layer coating, 0.81 → 0.91) and for performance that the public record does not show.</a:t>
+            </a:r>
+          </a:p>
+        </p:txBody>
+      </p:sp>
+      <p:sp>
+        <p:nvSpPr>
+          <p:cNvPr id="5" name="TextBox 4"/>
+          <p:cNvSpPr txBox="1"/>
+          <p:nvPr/>
+        </p:nvSpPr>
+        <p:spPr>
+          <a:xfrm>
+            <a:off x="411480" y="4232148"/>
+            <a:ext cx="11368735" cy="274320"/>
+          </a:xfrm>
+          <a:prstGeom prst="rect">
+            <a:avLst/>
+          </a:prstGeom>
+          <a:noFill/>
+        </p:spPr>
+        <p:txBody>
+          <a:bodyPr wrap="square">
+            <a:spAutoFit/>
+          </a:bodyPr>
+          <a:lstStyle/>
+          <a:p>
+            <a:pPr>
+              <a:spcAft>
+                <a:spcPts val="600"/>
+              </a:spcAft>
+            </a:pPr>
+            <a:r>
+              <a:rPr sz="1050" b="0">
+                <a:solidFill>
+                  <a:srgbClr val="6E6E6E"/>
+                </a:solidFill>
+                <a:latin typeface="Arial"/>
+              </a:rPr>
+              <a:t>Also open from the last round: whether the detector window is cemented to the block in the builds (six crossings and 0.81 uncoated, against four and 0.87).</a:t>
+            </a:r>
+          </a:p>
+        </p:txBody>
+      </p:sp>
+    </p:spTree>
+  </p:cSld>
+  <p:clrMapOvr>
+    <a:masterClrMapping/>
+  </p:clrMapOvr>
+</p:sld>
+</file>
+
+<file path=ppt/slides/slide12.xml><?xml version="1.0" encoding="utf-8"?>
+<p:sld xmlns:a="http://schemas.openxmlformats.org/drawingml/2006/main" xmlns:p="http://schemas.openxmlformats.org/presentationml/2006/main" xmlns:r="http://schemas.openxmlformats.org/officeDocument/2006/relationships">
+  <p:cSld>
+    <p:spTree>
+      <p:nvGrpSpPr>
+        <p:cNvPr id="1" name=""/>
+        <p:cNvGrpSpPr/>
+        <p:nvPr/>
+      </p:nvGrpSpPr>
+      <p:grpSpPr/>
+      <p:sp>
+        <p:nvSpPr>
+          <p:cNvPr id="2" name="TextBox 1"/>
+          <p:cNvSpPr txBox="1"/>
+          <p:nvPr/>
+        </p:nvSpPr>
+        <p:spPr>
+          <a:xfrm>
+            <a:off x="411480" y="201168"/>
+            <a:ext cx="11368735" cy="914400"/>
+          </a:xfrm>
+          <a:prstGeom prst="rect">
+            <a:avLst/>
+          </a:prstGeom>
+          <a:noFill/>
+        </p:spPr>
+        <p:txBody>
+          <a:bodyPr wrap="square">
+            <a:spAutoFit/>
+          </a:bodyPr>
+          <a:lstStyle/>
+          <a:p>
+            <a:pPr>
+              <a:spcAft>
+                <a:spcPts val="400"/>
+              </a:spcAft>
+            </a:pPr>
+            <a:r>
+              <a:rPr sz="2400" b="1">
+                <a:solidFill>
+                  <a:srgbClr val="1F4E79"/>
+                </a:solidFill>
+                <a:latin typeface="Arial"/>
+              </a:rPr>
+              <a:t>Next steps</a:t>
+            </a:r>
+          </a:p>
+          <a:p>
+            <a:pPr>
+              <a:spcAft>
+                <a:spcPts val="0"/>
+              </a:spcAft>
+            </a:pPr>
+            <a:r>
+              <a:rPr sz="1250" b="0">
+                <a:solidFill>
+                  <a:srgbClr val="6E6E6E"/>
+                </a:solidFill>
+                <a:latin typeface="Arial"/>
+              </a:rPr>
+              <a:t>The 3k telescope, the cold window, the radiometric chain</a:t>
+            </a:r>
+          </a:p>
+        </p:txBody>
+      </p:sp>
+      <p:sp>
+        <p:nvSpPr>
+          <p:cNvPr id="3" name="Rectangle 2"/>
+          <p:cNvSpPr/>
+          <p:nvPr/>
+        </p:nvSpPr>
+        <p:spPr>
+          <a:xfrm>
+            <a:off x="411480" y="1133856"/>
+            <a:ext cx="11368735" cy="20320"/>
+          </a:xfrm>
+          <a:prstGeom prst="rect">
+            <a:avLst/>
+          </a:prstGeom>
+          <a:solidFill>
+            <a:srgbClr val="B8C6D4"/>
+          </a:solidFill>
+          <a:ln>
+            <a:noFill/>
+          </a:ln>
+          <a:effectLst/>
+        </p:spPr>
+        <p:style>
+          <a:lnRef idx="1">
+            <a:schemeClr val="accent1"/>
+          </a:lnRef>
+          <a:fillRef idx="3">
+            <a:schemeClr val="accent1"/>
+          </a:fillRef>
+          <a:effectRef idx="2">
+            <a:schemeClr val="accent1"/>
+          </a:effectRef>
+          <a:fontRef idx="minor">
+            <a:schemeClr val="lt1"/>
+          </a:fontRef>
+        </p:style>
+        <p:txBody>
+          <a:bodyPr rtlCol="0" anchor="ctr"/>
+          <a:lstStyle/>
+          <a:p>
+            <a:pPr algn="ctr"/>
+          </a:p>
+        </p:txBody>
+      </p:sp>
+      <p:sp>
+        <p:nvSpPr>
+          <p:cNvPr id="4" name="TextBox 3"/>
+          <p:cNvSpPr txBox="1"/>
+          <p:nvPr/>
+        </p:nvSpPr>
+        <p:spPr>
+          <a:xfrm>
+            <a:off x="411480" y="1298448"/>
+            <a:ext cx="5806440" cy="274320"/>
+          </a:xfrm>
+          <a:prstGeom prst="rect">
+            <a:avLst/>
+          </a:prstGeom>
+          <a:noFill/>
+        </p:spPr>
+        <p:txBody>
+          <a:bodyPr wrap="square">
+            <a:spAutoFit/>
+          </a:bodyPr>
+          <a:lstStyle/>
+          <a:p>
+            <a:pPr>
+              <a:spcAft>
+                <a:spcPts val="600"/>
+              </a:spcAft>
+            </a:pPr>
+            <a:r>
+              <a:rPr sz="1200" b="0">
+                <a:solidFill>
+                  <a:srgbClr val="282828"/>
+                </a:solidFill>
+                <a:latin typeface="Arial"/>
+              </a:rPr>
+              <a:t>•  The 3k telescope: the stop at M2; an asphere-only solve from the freeform seed; a merit written on the response-function width for the final step; the field weighting across the strip as a ruling.</a:t>
+            </a:r>
+          </a:p>
+          <a:p>
+            <a:pPr>
+              <a:spcAft>
+                <a:spcPts val="600"/>
+              </a:spcAft>
+            </a:pPr>
+            <a:r>
+              <a:rPr sz="1200" b="0">
+                <a:solidFill>
+                  <a:srgbClr val="282828"/>
+                </a:solidFill>
+                <a:latin typeface="Arial"/>
+              </a:rPr>
+              <a:t>•  The 1.5k module's package: the cold window cemented as the block's exit face with the shield as the detector housing behind it, under the same clearance check; the 1.5 mm of working distance the 130 mm module tolerates is where it goes.</a:t>
+            </a:r>
+          </a:p>
+          <a:p>
+            <a:pPr>
+              <a:spcAft>
+                <a:spcPts val="600"/>
+              </a:spcAft>
+            </a:pPr>
+            <a:r>
+              <a:rPr sz="1200" b="0">
+                <a:solidFill>
+                  <a:srgbClr val="282828"/>
+                </a:solidFill>
+                <a:latin typeface="Arial"/>
+              </a:rPr>
+              <a:t>•  The radiometric chain against the band: throughput, grating efficiency, detector quantum efficiency and the slit's diffraction loss (0.3 % at 380 nm to 1.8 % at 2500 nm past the grating, before the telescope's cone).</a:t>
+            </a:r>
+          </a:p>
+        </p:txBody>
+      </p:sp>
+      <p:sp>
+        <p:nvSpPr>
+          <p:cNvPr id="5" name="TextBox 4"/>
+          <p:cNvSpPr txBox="1"/>
+          <p:nvPr/>
+        </p:nvSpPr>
+        <p:spPr>
+          <a:xfrm>
+            <a:off x="6400800" y="1298448"/>
+            <a:ext cx="5394960" cy="274320"/>
+          </a:xfrm>
+          <a:prstGeom prst="rect">
+            <a:avLst/>
+          </a:prstGeom>
+          <a:noFill/>
+        </p:spPr>
+        <p:txBody>
+          <a:bodyPr wrap="square">
+            <a:spAutoFit/>
+          </a:bodyPr>
+          <a:lstStyle/>
+          <a:p>
+            <a:pPr>
+              <a:spcAft>
+                <a:spcPts val="600"/>
+              </a:spcAft>
+            </a:pPr>
+            <a:r>
+              <a:rPr sz="1200" b="0">
+                <a:solidFill>
+                  <a:srgbClr val="282828"/>
+                </a:solidFill>
+                <a:latin typeface="Arial"/>
+              </a:rPr>
+              <a:t>•  In the engine: a fixed-station reference sphere for the wavefront merit on telecentric designs; an asphere-plus-Zernike surface in one declaration; a short-line guard for every multi-value prescription keyword.</a:t>
+            </a:r>
+          </a:p>
+          <a:p>
+            <a:pPr>
+              <a:spcAft>
+                <a:spcPts val="600"/>
+              </a:spcAft>
+            </a:pPr>
+            <a:r>
+              <a:rPr sz="1200" b="0">
+                <a:solidFill>
+                  <a:srgbClr val="282828"/>
+                </a:solidFill>
+                <a:latin typeface="Arial"/>
+              </a:rPr>
+              <a:t>•  Later, once the design of record is stable: full diffraction from the slit through the grating to the detector (the slit's truncation of the telescope's image, about 10 % on the response functions in the literature); polarization sensitivity of the Dyson against the Offner; a surface-by-surface tour of the prescription.</a:t>
+            </a:r>
+          </a:p>
+        </p:txBody>
+      </p:sp>
+    </p:spTree>
+  </p:cSld>
+  <p:clrMapOvr>
+    <a:masterClrMapping/>
+  </p:clrMapOvr>
+</p:sld>
+</file>
+
+<file path=ppt/slides/slide13.xml><?xml version="1.0" encoding="utf-8"?>
 <p:sld xmlns:a="http://schemas.openxmlformats.org/drawingml/2006/main" xmlns:p="http://schemas.openxmlformats.org/presentationml/2006/main" xmlns:r="http://schemas.openxmlformats.org/officeDocument/2006/relationships">
   <p:cSld>
     <p:spTree>
@@ -3811,7 +4322,7 @@
 </p:sld>
 </file>
 
-<file path=ppt/slides/slide12.xml><?xml version="1.0" encoding="utf-8"?>
+<file path=ppt/slides/slide14.xml><?xml version="1.0" encoding="utf-8"?>
 <p:sld xmlns:a="http://schemas.openxmlformats.org/drawingml/2006/main" xmlns:p="http://schemas.openxmlformats.org/presentationml/2006/main" xmlns:r="http://schemas.openxmlformats.org/officeDocument/2006/relationships">
   <p:cSld>
     <p:spTree>
@@ -3951,7 +4462,7 @@
 </p:sld>
 </file>
 
-<file path=ppt/slides/slide13.xml><?xml version="1.0" encoding="utf-8"?>
+<file path=ppt/slides/slide15.xml><?xml version="1.0" encoding="utf-8"?>
 <p:sld xmlns:a="http://schemas.openxmlformats.org/drawingml/2006/main" xmlns:p="http://schemas.openxmlformats.org/presentationml/2006/main" xmlns:r="http://schemas.openxmlformats.org/officeDocument/2006/relationships">
   <p:cSld>
     <p:spTree>
@@ -4629,7 +5140,7 @@
 </p:sld>
 </file>
 
-<file path=ppt/slides/slide14.xml><?xml version="1.0" encoding="utf-8"?>
+<file path=ppt/slides/slide16.xml><?xml version="1.0" encoding="utf-8"?>
 <p:sld xmlns:a="http://schemas.openxmlformats.org/drawingml/2006/main" xmlns:p="http://schemas.openxmlformats.org/presentationml/2006/main" xmlns:r="http://schemas.openxmlformats.org/officeDocument/2006/relationships">
   <p:cSld>
     <p:spTree>
@@ -6618,7 +7129,7 @@
 </p:sld>
 </file>
 
-<file path=ppt/slides/slide15.xml><?xml version="1.0" encoding="utf-8"?>
+<file path=ppt/slides/slide17.xml><?xml version="1.0" encoding="utf-8"?>
 <p:sld xmlns:a="http://schemas.openxmlformats.org/drawingml/2006/main" xmlns:p="http://schemas.openxmlformats.org/presentationml/2006/main" xmlns:r="http://schemas.openxmlformats.org/officeDocument/2006/relationships">
   <p:cSld>
     <p:spTree>
@@ -6924,7 +7435,7 @@
 </p:sld>
 </file>
 
-<file path=ppt/slides/slide16.xml><?xml version="1.0" encoding="utf-8"?>
+<file path=ppt/slides/slide18.xml><?xml version="1.0" encoding="utf-8"?>
 <p:sld xmlns:a="http://schemas.openxmlformats.org/drawingml/2006/main" xmlns:p="http://schemas.openxmlformats.org/presentationml/2006/main" xmlns:r="http://schemas.openxmlformats.org/officeDocument/2006/relationships">
   <p:cSld>
     <p:spTree>
@@ -8102,7 +8613,7 @@
 </p:sld>
 </file>
 
-<file path=ppt/slides/slide17.xml><?xml version="1.0" encoding="utf-8"?>
+<file path=ppt/slides/slide19.xml><?xml version="1.0" encoding="utf-8"?>
 <p:sld xmlns:a="http://schemas.openxmlformats.org/drawingml/2006/main" xmlns:p="http://schemas.openxmlformats.org/presentationml/2006/main" xmlns:r="http://schemas.openxmlformats.org/officeDocument/2006/relationships">
   <p:cSld>
     <p:spTree>
@@ -8400,7 +8911,7 @@
 </p:sld>
 </file>
 
-<file path=ppt/slides/slide18.xml><?xml version="1.0" encoding="utf-8"?>
+<file path=ppt/slides/slide2.xml><?xml version="1.0" encoding="utf-8"?>
 <p:sld xmlns:a="http://schemas.openxmlformats.org/drawingml/2006/main" xmlns:p="http://schemas.openxmlformats.org/presentationml/2006/main" xmlns:r="http://schemas.openxmlformats.org/officeDocument/2006/relationships">
   <p:cSld>
     <p:spTree>
@@ -8444,7 +8955,7 @@
                 </a:solidFill>
                 <a:latin typeface="Arial"/>
               </a:rPr>
-              <a:t>Eight engine findings from the spectrometer, each with a regression test</a:t>
+              <a:t>Contents</a:t>
             </a:r>
           </a:p>
           <a:p>
@@ -8460,7 +8971,7 @@
                 </a:solidFill>
                 <a:latin typeface="Arial"/>
               </a:rPr>
-              <a:t>Found by the design's own checks between 2026-09-30 and 10-03, fixed in the engine the same day</a:t>
+              <a:t>The target, the instrument of record, the comparison for Jim, the open module, the questions</a:t>
             </a:r>
           </a:p>
         </p:txBody>
@@ -8509,655 +9020,16 @@
           </a:p>
         </p:txBody>
       </p:sp>
-      <p:graphicFrame>
-        <p:nvGraphicFramePr>
-          <p:cNvPr id="4" name="Table 3"/>
-          <p:cNvGraphicFramePr>
-            <a:graphicFrameLocks noGrp="1"/>
-          </p:cNvGraphicFramePr>
-          <p:nvPr/>
-        </p:nvGraphicFramePr>
-        <p:xfrm>
-          <a:off x="411480" y="1298448"/>
-          <a:ext cx="11368733" cy="4029075"/>
-        </p:xfrm>
-        <a:graphic>
-          <a:graphicData uri="http://schemas.openxmlformats.org/drawingml/2006/table">
-            <a:tbl>
-              <a:tblPr firstRow="1" bandRow="1">
-                <a:tableStyleId>{5C22544A-7EE6-4342-B048-85BDC9FD1C3A}</a:tableStyleId>
-              </a:tblPr>
-              <a:tblGrid>
-                <a:gridCol w="1944095"/>
-                <a:gridCol w="4606662"/>
-                <a:gridCol w="4817976"/>
-              </a:tblGrid>
-              <a:tr h="280035">
-                <a:tc>
-                  <a:txBody>
-                    <a:bodyPr wrap="square"/>
-                    <a:lstStyle/>
-                    <a:p>
-                      <a:r>
-                        <a:rPr sz="1100" b="1">
-                          <a:solidFill>
-                            <a:srgbClr val="FFFFFF"/>
-                          </a:solidFill>
-                          <a:latin typeface="Arial"/>
-                        </a:rPr>
-                        <a:t>finding</a:t>
-                      </a:r>
-                    </a:p>
-                  </a:txBody>
-                  <a:tcPr marL="54864" marR="54864" marT="18288" marB="18288">
-                    <a:solidFill>
-                      <a:srgbClr val="1F4E79"/>
-                    </a:solidFill>
-                  </a:tcPr>
-                </a:tc>
-                <a:tc>
-                  <a:txBody>
-                    <a:bodyPr wrap="square"/>
-                    <a:lstStyle/>
-                    <a:p>
-                      <a:r>
-                        <a:rPr sz="1100" b="1">
-                          <a:solidFill>
-                            <a:srgbClr val="FFFFFF"/>
-                          </a:solidFill>
-                          <a:latin typeface="Arial"/>
-                        </a:rPr>
-                        <a:t>symptom</a:t>
-                      </a:r>
-                    </a:p>
-                  </a:txBody>
-                  <a:tcPr marL="54864" marR="54864" marT="18288" marB="18288">
-                    <a:solidFill>
-                      <a:srgbClr val="1F4E79"/>
-                    </a:solidFill>
-                  </a:tcPr>
-                </a:tc>
-                <a:tc>
-                  <a:txBody>
-                    <a:bodyPr wrap="square"/>
-                    <a:lstStyle/>
-                    <a:p>
-                      <a:r>
-                        <a:rPr sz="1100" b="1">
-                          <a:solidFill>
-                            <a:srgbClr val="FFFFFF"/>
-                          </a:solidFill>
-                          <a:latin typeface="Arial"/>
-                        </a:rPr>
-                        <a:t>fix</a:t>
-                      </a:r>
-                    </a:p>
-                  </a:txBody>
-                  <a:tcPr marL="54864" marR="54864" marT="18288" marB="18288">
-                    <a:solidFill>
-                      <a:srgbClr val="1F4E79"/>
-                    </a:solidFill>
-                  </a:tcPr>
-                </a:tc>
-              </a:tr>
-              <a:tr h="468630">
-                <a:tc>
-                  <a:txBody>
-                    <a:bodyPr wrap="square"/>
-                    <a:lstStyle/>
-                    <a:p>
-                      <a:r>
-                        <a:rPr sz="1100" b="0">
-                          <a:solidFill>
-                            <a:srgbClr val="282828"/>
-                          </a:solidFill>
-                          <a:latin typeface="Arial"/>
-                        </a:rPr>
-                        <a:t>glass names ignored at load</a:t>
-                      </a:r>
-                    </a:p>
-                  </a:txBody>
-                  <a:tcPr marL="54864" marR="54864" marT="18288" marB="18288">
-                    <a:solidFill>
-                      <a:srgbClr val="FFFFFF"/>
-                    </a:solidFill>
-                  </a:tcPr>
-                </a:tc>
-                <a:tc>
-                  <a:txBody>
-                    <a:bodyPr wrap="square"/>
-                    <a:lstStyle/>
-                    <a:p>
-                      <a:r>
-                        <a:rPr sz="1100" b="0">
-                          <a:solidFill>
-                            <a:srgbClr val="282828"/>
-                          </a:solidFill>
-                          <a:latin typeface="Arial"/>
-                        </a:rPr>
-                        <a:t>a GlassElt= Silica element traced as air</a:t>
-                      </a:r>
-                    </a:p>
-                  </a:txBody>
-                  <a:tcPr marL="54864" marR="54864" marT="18288" marB="18288">
-                    <a:solidFill>
-                      <a:srgbClr val="FFFFFF"/>
-                    </a:solidFill>
-                  </a:tcPr>
-                </a:tc>
-                <a:tc>
-                  <a:txBody>
-                    <a:bodyPr wrap="square"/>
-                    <a:lstStyle/>
-                    <a:p>
-                      <a:r>
-                        <a:rPr sz="1100" b="0">
-                          <a:solidFill>
-                            <a:srgbClr val="282828"/>
-                          </a:solidFill>
-                          <a:latin typeface="Arial"/>
-                        </a:rPr>
-                        <a:t>the glass catalog is blanked once at allocation, not on every load</a:t>
-                      </a:r>
-                    </a:p>
-                  </a:txBody>
-                  <a:tcPr marL="54864" marR="54864" marT="18288" marB="18288">
-                    <a:solidFill>
-                      <a:srgbClr val="FFFFFF"/>
-                    </a:solidFill>
-                  </a:tcPr>
-                </a:tc>
-              </a:tr>
-              <a:tr h="468630">
-                <a:tc>
-                  <a:txBody>
-                    <a:bodyPr wrap="square"/>
-                    <a:lstStyle/>
-                    <a:p>
-                      <a:r>
-                        <a:rPr sz="1100" b="0">
-                          <a:solidFill>
-                            <a:srgbClr val="282828"/>
-                          </a:solidFill>
-                          <a:latin typeface="Arial"/>
-                        </a:rPr>
-                        <a:t>vacuum wavelength inside glass</a:t>
-                      </a:r>
-                    </a:p>
-                  </a:txBody>
-                  <a:tcPr marL="54864" marR="54864" marT="18288" marB="18288">
-                    <a:solidFill>
-                      <a:srgbClr val="ECF1F6"/>
-                    </a:solidFill>
-                  </a:tcPr>
-                </a:tc>
-                <a:tc>
-                  <a:txBody>
-                    <a:bodyPr wrap="square"/>
-                    <a:lstStyle/>
-                    <a:p>
-                      <a:r>
-                        <a:rPr sz="1100" b="0">
-                          <a:solidFill>
-                            <a:srgbClr val="282828"/>
-                          </a:solidFill>
-                          <a:latin typeface="Arial"/>
-                        </a:rPr>
-                        <a:t>a propagation leg in a medium ran at the wrong Fresnel number by n</a:t>
-                      </a:r>
-                    </a:p>
-                  </a:txBody>
-                  <a:tcPr marL="54864" marR="54864" marT="18288" marB="18288">
-                    <a:solidFill>
-                      <a:srgbClr val="ECF1F6"/>
-                    </a:solidFill>
-                  </a:tcPr>
-                </a:tc>
-                <a:tc>
-                  <a:txBody>
-                    <a:bodyPr wrap="square"/>
-                    <a:lstStyle/>
-                    <a:p>
-                      <a:r>
-                        <a:rPr sz="1100" b="0">
-                          <a:solidFill>
-                            <a:srgbClr val="282828"/>
-                          </a:solidFill>
-                          <a:latin typeface="Arial"/>
-                        </a:rPr>
-                        <a:t>every kernel takes λ/n of the leg's medium</a:t>
-                      </a:r>
-                    </a:p>
-                  </a:txBody>
-                  <a:tcPr marL="54864" marR="54864" marT="18288" marB="18288">
-                    <a:solidFill>
-                      <a:srgbClr val="ECF1F6"/>
-                    </a:solidFill>
-                  </a:tcPr>
-                </a:tc>
-              </a:tr>
-              <a:tr h="468630">
-                <a:tc>
-                  <a:txBody>
-                    <a:bodyPr wrap="square"/>
-                    <a:lstStyle/>
-                    <a:p>
-                      <a:r>
-                        <a:rPr sz="1100" b="0">
-                          <a:solidFill>
-                            <a:srgbClr val="282828"/>
-                          </a:solidFill>
-                          <a:latin typeface="Arial"/>
-                        </a:rPr>
-                        <a:t>groove period along the surface</a:t>
-                      </a:r>
-                    </a:p>
-                  </a:txBody>
-                  <a:tcPr marL="54864" marR="54864" marT="18288" marB="18288">
-                    <a:solidFill>
-                      <a:srgbClr val="FFFFFF"/>
-                    </a:solidFill>
-                  </a:tcPr>
-                </a:tc>
-                <a:tc>
-                  <a:txBody>
-                    <a:bodyPr wrap="square"/>
-                    <a:lstStyle/>
-                    <a:p>
-                      <a:r>
-                        <a:rPr sz="1100" b="0">
-                          <a:solidFill>
-                            <a:srgbClr val="282828"/>
-                          </a:solidFill>
-                          <a:latin typeface="Arial"/>
-                        </a:rPr>
-                        <a:t>2.8 / 3.3 px rms spectral blur at 2500 nm (Offner / Dyson)</a:t>
-                      </a:r>
-                    </a:p>
-                  </a:txBody>
-                  <a:tcPr marL="54864" marR="54864" marT="18288" marB="18288">
-                    <a:solidFill>
-                      <a:srgbClr val="FFFFFF"/>
-                    </a:solidFill>
-                  </a:tcPr>
-                </a:tc>
-                <a:tc>
-                  <a:txBody>
-                    <a:bodyPr wrap="square"/>
-                    <a:lstStyle/>
-                    <a:p>
-                      <a:r>
-                        <a:rPr sz="1100" b="0">
-                          <a:solidFill>
-                            <a:srgbClr val="282828"/>
-                          </a:solidFill>
-                          <a:latin typeface="Arial"/>
-                        </a:rPr>
-                        <a:t>the local grating vector is the projection of the ruling direction, un-normalized (chord-ruled)</a:t>
-                      </a:r>
-                    </a:p>
-                  </a:txBody>
-                  <a:tcPr marL="54864" marR="54864" marT="18288" marB="18288">
-                    <a:solidFill>
-                      <a:srgbClr val="FFFFFF"/>
-                    </a:solidFill>
-                  </a:tcPr>
-                </a:tc>
-              </a:tr>
-              <a:tr h="468630">
-                <a:tc>
-                  <a:txBody>
-                    <a:bodyPr wrap="square"/>
-                    <a:lstStyle/>
-                    <a:p>
-                      <a:r>
-                        <a:rPr sz="1100" b="0">
-                          <a:solidFill>
-                            <a:srgbClr val="282828"/>
-                          </a:solidFill>
-                          <a:latin typeface="Arial"/>
-                        </a:rPr>
-                        <a:t>grating path-length jump</a:t>
-                      </a:r>
-                    </a:p>
-                  </a:txBody>
-                  <a:tcPr marL="54864" marR="54864" marT="18288" marB="18288">
-                    <a:solidFill>
-                      <a:srgbClr val="ECF1F6"/>
-                    </a:solidFill>
-                  </a:tcPr>
-                </a:tc>
-                <a:tc>
-                  <a:txBody>
-                    <a:bodyPr wrap="square"/>
-                    <a:lstStyle/>
-                    <a:p>
-                      <a:r>
-                        <a:rPr sz="1100" b="0">
-                          <a:solidFill>
-                            <a:srgbClr val="282828"/>
-                          </a:solidFill>
-                          <a:latin typeface="Arial"/>
-                        </a:rPr>
-                        <a:t>4 waves rms of pupil error where the rays converged to 0.05 µm</a:t>
-                      </a:r>
-                    </a:p>
-                  </a:txBody>
-                  <a:tcPr marL="54864" marR="54864" marT="18288" marB="18288">
-                    <a:solidFill>
-                      <a:srgbClr val="ECF1F6"/>
-                    </a:solidFill>
-                  </a:tcPr>
-                </a:tc>
-                <a:tc>
-                  <a:txBody>
-                    <a:bodyPr wrap="square"/>
-                    <a:lstStyle/>
-                    <a:p>
-                      <a:r>
-                        <a:rPr sz="1100" b="0">
-                          <a:solidFill>
-                            <a:srgbClr val="282828"/>
-                          </a:solidFill>
-                          <a:latin typeface="Arial"/>
-                        </a:rPr>
-                        <a:t>the jump is the groove count from the vertex along the ruling direction</a:t>
-                      </a:r>
-                    </a:p>
-                  </a:txBody>
-                  <a:tcPr marL="54864" marR="54864" marT="18288" marB="18288">
-                    <a:solidFill>
-                      <a:srgbClr val="ECF1F6"/>
-                    </a:solidFill>
-                  </a:tcPr>
-                </a:tc>
-              </a:tr>
-              <a:tr h="468630">
-                <a:tc>
-                  <a:txBody>
-                    <a:bodyPr wrap="square"/>
-                    <a:lstStyle/>
-                    <a:p>
-                      <a:r>
-                        <a:rPr sz="1100" b="0">
-                          <a:solidFill>
-                            <a:srgbClr val="282828"/>
-                          </a:solidFill>
-                          <a:latin typeface="Arial"/>
-                        </a:rPr>
-                        <a:t>optimizer derivative stride</a:t>
-                      </a:r>
-                    </a:p>
-                  </a:txBody>
-                  <a:tcPr marL="54864" marR="54864" marT="18288" marB="18288">
-                    <a:solidFill>
-                      <a:srgbClr val="FFFFFF"/>
-                    </a:solidFill>
-                  </a:tcPr>
-                </a:tc>
-                <a:tc>
-                  <a:txBody>
-                    <a:bodyPr wrap="square"/>
-                    <a:lstStyle/>
-                    <a:p>
-                      <a:r>
-                        <a:rPr sz="1100" b="0">
-                          <a:solidFill>
-                            <a:srgbClr val="282828"/>
-                          </a:solidFill>
-                          <a:latin typeface="Arial"/>
-                        </a:rPr>
-                        <a:t>a multi-field spot-size solve overwrote memory on its second field</a:t>
-                      </a:r>
-                    </a:p>
-                  </a:txBody>
-                  <a:tcPr marL="54864" marR="54864" marT="18288" marB="18288">
-                    <a:solidFill>
-                      <a:srgbClr val="FFFFFF"/>
-                    </a:solidFill>
-                  </a:tcPr>
-                </a:tc>
-                <a:tc>
-                  <a:txBody>
-                    <a:bodyPr wrap="square"/>
-                    <a:lstStyle/>
-                    <a:p>
-                      <a:r>
-                        <a:rPr sz="1100" b="0">
-                          <a:solidFill>
-                            <a:srgbClr val="282828"/>
-                          </a:solidFill>
-                          <a:latin typeface="Arial"/>
-                        </a:rPr>
-                        <a:t>advance by the objective's size, as the value loop does</a:t>
-                      </a:r>
-                    </a:p>
-                  </a:txBody>
-                  <a:tcPr marL="54864" marR="54864" marT="18288" marB="18288">
-                    <a:solidFill>
-                      <a:srgbClr val="FFFFFF"/>
-                    </a:solidFill>
-                  </a:tcPr>
-                </a:tc>
-              </a:tr>
-              <a:tr h="468630">
-                <a:tc>
-                  <a:txBody>
-                    <a:bodyPr wrap="square"/>
-                    <a:lstStyle/>
-                    <a:p>
-                      <a:r>
-                        <a:rPr sz="1100" b="0">
-                          <a:solidFill>
-                            <a:srgbClr val="282828"/>
-                          </a:solidFill>
-                          <a:latin typeface="Arial"/>
-                        </a:rPr>
-                        <a:t>ray behind the surface after a pupil reference</a:t>
-                      </a:r>
-                    </a:p>
-                  </a:txBody>
-                  <a:tcPr marL="54864" marR="54864" marT="18288" marB="18288">
-                    <a:solidFill>
-                      <a:srgbClr val="ECF1F6"/>
-                    </a:solidFill>
-                  </a:tcPr>
-                </a:tc>
-                <a:tc>
-                  <a:txBody>
-                    <a:bodyPr wrap="square"/>
-                    <a:lstStyle/>
-                    <a:p>
-                      <a:r>
-                        <a:rPr sz="1100" b="0">
-                          <a:solidFill>
-                            <a:srgbClr val="282828"/>
-                          </a:solidFill>
-                          <a:latin typeface="Arial"/>
-                        </a:rPr>
-                        <a:t>a two-mirror with its pupil reference 5 mm ahead of a convex primary scattered every ray in a one-call trace</a:t>
-                      </a:r>
-                    </a:p>
-                  </a:txBody>
-                  <a:tcPr marL="54864" marR="54864" marT="18288" marB="18288">
-                    <a:solidFill>
-                      <a:srgbClr val="ECF1F6"/>
-                    </a:solidFill>
-                  </a:tcPr>
-                </a:tc>
-                <a:tc>
-                  <a:txBody>
-                    <a:bodyPr wrap="square"/>
-                    <a:lstStyle/>
-                    <a:p>
-                      <a:r>
-                        <a:rPr sz="1100" b="0">
-                          <a:solidFill>
-                            <a:srgbClr val="282828"/>
-                          </a:solidFill>
-                          <a:latin typeface="Arial"/>
-                        </a:rPr>
-                        <a:t>the conic root nearest the element's reference point; a restarted trace resets its previous element per ray</a:t>
-                      </a:r>
-                    </a:p>
-                  </a:txBody>
-                  <a:tcPr marL="54864" marR="54864" marT="18288" marB="18288">
-                    <a:solidFill>
-                      <a:srgbClr val="ECF1F6"/>
-                    </a:solidFill>
-                  </a:tcPr>
-                </a:tc>
-              </a:tr>
-              <a:tr h="468630">
-                <a:tc>
-                  <a:txBody>
-                    <a:bodyPr wrap="square"/>
-                    <a:lstStyle/>
-                    <a:p>
-                      <a:r>
-                        <a:rPr sz="1100" b="0">
-                          <a:solidFill>
-                            <a:srgbClr val="282828"/>
-                          </a:solidFill>
-                          <a:latin typeface="Arial"/>
-                        </a:rPr>
-                        <a:t>beam conditions only under a beam target</a:t>
-                      </a:r>
-                    </a:p>
-                  </a:txBody>
-                  <a:tcPr marL="54864" marR="54864" marT="18288" marB="18288">
-                    <a:solidFill>
-                      <a:srgbClr val="FFFFFF"/>
-                    </a:solidFill>
-                  </a:tcPr>
-                </a:tc>
-                <a:tc>
-                  <a:txBody>
-                    <a:bodyPr wrap="square"/>
-                    <a:lstStyle/>
-                    <a:p>
-                      <a:r>
-                        <a:rPr sz="1100" b="0">
-                          <a:solidFill>
-                            <a:srgbClr val="282828"/>
-                          </a:solidFill>
-                          <a:latin typeface="Arial"/>
-                        </a:rPr>
-                        <a:t>chief direction and position could not be scored with a spot or wavefront target</a:t>
-                      </a:r>
-                    </a:p>
-                  </a:txBody>
-                  <a:tcPr marL="54864" marR="54864" marT="18288" marB="18288">
-                    <a:solidFill>
-                      <a:srgbClr val="FFFFFF"/>
-                    </a:solidFill>
-                  </a:tcPr>
-                </a:tc>
-                <a:tc>
-                  <a:txBody>
-                    <a:bodyPr wrap="square"/>
-                    <a:lstStyle/>
-                    <a:p>
-                      <a:r>
-                        <a:rPr sz="1100" b="0">
-                          <a:solidFill>
-                            <a:srgbClr val="282828"/>
-                          </a:solidFill>
-                          <a:latin typeface="Arial"/>
-                        </a:rPr>
-                        <a:t>the beam rows ride on any target; a position target per field; the centroid as the position</a:t>
-                      </a:r>
-                    </a:p>
-                  </a:txBody>
-                  <a:tcPr marL="54864" marR="54864" marT="18288" marB="18288">
-                    <a:solidFill>
-                      <a:srgbClr val="FFFFFF"/>
-                    </a:solidFill>
-                  </a:tcPr>
-                </a:tc>
-              </a:tr>
-              <a:tr h="468630">
-                <a:tc>
-                  <a:txBody>
-                    <a:bodyPr wrap="square"/>
-                    <a:lstStyle/>
-                    <a:p>
-                      <a:r>
-                        <a:rPr sz="1100" b="0">
-                          <a:solidFill>
-                            <a:srgbClr val="282828"/>
-                          </a:solidFill>
-                          <a:latin typeface="Arial"/>
-                        </a:rPr>
-                        <a:t>optimizer asphere step and failure exit</a:t>
-                      </a:r>
-                    </a:p>
-                  </a:txBody>
-                  <a:tcPr marL="54864" marR="54864" marT="18288" marB="18288">
-                    <a:solidFill>
-                      <a:srgbClr val="ECF1F6"/>
-                    </a:solidFill>
-                  </a:tcPr>
-                </a:tc>
-                <a:tc>
-                  <a:txBody>
-                    <a:bodyPr wrap="square"/>
-                    <a:lstStyle/>
-                    <a:p>
-                      <a:r>
-                        <a:rPr sz="1100" b="0">
-                          <a:solidFill>
-                            <a:srgbClr val="282828"/>
-                          </a:solidFill>
-                          <a:latin typeface="Arial"/>
-                        </a:rPr>
-                        <a:t>a fixed 1e-10 probe step: a zero derivative column, a singular matrix, and a stop that ended the host process</a:t>
-                      </a:r>
-                    </a:p>
-                  </a:txBody>
-                  <a:tcPr marL="54864" marR="54864" marT="18288" marB="18288">
-                    <a:solidFill>
-                      <a:srgbClr val="ECF1F6"/>
-                    </a:solidFill>
-                  </a:tcPr>
-                </a:tc>
-                <a:tc>
-                  <a:txBody>
-                    <a:bodyPr wrap="square"/>
-                    <a:lstStyle/>
-                    <a:p>
-                      <a:r>
-                        <a:rPr sz="1100" b="0">
-                          <a:solidFill>
-                            <a:srgbClr val="282828"/>
-                          </a:solidFill>
-                          <a:latin typeface="Arial"/>
-                        </a:rPr>
-                        <a:t>the step is 1e-3 of the coefficient (sag-based for a zero one); the failure restores the optics and returns a flag</a:t>
-                      </a:r>
-                    </a:p>
-                  </a:txBody>
-                  <a:tcPr marL="54864" marR="54864" marT="18288" marB="18288">
-                    <a:solidFill>
-                      <a:srgbClr val="ECF1F6"/>
-                    </a:solidFill>
-                  </a:tcPr>
-                </a:tc>
-              </a:tr>
-            </a:tbl>
-          </a:graphicData>
-        </a:graphic>
-      </p:graphicFrame>
       <p:sp>
         <p:nvSpPr>
-          <p:cNvPr id="5" name="TextBox 4"/>
+          <p:cNvPr id="4" name="TextBox 3"/>
           <p:cNvSpPr txBox="1"/>
           <p:nvPr/>
         </p:nvSpPr>
         <p:spPr>
           <a:xfrm>
-            <a:off x="411480" y="5473827"/>
-            <a:ext cx="11368735" cy="274320"/>
+            <a:off x="411480" y="1298448"/>
+            <a:ext cx="5806440" cy="274320"/>
           </a:xfrm>
           <a:prstGeom prst="rect">
             <a:avLst/>
@@ -9176,13 +9048,212 @@
               </a:spcAft>
             </a:pPr>
             <a:r>
-              <a:rPr sz="1050" b="0">
+              <a:rPr sz="1200" b="0">
                 <a:solidFill>
-                  <a:srgbClr val="6E6E6E"/>
+                  <a:srgbClr val="282828"/>
                 </a:solidFill>
                 <a:latin typeface="Arial"/>
               </a:rPr>
-              <a:t>Tests: tGlassDispersion, tPropMedium, tGratingImmersed + test_grating_chord, tGratingOpl, tSpectrometerRx, tTraceRestart, tBeamRows, tAsphCalib.  Flat gratings are unchanged by the grating fixes; the wavefront-target optimizer, which every telescope design used, was never affected by the fifth.</a:t>
+              <a:t>•  3 The target and how it is scored</a:t>
+            </a:r>
+          </a:p>
+          <a:p>
+            <a:pPr>
+              <a:spcAft>
+                <a:spcPts val="600"/>
+              </a:spcAft>
+            </a:pPr>
+            <a:r>
+              <a:rPr sz="1200" b="0">
+                <a:solidFill>
+                  <a:srgbClr val="282828"/>
+                </a:solidFill>
+                <a:latin typeface="Arial"/>
+              </a:rPr>
+              <a:t>•  4 The 1.5k module, scored: spectrometer, telescope, and the two together</a:t>
+            </a:r>
+          </a:p>
+          <a:p>
+            <a:pPr>
+              <a:spcAft>
+                <a:spcPts val="600"/>
+              </a:spcAft>
+            </a:pPr>
+            <a:r>
+              <a:rPr sz="1200" b="0">
+                <a:solidFill>
+                  <a:srgbClr val="282828"/>
+                </a:solidFill>
+                <a:latin typeface="Arial"/>
+              </a:rPr>
+              <a:t>•  5 The 1.5k module, end to end</a:t>
+            </a:r>
+          </a:p>
+          <a:p>
+            <a:pPr>
+              <a:spcAft>
+                <a:spcPts val="600"/>
+              </a:spcAft>
+            </a:pPr>
+            <a:r>
+              <a:rPr sz="1200" b="0">
+                <a:solidFill>
+                  <a:srgbClr val="282828"/>
+                </a:solidFill>
+                <a:latin typeface="Arial"/>
+              </a:rPr>
+              <a:t>•  6 The telescope so far: three off-axis aspheres</a:t>
+            </a:r>
+          </a:p>
+          <a:p>
+            <a:pPr>
+              <a:spcAft>
+                <a:spcPts val="600"/>
+              </a:spcAft>
+            </a:pPr>
+            <a:r>
+              <a:rPr sz="1200" b="0">
+                <a:solidFill>
+                  <a:srgbClr val="282828"/>
+                </a:solidFill>
+                <a:latin typeface="Arial"/>
+              </a:rPr>
+              <a:t>•  7 The spectrometer of record for the 1.5k module</a:t>
+            </a:r>
+          </a:p>
+          <a:p>
+            <a:pPr>
+              <a:spcAft>
+                <a:spcPts val="600"/>
+              </a:spcAft>
+            </a:pPr>
+            <a:r>
+              <a:rPr sz="1200" b="0">
+                <a:solidFill>
+                  <a:srgbClr val="282828"/>
+                </a:solidFill>
+                <a:latin typeface="Arial"/>
+              </a:rPr>
+              <a:t>•  8 Two of 3k in CaF2 or four of 1.5k in silica</a:t>
+            </a:r>
+          </a:p>
+        </p:txBody>
+      </p:sp>
+      <p:sp>
+        <p:nvSpPr>
+          <p:cNvPr id="5" name="TextBox 4"/>
+          <p:cNvSpPr txBox="1"/>
+          <p:nvPr/>
+        </p:nvSpPr>
+        <p:spPr>
+          <a:xfrm>
+            <a:off x="6400800" y="1298448"/>
+            <a:ext cx="5394960" cy="274320"/>
+          </a:xfrm>
+          <a:prstGeom prst="rect">
+            <a:avLst/>
+          </a:prstGeom>
+          <a:noFill/>
+        </p:spPr>
+        <p:txBody>
+          <a:bodyPr wrap="square">
+            <a:spAutoFit/>
+          </a:bodyPr>
+          <a:lstStyle/>
+          <a:p>
+            <a:pPr>
+              <a:spcAft>
+                <a:spcPts val="600"/>
+              </a:spcAft>
+            </a:pPr>
+            <a:r>
+              <a:rPr sz="1200" b="0">
+                <a:solidFill>
+                  <a:srgbClr val="282828"/>
+                </a:solidFill>
+                <a:latin typeface="Arial"/>
+              </a:rPr>
+              <a:t>•  9 The 3k module: where it stands</a:t>
+            </a:r>
+          </a:p>
+          <a:p>
+            <a:pPr>
+              <a:spcAft>
+                <a:spcPts val="600"/>
+              </a:spcAft>
+            </a:pPr>
+            <a:r>
+              <a:rPr sz="1200" b="0">
+                <a:solidFill>
+                  <a:srgbClr val="282828"/>
+                </a:solidFill>
+                <a:latin typeface="Arial"/>
+              </a:rPr>
+              <a:t>•  10 Alternatives to the Dyson for the 3k slit</a:t>
+            </a:r>
+          </a:p>
+          <a:p>
+            <a:pPr>
+              <a:spcAft>
+                <a:spcPts val="600"/>
+              </a:spcAft>
+            </a:pPr>
+            <a:r>
+              <a:rPr sz="1200" b="0">
+                <a:solidFill>
+                  <a:srgbClr val="282828"/>
+                </a:solidFill>
+                <a:latin typeface="Arial"/>
+              </a:rPr>
+              <a:t>•  11 Three asks of Jim</a:t>
+            </a:r>
+          </a:p>
+          <a:p>
+            <a:pPr>
+              <a:spcAft>
+                <a:spcPts val="600"/>
+              </a:spcAft>
+            </a:pPr>
+            <a:r>
+              <a:rPr sz="1200" b="0">
+                <a:solidFill>
+                  <a:srgbClr val="282828"/>
+                </a:solidFill>
+                <a:latin typeface="Arial"/>
+              </a:rPr>
+              <a:t>•  12 Next steps</a:t>
+            </a:r>
+          </a:p>
+          <a:p>
+            <a:pPr>
+              <a:spcAft>
+                <a:spcPts val="600"/>
+              </a:spcAft>
+            </a:pPr>
+            <a:r>
+              <a:rPr sz="1200" b="0">
+                <a:solidFill>
+                  <a:srgbClr val="282828"/>
+                </a:solidFill>
+                <a:latin typeface="Arial"/>
+              </a:rPr>
+              <a:t>•  13 Run it yourself</a:t>
+            </a:r>
+          </a:p>
+          <a:p>
+            <a:pPr>
+              <a:spcAft>
+                <a:spcPts val="600"/>
+              </a:spcAft>
+            </a:pPr>
+            <a:r>
+              <a:rPr sz="1200" b="0">
+                <a:solidFill>
+                  <a:srgbClr val="282828"/>
+                </a:solidFill>
+                <a:latin typeface="Arial"/>
+              </a:rPr>
+              <a:t>•  14 Backup: how the telescope reached the pixel; the Dyson design ladder; the 54 mm design; the block-size trade; the methods and the checks; twelve engine findings; records</a:t>
             </a:r>
           </a:p>
         </p:txBody>
@@ -9195,7 +9266,7 @@
 </p:sld>
 </file>
 
-<file path=ppt/slides/slide19.xml><?xml version="1.0" encoding="utf-8"?>
+<file path=ppt/slides/slide20.xml><?xml version="1.0" encoding="utf-8"?>
 <p:sld xmlns:a="http://schemas.openxmlformats.org/drawingml/2006/main" xmlns:p="http://schemas.openxmlformats.org/presentationml/2006/main" xmlns:r="http://schemas.openxmlformats.org/officeDocument/2006/relationships">
   <p:cSld>
     <p:spTree>
@@ -9239,7 +9310,7 @@
                 </a:solidFill>
                 <a:latin typeface="Arial"/>
               </a:rPr>
-              <a:t>Four more findings from the telescope's eccentric section</a:t>
+              <a:t>Eight engine findings from the spectrometer, each with a regression test</a:t>
             </a:r>
           </a:p>
           <a:p>
@@ -9255,7 +9326,7 @@
                 </a:solidFill>
                 <a:latin typeface="Arial"/>
               </a:rPr>
-              <a:t>Found 2026-10-04 to 10-05, each invisible on a coaxial design, each fixed the same day</a:t>
+              <a:t>Found by the design's own checks between 2026-09-30 and 10-03, fixed in the engine the same day</a:t>
             </a:r>
           </a:p>
         </p:txBody>
@@ -9314,7 +9385,7 @@
         </p:nvGraphicFramePr>
         <p:xfrm>
           <a:off x="411480" y="1298448"/>
-          <a:ext cx="11368734" cy="2154555"/>
+          <a:ext cx="11368733" cy="4029075"/>
         </p:xfrm>
         <a:graphic>
           <a:graphicData uri="http://schemas.openxmlformats.org/drawingml/2006/table">
@@ -9323,9 +9394,9 @@
                 <a:tableStyleId>{5C22544A-7EE6-4342-B048-85BDC9FD1C3A}</a:tableStyleId>
               </a:tblPr>
               <a:tblGrid>
-                <a:gridCol w="1894789"/>
-                <a:gridCol w="5581946"/>
-                <a:gridCol w="3891999"/>
+                <a:gridCol w="1944095"/>
+                <a:gridCol w="4606662"/>
+                <a:gridCol w="4817976"/>
               </a:tblGrid>
               <a:tr h="280035">
                 <a:tc>
@@ -9408,7 +9479,7 @@
                           </a:solidFill>
                           <a:latin typeface="Arial"/>
                         </a:rPr>
-                        <a:t>ray on the far sheet of a hyperboloid</a:t>
+                        <a:t>glass names ignored at load</a:t>
                       </a:r>
                     </a:p>
                   </a:txBody>
@@ -9430,7 +9501,7 @@
                           </a:solidFill>
                           <a:latin typeface="Arial"/>
                         </a:rPr>
-                        <a:t>40 of 1185 rays on the section's M3 took the second sheet: 44 mm of extra path, every ray reported as passing</a:t>
+                        <a:t>a GlassElt= Silica element traced as air</a:t>
                       </a:r>
                     </a:p>
                   </a:txBody>
@@ -9452,7 +9523,7 @@
                           </a:solidFill>
                           <a:latin typeface="Arial"/>
                         </a:rPr>
-                        <a:t>the root on the sheet the vertex is on; 406 prescriptions pre/post identical</a:t>
+                        <a:t>the glass catalog is blanked once at allocation, not on every load</a:t>
                       </a:r>
                     </a:p>
                   </a:txBody>
@@ -9476,7 +9547,7 @@
                           </a:solidFill>
                           <a:latin typeface="Arial"/>
                         </a:rPr>
-                        <a:t>optimizer aperture sized at one field</a:t>
+                        <a:t>vacuum wavelength inside glass</a:t>
                       </a:r>
                     </a:p>
                   </a:txBody>
@@ -9498,7 +9569,7 @@
                           </a:solidFill>
                           <a:latin typeface="Arial"/>
                         </a:rPr>
-                        <a:t>the strip-edge fields lost every ray on M3 and were dropped by the solve</a:t>
+                        <a:t>a propagation leg in a medium ran at the wrong Fresnel number by n</a:t>
                       </a:r>
                     </a:p>
                   </a:txBody>
@@ -9520,7 +9591,7 @@
                           </a:solidFill>
                           <a:latin typeface="Arial"/>
                         </a:rPr>
-                        <a:t>the aperture encloses the footprint over every field of the solve</a:t>
+                        <a:t>every kernel takes λ/n of the leg's medium</a:t>
                       </a:r>
                     </a:p>
                   </a:txBody>
@@ -9544,7 +9615,7 @@
                           </a:solidFill>
                           <a:latin typeface="Arial"/>
                         </a:rPr>
-                        <a:t>stop aimed at the parent vertex</a:t>
+                        <a:t>groove period along the surface</a:t>
                       </a:r>
                     </a:p>
                   </a:txBody>
@@ -9566,7 +9637,7 @@
                           </a:solidFill>
                           <a:latin typeface="Arial"/>
                         </a:rPr>
-                        <a:t>on an eccentric section the pupil sphere was placed 190 mm from the beam</a:t>
+                        <a:t>2.8 / 3.3 px rms spectral blur at 2500 nm (Offner / Dyson)</a:t>
                       </a:r>
                     </a:p>
                   </a:txBody>
@@ -9588,7 +9659,7 @@
                           </a:solidFill>
                           <a:latin typeface="Arial"/>
                         </a:rPr>
-                        <a:t>the stop at the prescription's object-space stop point</a:t>
+                        <a:t>the local grating vector is the projection of the ruling direction, un-normalized (chord-ruled)</a:t>
                       </a:r>
                     </a:p>
                   </a:txBody>
@@ -9612,7 +9683,7 @@
                           </a:solidFill>
                           <a:latin typeface="Arial"/>
                         </a:rPr>
-                        <a:t>Zernike origin at the parent vertex</a:t>
+                        <a:t>grating path-length jump</a:t>
                       </a:r>
                     </a:p>
                   </a:txBody>
@@ -9634,7 +9705,7 @@
                           </a:solidFill>
                           <a:latin typeface="Arial"/>
                         </a:rPr>
-                        <a:t>freeform terms on a section evaluated 3.8 radii outside the unit disc</a:t>
+                        <a:t>4 waves rms of pupil error where the rays converged to 0.05 µm</a:t>
                       </a:r>
                     </a:p>
                   </a:txBody>
@@ -9656,7 +9727,279 @@
                           </a:solidFill>
                           <a:latin typeface="Arial"/>
                         </a:rPr>
-                        <a:t>the origin is the element's pole</a:t>
+                        <a:t>the jump is the groove count from the vertex along the ruling direction</a:t>
+                      </a:r>
+                    </a:p>
+                  </a:txBody>
+                  <a:tcPr marL="54864" marR="54864" marT="18288" marB="18288">
+                    <a:solidFill>
+                      <a:srgbClr val="ECF1F6"/>
+                    </a:solidFill>
+                  </a:tcPr>
+                </a:tc>
+              </a:tr>
+              <a:tr h="468630">
+                <a:tc>
+                  <a:txBody>
+                    <a:bodyPr wrap="square"/>
+                    <a:lstStyle/>
+                    <a:p>
+                      <a:r>
+                        <a:rPr sz="1100" b="0">
+                          <a:solidFill>
+                            <a:srgbClr val="282828"/>
+                          </a:solidFill>
+                          <a:latin typeface="Arial"/>
+                        </a:rPr>
+                        <a:t>optimizer derivative stride</a:t>
+                      </a:r>
+                    </a:p>
+                  </a:txBody>
+                  <a:tcPr marL="54864" marR="54864" marT="18288" marB="18288">
+                    <a:solidFill>
+                      <a:srgbClr val="FFFFFF"/>
+                    </a:solidFill>
+                  </a:tcPr>
+                </a:tc>
+                <a:tc>
+                  <a:txBody>
+                    <a:bodyPr wrap="square"/>
+                    <a:lstStyle/>
+                    <a:p>
+                      <a:r>
+                        <a:rPr sz="1100" b="0">
+                          <a:solidFill>
+                            <a:srgbClr val="282828"/>
+                          </a:solidFill>
+                          <a:latin typeface="Arial"/>
+                        </a:rPr>
+                        <a:t>a multi-field spot-size solve overwrote memory on its second field</a:t>
+                      </a:r>
+                    </a:p>
+                  </a:txBody>
+                  <a:tcPr marL="54864" marR="54864" marT="18288" marB="18288">
+                    <a:solidFill>
+                      <a:srgbClr val="FFFFFF"/>
+                    </a:solidFill>
+                  </a:tcPr>
+                </a:tc>
+                <a:tc>
+                  <a:txBody>
+                    <a:bodyPr wrap="square"/>
+                    <a:lstStyle/>
+                    <a:p>
+                      <a:r>
+                        <a:rPr sz="1100" b="0">
+                          <a:solidFill>
+                            <a:srgbClr val="282828"/>
+                          </a:solidFill>
+                          <a:latin typeface="Arial"/>
+                        </a:rPr>
+                        <a:t>advance by the objective's size, as the value loop does</a:t>
+                      </a:r>
+                    </a:p>
+                  </a:txBody>
+                  <a:tcPr marL="54864" marR="54864" marT="18288" marB="18288">
+                    <a:solidFill>
+                      <a:srgbClr val="FFFFFF"/>
+                    </a:solidFill>
+                  </a:tcPr>
+                </a:tc>
+              </a:tr>
+              <a:tr h="468630">
+                <a:tc>
+                  <a:txBody>
+                    <a:bodyPr wrap="square"/>
+                    <a:lstStyle/>
+                    <a:p>
+                      <a:r>
+                        <a:rPr sz="1100" b="0">
+                          <a:solidFill>
+                            <a:srgbClr val="282828"/>
+                          </a:solidFill>
+                          <a:latin typeface="Arial"/>
+                        </a:rPr>
+                        <a:t>ray behind the surface after a pupil reference</a:t>
+                      </a:r>
+                    </a:p>
+                  </a:txBody>
+                  <a:tcPr marL="54864" marR="54864" marT="18288" marB="18288">
+                    <a:solidFill>
+                      <a:srgbClr val="ECF1F6"/>
+                    </a:solidFill>
+                  </a:tcPr>
+                </a:tc>
+                <a:tc>
+                  <a:txBody>
+                    <a:bodyPr wrap="square"/>
+                    <a:lstStyle/>
+                    <a:p>
+                      <a:r>
+                        <a:rPr sz="1100" b="0">
+                          <a:solidFill>
+                            <a:srgbClr val="282828"/>
+                          </a:solidFill>
+                          <a:latin typeface="Arial"/>
+                        </a:rPr>
+                        <a:t>a two-mirror with its pupil reference 5 mm ahead of a convex primary scattered every ray in a one-call trace</a:t>
+                      </a:r>
+                    </a:p>
+                  </a:txBody>
+                  <a:tcPr marL="54864" marR="54864" marT="18288" marB="18288">
+                    <a:solidFill>
+                      <a:srgbClr val="ECF1F6"/>
+                    </a:solidFill>
+                  </a:tcPr>
+                </a:tc>
+                <a:tc>
+                  <a:txBody>
+                    <a:bodyPr wrap="square"/>
+                    <a:lstStyle/>
+                    <a:p>
+                      <a:r>
+                        <a:rPr sz="1100" b="0">
+                          <a:solidFill>
+                            <a:srgbClr val="282828"/>
+                          </a:solidFill>
+                          <a:latin typeface="Arial"/>
+                        </a:rPr>
+                        <a:t>the conic root nearest the element's reference point; a restarted trace resets its previous element per ray</a:t>
+                      </a:r>
+                    </a:p>
+                  </a:txBody>
+                  <a:tcPr marL="54864" marR="54864" marT="18288" marB="18288">
+                    <a:solidFill>
+                      <a:srgbClr val="ECF1F6"/>
+                    </a:solidFill>
+                  </a:tcPr>
+                </a:tc>
+              </a:tr>
+              <a:tr h="468630">
+                <a:tc>
+                  <a:txBody>
+                    <a:bodyPr wrap="square"/>
+                    <a:lstStyle/>
+                    <a:p>
+                      <a:r>
+                        <a:rPr sz="1100" b="0">
+                          <a:solidFill>
+                            <a:srgbClr val="282828"/>
+                          </a:solidFill>
+                          <a:latin typeface="Arial"/>
+                        </a:rPr>
+                        <a:t>beam conditions only under a beam target</a:t>
+                      </a:r>
+                    </a:p>
+                  </a:txBody>
+                  <a:tcPr marL="54864" marR="54864" marT="18288" marB="18288">
+                    <a:solidFill>
+                      <a:srgbClr val="FFFFFF"/>
+                    </a:solidFill>
+                  </a:tcPr>
+                </a:tc>
+                <a:tc>
+                  <a:txBody>
+                    <a:bodyPr wrap="square"/>
+                    <a:lstStyle/>
+                    <a:p>
+                      <a:r>
+                        <a:rPr sz="1100" b="0">
+                          <a:solidFill>
+                            <a:srgbClr val="282828"/>
+                          </a:solidFill>
+                          <a:latin typeface="Arial"/>
+                        </a:rPr>
+                        <a:t>chief direction and position could not be scored with a spot or wavefront target</a:t>
+                      </a:r>
+                    </a:p>
+                  </a:txBody>
+                  <a:tcPr marL="54864" marR="54864" marT="18288" marB="18288">
+                    <a:solidFill>
+                      <a:srgbClr val="FFFFFF"/>
+                    </a:solidFill>
+                  </a:tcPr>
+                </a:tc>
+                <a:tc>
+                  <a:txBody>
+                    <a:bodyPr wrap="square"/>
+                    <a:lstStyle/>
+                    <a:p>
+                      <a:r>
+                        <a:rPr sz="1100" b="0">
+                          <a:solidFill>
+                            <a:srgbClr val="282828"/>
+                          </a:solidFill>
+                          <a:latin typeface="Arial"/>
+                        </a:rPr>
+                        <a:t>the beam rows ride on any target; a position target per field; the centroid as the position</a:t>
+                      </a:r>
+                    </a:p>
+                  </a:txBody>
+                  <a:tcPr marL="54864" marR="54864" marT="18288" marB="18288">
+                    <a:solidFill>
+                      <a:srgbClr val="FFFFFF"/>
+                    </a:solidFill>
+                  </a:tcPr>
+                </a:tc>
+              </a:tr>
+              <a:tr h="468630">
+                <a:tc>
+                  <a:txBody>
+                    <a:bodyPr wrap="square"/>
+                    <a:lstStyle/>
+                    <a:p>
+                      <a:r>
+                        <a:rPr sz="1100" b="0">
+                          <a:solidFill>
+                            <a:srgbClr val="282828"/>
+                          </a:solidFill>
+                          <a:latin typeface="Arial"/>
+                        </a:rPr>
+                        <a:t>optimizer asphere step and failure exit</a:t>
+                      </a:r>
+                    </a:p>
+                  </a:txBody>
+                  <a:tcPr marL="54864" marR="54864" marT="18288" marB="18288">
+                    <a:solidFill>
+                      <a:srgbClr val="ECF1F6"/>
+                    </a:solidFill>
+                  </a:tcPr>
+                </a:tc>
+                <a:tc>
+                  <a:txBody>
+                    <a:bodyPr wrap="square"/>
+                    <a:lstStyle/>
+                    <a:p>
+                      <a:r>
+                        <a:rPr sz="1100" b="0">
+                          <a:solidFill>
+                            <a:srgbClr val="282828"/>
+                          </a:solidFill>
+                          <a:latin typeface="Arial"/>
+                        </a:rPr>
+                        <a:t>a fixed 1e-10 probe step: a zero derivative column, a singular matrix, and a stop that ended the host process</a:t>
+                      </a:r>
+                    </a:p>
+                  </a:txBody>
+                  <a:tcPr marL="54864" marR="54864" marT="18288" marB="18288">
+                    <a:solidFill>
+                      <a:srgbClr val="ECF1F6"/>
+                    </a:solidFill>
+                  </a:tcPr>
+                </a:tc>
+                <a:tc>
+                  <a:txBody>
+                    <a:bodyPr wrap="square"/>
+                    <a:lstStyle/>
+                    <a:p>
+                      <a:r>
+                        <a:rPr sz="1100" b="0">
+                          <a:solidFill>
+                            <a:srgbClr val="282828"/>
+                          </a:solidFill>
+                          <a:latin typeface="Arial"/>
+                        </a:rPr>
+                        <a:t>the step is 1e-3 of the coefficient (sag-based for a zero one); the failure restores the optics and returns a flag</a:t>
                       </a:r>
                     </a:p>
                   </a:txBody>
@@ -9679,7 +10022,7 @@
         </p:nvSpPr>
         <p:spPr>
           <a:xfrm>
-            <a:off x="411480" y="3599307"/>
+            <a:off x="411480" y="5473827"/>
             <a:ext cx="11368735" cy="274320"/>
           </a:xfrm>
           <a:prstGeom prst="rect">
@@ -9705,7 +10048,7 @@
                 </a:solidFill>
                 <a:latin typeface="Arial"/>
               </a:rPr>
-              <a:t>Tests: tFwdRoot (5), tAsphHook (3), tStopApStop (4), tFreeformPole (3).  Each of the four passed every existing check (rays passed, solves converged, decks loaded); what exposed them was a section whose beam is 190 mm from its parent's vertex.</a:t>
+              <a:t>Tests: tGlassDispersion, tPropMedium, tGratingImmersed + test_grating_chord, tGratingOpl, tSpectrometerRx, tTraceRestart, tBeamRows, tAsphCalib.  Flat gratings are unchanged by the grating fixes; the wavefront-target optimizer, which every telescope design used, was never affected by the fifth.</a:t>
             </a:r>
           </a:p>
         </p:txBody>
@@ -9718,7 +10061,7 @@
 </p:sld>
 </file>
 
-<file path=ppt/slides/slide2.xml><?xml version="1.0" encoding="utf-8"?>
+<file path=ppt/slides/slide21.xml><?xml version="1.0" encoding="utf-8"?>
 <p:sld xmlns:a="http://schemas.openxmlformats.org/drawingml/2006/main" xmlns:p="http://schemas.openxmlformats.org/presentationml/2006/main" xmlns:r="http://schemas.openxmlformats.org/officeDocument/2006/relationships">
   <p:cSld>
     <p:spTree>
@@ -9762,7 +10105,7 @@
                 </a:solidFill>
                 <a:latin typeface="Arial"/>
               </a:rPr>
-              <a:t>Contents</a:t>
+              <a:t>Four more findings from the telescope's eccentric section</a:t>
             </a:r>
           </a:p>
           <a:p>
@@ -9778,7 +10121,7 @@
                 </a:solidFill>
                 <a:latin typeface="Arial"/>
               </a:rPr>
-              <a:t>The target, the instrument of record, the comparison for Jim, the open module, the questions</a:t>
+              <a:t>Found 2026-10-04 to 10-05, each invisible on a coaxial design, each fixed the same day</a:t>
             </a:r>
           </a:p>
         </p:txBody>
@@ -9827,16 +10170,383 @@
           </a:p>
         </p:txBody>
       </p:sp>
+      <p:graphicFrame>
+        <p:nvGraphicFramePr>
+          <p:cNvPr id="4" name="Table 3"/>
+          <p:cNvGraphicFramePr>
+            <a:graphicFrameLocks noGrp="1"/>
+          </p:cNvGraphicFramePr>
+          <p:nvPr/>
+        </p:nvGraphicFramePr>
+        <p:xfrm>
+          <a:off x="411480" y="1298448"/>
+          <a:ext cx="11368734" cy="2154555"/>
+        </p:xfrm>
+        <a:graphic>
+          <a:graphicData uri="http://schemas.openxmlformats.org/drawingml/2006/table">
+            <a:tbl>
+              <a:tblPr firstRow="1" bandRow="1">
+                <a:tableStyleId>{5C22544A-7EE6-4342-B048-85BDC9FD1C3A}</a:tableStyleId>
+              </a:tblPr>
+              <a:tblGrid>
+                <a:gridCol w="1894789"/>
+                <a:gridCol w="5581946"/>
+                <a:gridCol w="3891999"/>
+              </a:tblGrid>
+              <a:tr h="280035">
+                <a:tc>
+                  <a:txBody>
+                    <a:bodyPr wrap="square"/>
+                    <a:lstStyle/>
+                    <a:p>
+                      <a:r>
+                        <a:rPr sz="1100" b="1">
+                          <a:solidFill>
+                            <a:srgbClr val="FFFFFF"/>
+                          </a:solidFill>
+                          <a:latin typeface="Arial"/>
+                        </a:rPr>
+                        <a:t>finding</a:t>
+                      </a:r>
+                    </a:p>
+                  </a:txBody>
+                  <a:tcPr marL="54864" marR="54864" marT="18288" marB="18288">
+                    <a:solidFill>
+                      <a:srgbClr val="1F4E79"/>
+                    </a:solidFill>
+                  </a:tcPr>
+                </a:tc>
+                <a:tc>
+                  <a:txBody>
+                    <a:bodyPr wrap="square"/>
+                    <a:lstStyle/>
+                    <a:p>
+                      <a:r>
+                        <a:rPr sz="1100" b="1">
+                          <a:solidFill>
+                            <a:srgbClr val="FFFFFF"/>
+                          </a:solidFill>
+                          <a:latin typeface="Arial"/>
+                        </a:rPr>
+                        <a:t>symptom</a:t>
+                      </a:r>
+                    </a:p>
+                  </a:txBody>
+                  <a:tcPr marL="54864" marR="54864" marT="18288" marB="18288">
+                    <a:solidFill>
+                      <a:srgbClr val="1F4E79"/>
+                    </a:solidFill>
+                  </a:tcPr>
+                </a:tc>
+                <a:tc>
+                  <a:txBody>
+                    <a:bodyPr wrap="square"/>
+                    <a:lstStyle/>
+                    <a:p>
+                      <a:r>
+                        <a:rPr sz="1100" b="1">
+                          <a:solidFill>
+                            <a:srgbClr val="FFFFFF"/>
+                          </a:solidFill>
+                          <a:latin typeface="Arial"/>
+                        </a:rPr>
+                        <a:t>fix</a:t>
+                      </a:r>
+                    </a:p>
+                  </a:txBody>
+                  <a:tcPr marL="54864" marR="54864" marT="18288" marB="18288">
+                    <a:solidFill>
+                      <a:srgbClr val="1F4E79"/>
+                    </a:solidFill>
+                  </a:tcPr>
+                </a:tc>
+              </a:tr>
+              <a:tr h="468630">
+                <a:tc>
+                  <a:txBody>
+                    <a:bodyPr wrap="square"/>
+                    <a:lstStyle/>
+                    <a:p>
+                      <a:r>
+                        <a:rPr sz="1100" b="0">
+                          <a:solidFill>
+                            <a:srgbClr val="282828"/>
+                          </a:solidFill>
+                          <a:latin typeface="Arial"/>
+                        </a:rPr>
+                        <a:t>ray on the far sheet of a hyperboloid</a:t>
+                      </a:r>
+                    </a:p>
+                  </a:txBody>
+                  <a:tcPr marL="54864" marR="54864" marT="18288" marB="18288">
+                    <a:solidFill>
+                      <a:srgbClr val="FFFFFF"/>
+                    </a:solidFill>
+                  </a:tcPr>
+                </a:tc>
+                <a:tc>
+                  <a:txBody>
+                    <a:bodyPr wrap="square"/>
+                    <a:lstStyle/>
+                    <a:p>
+                      <a:r>
+                        <a:rPr sz="1100" b="0">
+                          <a:solidFill>
+                            <a:srgbClr val="282828"/>
+                          </a:solidFill>
+                          <a:latin typeface="Arial"/>
+                        </a:rPr>
+                        <a:t>40 of 1185 rays on the section's M3 took the second sheet: 44 mm of extra path, every ray reported as passing</a:t>
+                      </a:r>
+                    </a:p>
+                  </a:txBody>
+                  <a:tcPr marL="54864" marR="54864" marT="18288" marB="18288">
+                    <a:solidFill>
+                      <a:srgbClr val="FFFFFF"/>
+                    </a:solidFill>
+                  </a:tcPr>
+                </a:tc>
+                <a:tc>
+                  <a:txBody>
+                    <a:bodyPr wrap="square"/>
+                    <a:lstStyle/>
+                    <a:p>
+                      <a:r>
+                        <a:rPr sz="1100" b="0">
+                          <a:solidFill>
+                            <a:srgbClr val="282828"/>
+                          </a:solidFill>
+                          <a:latin typeface="Arial"/>
+                        </a:rPr>
+                        <a:t>the root on the sheet the vertex is on; 406 prescriptions pre/post identical</a:t>
+                      </a:r>
+                    </a:p>
+                  </a:txBody>
+                  <a:tcPr marL="54864" marR="54864" marT="18288" marB="18288">
+                    <a:solidFill>
+                      <a:srgbClr val="FFFFFF"/>
+                    </a:solidFill>
+                  </a:tcPr>
+                </a:tc>
+              </a:tr>
+              <a:tr h="468630">
+                <a:tc>
+                  <a:txBody>
+                    <a:bodyPr wrap="square"/>
+                    <a:lstStyle/>
+                    <a:p>
+                      <a:r>
+                        <a:rPr sz="1100" b="0">
+                          <a:solidFill>
+                            <a:srgbClr val="282828"/>
+                          </a:solidFill>
+                          <a:latin typeface="Arial"/>
+                        </a:rPr>
+                        <a:t>optimizer aperture sized at one field</a:t>
+                      </a:r>
+                    </a:p>
+                  </a:txBody>
+                  <a:tcPr marL="54864" marR="54864" marT="18288" marB="18288">
+                    <a:solidFill>
+                      <a:srgbClr val="ECF1F6"/>
+                    </a:solidFill>
+                  </a:tcPr>
+                </a:tc>
+                <a:tc>
+                  <a:txBody>
+                    <a:bodyPr wrap="square"/>
+                    <a:lstStyle/>
+                    <a:p>
+                      <a:r>
+                        <a:rPr sz="1100" b="0">
+                          <a:solidFill>
+                            <a:srgbClr val="282828"/>
+                          </a:solidFill>
+                          <a:latin typeface="Arial"/>
+                        </a:rPr>
+                        <a:t>the strip-edge fields lost every ray on M3 and were dropped by the solve</a:t>
+                      </a:r>
+                    </a:p>
+                  </a:txBody>
+                  <a:tcPr marL="54864" marR="54864" marT="18288" marB="18288">
+                    <a:solidFill>
+                      <a:srgbClr val="ECF1F6"/>
+                    </a:solidFill>
+                  </a:tcPr>
+                </a:tc>
+                <a:tc>
+                  <a:txBody>
+                    <a:bodyPr wrap="square"/>
+                    <a:lstStyle/>
+                    <a:p>
+                      <a:r>
+                        <a:rPr sz="1100" b="0">
+                          <a:solidFill>
+                            <a:srgbClr val="282828"/>
+                          </a:solidFill>
+                          <a:latin typeface="Arial"/>
+                        </a:rPr>
+                        <a:t>the aperture encloses the footprint over every field of the solve</a:t>
+                      </a:r>
+                    </a:p>
+                  </a:txBody>
+                  <a:tcPr marL="54864" marR="54864" marT="18288" marB="18288">
+                    <a:solidFill>
+                      <a:srgbClr val="ECF1F6"/>
+                    </a:solidFill>
+                  </a:tcPr>
+                </a:tc>
+              </a:tr>
+              <a:tr h="468630">
+                <a:tc>
+                  <a:txBody>
+                    <a:bodyPr wrap="square"/>
+                    <a:lstStyle/>
+                    <a:p>
+                      <a:r>
+                        <a:rPr sz="1100" b="0">
+                          <a:solidFill>
+                            <a:srgbClr val="282828"/>
+                          </a:solidFill>
+                          <a:latin typeface="Arial"/>
+                        </a:rPr>
+                        <a:t>stop aimed at the parent vertex</a:t>
+                      </a:r>
+                    </a:p>
+                  </a:txBody>
+                  <a:tcPr marL="54864" marR="54864" marT="18288" marB="18288">
+                    <a:solidFill>
+                      <a:srgbClr val="FFFFFF"/>
+                    </a:solidFill>
+                  </a:tcPr>
+                </a:tc>
+                <a:tc>
+                  <a:txBody>
+                    <a:bodyPr wrap="square"/>
+                    <a:lstStyle/>
+                    <a:p>
+                      <a:r>
+                        <a:rPr sz="1100" b="0">
+                          <a:solidFill>
+                            <a:srgbClr val="282828"/>
+                          </a:solidFill>
+                          <a:latin typeface="Arial"/>
+                        </a:rPr>
+                        <a:t>on an eccentric section the pupil sphere was placed 190 mm from the beam</a:t>
+                      </a:r>
+                    </a:p>
+                  </a:txBody>
+                  <a:tcPr marL="54864" marR="54864" marT="18288" marB="18288">
+                    <a:solidFill>
+                      <a:srgbClr val="FFFFFF"/>
+                    </a:solidFill>
+                  </a:tcPr>
+                </a:tc>
+                <a:tc>
+                  <a:txBody>
+                    <a:bodyPr wrap="square"/>
+                    <a:lstStyle/>
+                    <a:p>
+                      <a:r>
+                        <a:rPr sz="1100" b="0">
+                          <a:solidFill>
+                            <a:srgbClr val="282828"/>
+                          </a:solidFill>
+                          <a:latin typeface="Arial"/>
+                        </a:rPr>
+                        <a:t>the stop at the prescription's object-space stop point</a:t>
+                      </a:r>
+                    </a:p>
+                  </a:txBody>
+                  <a:tcPr marL="54864" marR="54864" marT="18288" marB="18288">
+                    <a:solidFill>
+                      <a:srgbClr val="FFFFFF"/>
+                    </a:solidFill>
+                  </a:tcPr>
+                </a:tc>
+              </a:tr>
+              <a:tr h="468630">
+                <a:tc>
+                  <a:txBody>
+                    <a:bodyPr wrap="square"/>
+                    <a:lstStyle/>
+                    <a:p>
+                      <a:r>
+                        <a:rPr sz="1100" b="0">
+                          <a:solidFill>
+                            <a:srgbClr val="282828"/>
+                          </a:solidFill>
+                          <a:latin typeface="Arial"/>
+                        </a:rPr>
+                        <a:t>Zernike origin at the parent vertex</a:t>
+                      </a:r>
+                    </a:p>
+                  </a:txBody>
+                  <a:tcPr marL="54864" marR="54864" marT="18288" marB="18288">
+                    <a:solidFill>
+                      <a:srgbClr val="ECF1F6"/>
+                    </a:solidFill>
+                  </a:tcPr>
+                </a:tc>
+                <a:tc>
+                  <a:txBody>
+                    <a:bodyPr wrap="square"/>
+                    <a:lstStyle/>
+                    <a:p>
+                      <a:r>
+                        <a:rPr sz="1100" b="0">
+                          <a:solidFill>
+                            <a:srgbClr val="282828"/>
+                          </a:solidFill>
+                          <a:latin typeface="Arial"/>
+                        </a:rPr>
+                        <a:t>freeform terms on a section evaluated 3.8 radii outside the unit disc</a:t>
+                      </a:r>
+                    </a:p>
+                  </a:txBody>
+                  <a:tcPr marL="54864" marR="54864" marT="18288" marB="18288">
+                    <a:solidFill>
+                      <a:srgbClr val="ECF1F6"/>
+                    </a:solidFill>
+                  </a:tcPr>
+                </a:tc>
+                <a:tc>
+                  <a:txBody>
+                    <a:bodyPr wrap="square"/>
+                    <a:lstStyle/>
+                    <a:p>
+                      <a:r>
+                        <a:rPr sz="1100" b="0">
+                          <a:solidFill>
+                            <a:srgbClr val="282828"/>
+                          </a:solidFill>
+                          <a:latin typeface="Arial"/>
+                        </a:rPr>
+                        <a:t>the origin is the element's pole</a:t>
+                      </a:r>
+                    </a:p>
+                  </a:txBody>
+                  <a:tcPr marL="54864" marR="54864" marT="18288" marB="18288">
+                    <a:solidFill>
+                      <a:srgbClr val="ECF1F6"/>
+                    </a:solidFill>
+                  </a:tcPr>
+                </a:tc>
+              </a:tr>
+            </a:tbl>
+          </a:graphicData>
+        </a:graphic>
+      </p:graphicFrame>
       <p:sp>
         <p:nvSpPr>
-          <p:cNvPr id="4" name="TextBox 3"/>
+          <p:cNvPr id="5" name="TextBox 4"/>
           <p:cNvSpPr txBox="1"/>
           <p:nvPr/>
         </p:nvSpPr>
         <p:spPr>
           <a:xfrm>
-            <a:off x="411480" y="1298448"/>
-            <a:ext cx="5806440" cy="274320"/>
+            <a:off x="411480" y="3599307"/>
+            <a:ext cx="11368735" cy="274320"/>
           </a:xfrm>
           <a:prstGeom prst="rect">
             <a:avLst/>
@@ -9855,180 +10565,13 @@
               </a:spcAft>
             </a:pPr>
             <a:r>
-              <a:rPr sz="1200" b="0">
+              <a:rPr sz="1050" b="0">
                 <a:solidFill>
-                  <a:srgbClr val="282828"/>
+                  <a:srgbClr val="6E6E6E"/>
                 </a:solidFill>
                 <a:latin typeface="Arial"/>
               </a:rPr>
-              <a:t>•  3 The target and how it is scored</a:t>
-            </a:r>
-          </a:p>
-          <a:p>
-            <a:pPr>
-              <a:spcAft>
-                <a:spcPts val="600"/>
-              </a:spcAft>
-            </a:pPr>
-            <a:r>
-              <a:rPr sz="1200" b="0">
-                <a:solidFill>
-                  <a:srgbClr val="282828"/>
-                </a:solidFill>
-                <a:latin typeface="Arial"/>
-              </a:rPr>
-              <a:t>•  4 The 1.5k module, end to end</a:t>
-            </a:r>
-          </a:p>
-          <a:p>
-            <a:pPr>
-              <a:spcAft>
-                <a:spcPts val="600"/>
-              </a:spcAft>
-            </a:pPr>
-            <a:r>
-              <a:rPr sz="1200" b="0">
-                <a:solidFill>
-                  <a:srgbClr val="282828"/>
-                </a:solidFill>
-                <a:latin typeface="Arial"/>
-              </a:rPr>
-              <a:t>•  5 The telescope of record</a:t>
-            </a:r>
-          </a:p>
-          <a:p>
-            <a:pPr>
-              <a:spcAft>
-                <a:spcPts val="600"/>
-              </a:spcAft>
-            </a:pPr>
-            <a:r>
-              <a:rPr sz="1200" b="0">
-                <a:solidFill>
-                  <a:srgbClr val="282828"/>
-                </a:solidFill>
-                <a:latin typeface="Arial"/>
-              </a:rPr>
-              <a:t>•  6 The spectrometer of record for the 1.5k module</a:t>
-            </a:r>
-          </a:p>
-          <a:p>
-            <a:pPr>
-              <a:spcAft>
-                <a:spcPts val="600"/>
-              </a:spcAft>
-            </a:pPr>
-            <a:r>
-              <a:rPr sz="1200" b="0">
-                <a:solidFill>
-                  <a:srgbClr val="282828"/>
-                </a:solidFill>
-                <a:latin typeface="Arial"/>
-              </a:rPr>
-              <a:t>•  7 Two of 3k in CaF2 or four of 1.5k in silica</a:t>
-            </a:r>
-          </a:p>
-          <a:p>
-            <a:pPr>
-              <a:spcAft>
-                <a:spcPts val="600"/>
-              </a:spcAft>
-            </a:pPr>
-            <a:r>
-              <a:rPr sz="1200" b="0">
-                <a:solidFill>
-                  <a:srgbClr val="282828"/>
-                </a:solidFill>
-                <a:latin typeface="Arial"/>
-              </a:rPr>
-              <a:t>•  8 The 3k module: where it stands</a:t>
-            </a:r>
-          </a:p>
-        </p:txBody>
-      </p:sp>
-      <p:sp>
-        <p:nvSpPr>
-          <p:cNvPr id="5" name="TextBox 4"/>
-          <p:cNvSpPr txBox="1"/>
-          <p:nvPr/>
-        </p:nvSpPr>
-        <p:spPr>
-          <a:xfrm>
-            <a:off x="6400800" y="1298448"/>
-            <a:ext cx="5394960" cy="274320"/>
-          </a:xfrm>
-          <a:prstGeom prst="rect">
-            <a:avLst/>
-          </a:prstGeom>
-          <a:noFill/>
-        </p:spPr>
-        <p:txBody>
-          <a:bodyPr wrap="square">
-            <a:spAutoFit/>
-          </a:bodyPr>
-          <a:lstStyle/>
-          <a:p>
-            <a:pPr>
-              <a:spcAft>
-                <a:spcPts val="600"/>
-              </a:spcAft>
-            </a:pPr>
-            <a:r>
-              <a:rPr sz="1200" b="0">
-                <a:solidFill>
-                  <a:srgbClr val="282828"/>
-                </a:solidFill>
-                <a:latin typeface="Arial"/>
-              </a:rPr>
-              <a:t>•  9 Questions for Jim</a:t>
-            </a:r>
-          </a:p>
-          <a:p>
-            <a:pPr>
-              <a:spcAft>
-                <a:spcPts val="600"/>
-              </a:spcAft>
-            </a:pPr>
-            <a:r>
-              <a:rPr sz="1200" b="0">
-                <a:solidFill>
-                  <a:srgbClr val="282828"/>
-                </a:solidFill>
-                <a:latin typeface="Arial"/>
-              </a:rPr>
-              <a:t>•  10 Next steps</a:t>
-            </a:r>
-          </a:p>
-          <a:p>
-            <a:pPr>
-              <a:spcAft>
-                <a:spcPts val="600"/>
-              </a:spcAft>
-            </a:pPr>
-            <a:r>
-              <a:rPr sz="1200" b="0">
-                <a:solidFill>
-                  <a:srgbClr val="282828"/>
-                </a:solidFill>
-                <a:latin typeface="Arial"/>
-              </a:rPr>
-              <a:t>•  11 Run it yourself</a:t>
-            </a:r>
-          </a:p>
-          <a:p>
-            <a:pPr>
-              <a:spcAft>
-                <a:spcPts val="600"/>
-              </a:spcAft>
-            </a:pPr>
-            <a:r>
-              <a:rPr sz="1200" b="0">
-                <a:solidFill>
-                  <a:srgbClr val="282828"/>
-                </a:solidFill>
-                <a:latin typeface="Arial"/>
-              </a:rPr>
-              <a:t>•  12 Backup: how the telescope reached the pixel; the Dyson design ladder; the 54 mm design; the block-size trade; the methods and the checks; twelve engine findings; records</a:t>
+              <a:t>Tests: tFwdRoot (5), tAsphHook (3), tStopApStop (4), tFreeformPole (3).  Each of the four passed every existing check (rays passed, solves converged, decks loaded); what exposed them was a section whose beam is 190 mm from its parent's vertex.</a:t>
             </a:r>
           </a:p>
         </p:txBody>
@@ -10041,7 +10584,7 @@
 </p:sld>
 </file>
 
-<file path=ppt/slides/slide20.xml><?xml version="1.0" encoding="utf-8"?>
+<file path=ppt/slides/slide22.xml><?xml version="1.0" encoding="utf-8"?>
 <p:sld xmlns:a="http://schemas.openxmlformats.org/drawingml/2006/main" xmlns:p="http://schemas.openxmlformats.org/presentationml/2006/main" xmlns:r="http://schemas.openxmlformats.org/officeDocument/2006/relationships">
   <p:cSld>
     <p:spTree>
@@ -11735,6 +12278,1535 @@
 </file>
 
 <file path=ppt/slides/slide4.xml><?xml version="1.0" encoding="utf-8"?>
+<p:sld xmlns:a="http://schemas.openxmlformats.org/drawingml/2006/main" xmlns:p="http://schemas.openxmlformats.org/presentationml/2006/main" xmlns:r="http://schemas.openxmlformats.org/officeDocument/2006/relationships">
+  <p:cSld>
+    <p:spTree>
+      <p:nvGrpSpPr>
+        <p:cNvPr id="1" name=""/>
+        <p:cNvGrpSpPr/>
+        <p:nvPr/>
+      </p:nvGrpSpPr>
+      <p:grpSpPr/>
+      <p:sp>
+        <p:nvSpPr>
+          <p:cNvPr id="2" name="TextBox 1"/>
+          <p:cNvSpPr txBox="1"/>
+          <p:nvPr/>
+        </p:nvSpPr>
+        <p:spPr>
+          <a:xfrm>
+            <a:off x="411480" y="201168"/>
+            <a:ext cx="11368735" cy="914400"/>
+          </a:xfrm>
+          <a:prstGeom prst="rect">
+            <a:avLst/>
+          </a:prstGeom>
+          <a:noFill/>
+        </p:spPr>
+        <p:txBody>
+          <a:bodyPr wrap="square">
+            <a:spAutoFit/>
+          </a:bodyPr>
+          <a:lstStyle/>
+          <a:p>
+            <a:pPr>
+              <a:spcAft>
+                <a:spcPts val="400"/>
+              </a:spcAft>
+            </a:pPr>
+            <a:r>
+              <a:rPr sz="2400" b="1">
+                <a:solidFill>
+                  <a:srgbClr val="1F4E79"/>
+                </a:solidFill>
+                <a:latin typeface="Arial"/>
+              </a:rPr>
+              <a:t>The 1.5k module, scored: spectrometer, telescope, and the two together</a:t>
+            </a:r>
+          </a:p>
+          <a:p>
+            <a:pPr>
+              <a:spcAft>
+                <a:spcPts val="0"/>
+              </a:spcAft>
+            </a:pPr>
+            <a:r>
+              <a:rPr sz="1250" b="0">
+                <a:solidFill>
+                  <a:srgbClr val="6E6E6E"/>
+                </a:solidFill>
+                <a:latin typeface="Arial"/>
+              </a:rPr>
+              <a:t>The spectrometer meets every line of the specification; the telescope reaches the pixel at the strip center and 0.8 px at its ends; together they image at the pixel over the strip, with the energy in a pixel falling toward the ends</a:t>
+            </a:r>
+          </a:p>
+        </p:txBody>
+      </p:sp>
+      <p:sp>
+        <p:nvSpPr>
+          <p:cNvPr id="3" name="Rectangle 2"/>
+          <p:cNvSpPr/>
+          <p:nvPr/>
+        </p:nvSpPr>
+        <p:spPr>
+          <a:xfrm>
+            <a:off x="411480" y="1133856"/>
+            <a:ext cx="11368735" cy="20320"/>
+          </a:xfrm>
+          <a:prstGeom prst="rect">
+            <a:avLst/>
+          </a:prstGeom>
+          <a:solidFill>
+            <a:srgbClr val="B8C6D4"/>
+          </a:solidFill>
+          <a:ln>
+            <a:noFill/>
+          </a:ln>
+          <a:effectLst/>
+        </p:spPr>
+        <p:style>
+          <a:lnRef idx="1">
+            <a:schemeClr val="accent1"/>
+          </a:lnRef>
+          <a:fillRef idx="3">
+            <a:schemeClr val="accent1"/>
+          </a:fillRef>
+          <a:effectRef idx="2">
+            <a:schemeClr val="accent1"/>
+          </a:effectRef>
+          <a:fontRef idx="minor">
+            <a:schemeClr val="lt1"/>
+          </a:fontRef>
+        </p:style>
+        <p:txBody>
+          <a:bodyPr rtlCol="0" anchor="ctr"/>
+          <a:lstStyle/>
+          <a:p>
+            <a:pPr algn="ctr"/>
+          </a:p>
+        </p:txBody>
+      </p:sp>
+      <p:graphicFrame>
+        <p:nvGraphicFramePr>
+          <p:cNvPr id="4" name="Table 3"/>
+          <p:cNvGraphicFramePr>
+            <a:graphicFrameLocks noGrp="1"/>
+          </p:cNvGraphicFramePr>
+          <p:nvPr/>
+        </p:nvGraphicFramePr>
+        <p:xfrm>
+          <a:off x="411480" y="1298448"/>
+          <a:ext cx="11368734" cy="4491990"/>
+        </p:xfrm>
+        <a:graphic>
+          <a:graphicData uri="http://schemas.openxmlformats.org/drawingml/2006/table">
+            <a:tbl>
+              <a:tblPr firstRow="1" bandRow="1">
+                <a:tableStyleId>{5C22544A-7EE6-4342-B048-85BDC9FD1C3A}</a:tableStyleId>
+              </a:tblPr>
+              <a:tblGrid>
+                <a:gridCol w="1776282"/>
+                <a:gridCol w="1599184"/>
+                <a:gridCol w="2141987"/>
+                <a:gridCol w="2194230"/>
+                <a:gridCol w="3657051"/>
+              </a:tblGrid>
+              <a:tr h="468630">
+                <a:tc>
+                  <a:txBody>
+                    <a:bodyPr wrap="square"/>
+                    <a:lstStyle/>
+                    <a:p>
+                      <a:r>
+                        <a:rPr sz="1100" b="1">
+                          <a:solidFill>
+                            <a:srgbClr val="FFFFFF"/>
+                          </a:solidFill>
+                          <a:latin typeface="Arial"/>
+                        </a:rPr>
+                        <a:t>criterion</a:t>
+                      </a:r>
+                    </a:p>
+                  </a:txBody>
+                  <a:tcPr marL="54864" marR="54864" marT="18288" marB="18288">
+                    <a:solidFill>
+                      <a:srgbClr val="1F4E79"/>
+                    </a:solidFill>
+                  </a:tcPr>
+                </a:tc>
+                <a:tc>
+                  <a:txBody>
+                    <a:bodyPr wrap="square"/>
+                    <a:lstStyle/>
+                    <a:p>
+                      <a:r>
+                        <a:rPr sz="1100" b="1">
+                          <a:solidFill>
+                            <a:srgbClr val="FFFFFF"/>
+                          </a:solidFill>
+                          <a:latin typeface="Arial"/>
+                        </a:rPr>
+                        <a:t>specification</a:t>
+                      </a:r>
+                    </a:p>
+                  </a:txBody>
+                  <a:tcPr marL="54864" marR="54864" marT="18288" marB="18288">
+                    <a:solidFill>
+                      <a:srgbClr val="1F4E79"/>
+                    </a:solidFill>
+                  </a:tcPr>
+                </a:tc>
+                <a:tc>
+                  <a:txBody>
+                    <a:bodyPr wrap="square"/>
+                    <a:lstStyle/>
+                    <a:p>
+                      <a:r>
+                        <a:rPr sz="1100" b="1">
+                          <a:solidFill>
+                            <a:srgbClr val="FFFFFF"/>
+                          </a:solidFill>
+                          <a:latin typeface="Arial"/>
+                        </a:rPr>
+                        <a:t>spectrometer alone (130 mm silica Dyson)</a:t>
+                      </a:r>
+                    </a:p>
+                  </a:txBody>
+                  <a:tcPr marL="54864" marR="54864" marT="18288" marB="18288">
+                    <a:solidFill>
+                      <a:srgbClr val="1F4E79"/>
+                    </a:solidFill>
+                  </a:tcPr>
+                </a:tc>
+                <a:tc>
+                  <a:txBody>
+                    <a:bodyPr wrap="square"/>
+                    <a:lstStyle/>
+                    <a:p>
+                      <a:r>
+                        <a:rPr sz="1100" b="1">
+                          <a:solidFill>
+                            <a:srgbClr val="FFFFFF"/>
+                          </a:solidFill>
+                          <a:latin typeface="Arial"/>
+                        </a:rPr>
+                        <a:t>telescope alone (three off-axis aspheres)</a:t>
+                      </a:r>
+                    </a:p>
+                  </a:txBody>
+                  <a:tcPr marL="54864" marR="54864" marT="18288" marB="18288">
+                    <a:solidFill>
+                      <a:srgbClr val="1F4E79"/>
+                    </a:solidFill>
+                  </a:tcPr>
+                </a:tc>
+                <a:tc>
+                  <a:txBody>
+                    <a:bodyPr wrap="square"/>
+                    <a:lstStyle/>
+                    <a:p>
+                      <a:r>
+                        <a:rPr sz="1100" b="1">
+                          <a:solidFill>
+                            <a:srgbClr val="FFFFFF"/>
+                          </a:solidFill>
+                          <a:latin typeface="Arial"/>
+                        </a:rPr>
+                        <a:t>together, end to end</a:t>
+                      </a:r>
+                    </a:p>
+                  </a:txBody>
+                  <a:tcPr marL="54864" marR="54864" marT="18288" marB="18288">
+                    <a:solidFill>
+                      <a:srgbClr val="1F4E79"/>
+                    </a:solidFill>
+                  </a:tcPr>
+                </a:tc>
+              </a:tr>
+              <a:tr h="280035">
+                <a:tc>
+                  <a:txBody>
+                    <a:bodyPr wrap="square"/>
+                    <a:lstStyle/>
+                    <a:p>
+                      <a:r>
+                        <a:rPr sz="1100" b="0">
+                          <a:solidFill>
+                            <a:srgbClr val="282828"/>
+                          </a:solidFill>
+                          <a:latin typeface="Arial"/>
+                        </a:rPr>
+                        <a:t>smile</a:t>
+                      </a:r>
+                    </a:p>
+                  </a:txBody>
+                  <a:tcPr marL="54864" marR="54864" marT="18288" marB="18288">
+                    <a:solidFill>
+                      <a:srgbClr val="FFFFFF"/>
+                    </a:solidFill>
+                  </a:tcPr>
+                </a:tc>
+                <a:tc>
+                  <a:txBody>
+                    <a:bodyPr wrap="square"/>
+                    <a:lstStyle/>
+                    <a:p>
+                      <a:r>
+                        <a:rPr sz="1100" b="0">
+                          <a:solidFill>
+                            <a:srgbClr val="282828"/>
+                          </a:solidFill>
+                          <a:latin typeface="Arial"/>
+                        </a:rPr>
+                        <a:t>&lt; 0.1 px</a:t>
+                      </a:r>
+                    </a:p>
+                  </a:txBody>
+                  <a:tcPr marL="54864" marR="54864" marT="18288" marB="18288">
+                    <a:solidFill>
+                      <a:srgbClr val="FFFFFF"/>
+                    </a:solidFill>
+                  </a:tcPr>
+                </a:tc>
+                <a:tc>
+                  <a:txBody>
+                    <a:bodyPr wrap="square"/>
+                    <a:lstStyle/>
+                    <a:p>
+                      <a:r>
+                        <a:rPr sz="1100" b="0">
+                          <a:solidFill>
+                            <a:srgbClr val="282828"/>
+                          </a:solidFill>
+                          <a:latin typeface="Arial"/>
+                        </a:rPr>
+                        <a:t>0.007 px</a:t>
+                      </a:r>
+                    </a:p>
+                  </a:txBody>
+                  <a:tcPr marL="54864" marR="54864" marT="18288" marB="18288">
+                    <a:solidFill>
+                      <a:srgbClr val="FFFFFF"/>
+                    </a:solidFill>
+                  </a:tcPr>
+                </a:tc>
+                <a:tc>
+                  <a:txBody>
+                    <a:bodyPr wrap="square"/>
+                    <a:lstStyle/>
+                    <a:p>
+                      <a:r>
+                        <a:rPr sz="1100" b="0">
+                          <a:solidFill>
+                            <a:srgbClr val="282828"/>
+                          </a:solidFill>
+                          <a:latin typeface="Arial"/>
+                        </a:rPr>
+                        <a:t>–</a:t>
+                      </a:r>
+                    </a:p>
+                  </a:txBody>
+                  <a:tcPr marL="54864" marR="54864" marT="18288" marB="18288">
+                    <a:solidFill>
+                      <a:srgbClr val="FFFFFF"/>
+                    </a:solidFill>
+                  </a:tcPr>
+                </a:tc>
+                <a:tc>
+                  <a:txBody>
+                    <a:bodyPr wrap="square"/>
+                    <a:lstStyle/>
+                    <a:p>
+                      <a:r>
+                        <a:rPr sz="1100" b="0">
+                          <a:solidFill>
+                            <a:srgbClr val="282828"/>
+                          </a:solidFill>
+                          <a:latin typeface="Arial"/>
+                        </a:rPr>
+                        <a:t>0.51 px</a:t>
+                      </a:r>
+                    </a:p>
+                  </a:txBody>
+                  <a:tcPr marL="54864" marR="54864" marT="18288" marB="18288">
+                    <a:solidFill>
+                      <a:srgbClr val="FFFFFF"/>
+                    </a:solidFill>
+                  </a:tcPr>
+                </a:tc>
+              </a:tr>
+              <a:tr h="280035">
+                <a:tc>
+                  <a:txBody>
+                    <a:bodyPr wrap="square"/>
+                    <a:lstStyle/>
+                    <a:p>
+                      <a:r>
+                        <a:rPr sz="1100" b="0">
+                          <a:solidFill>
+                            <a:srgbClr val="282828"/>
+                          </a:solidFill>
+                          <a:latin typeface="Arial"/>
+                        </a:rPr>
+                        <a:t>keystone</a:t>
+                      </a:r>
+                    </a:p>
+                  </a:txBody>
+                  <a:tcPr marL="54864" marR="54864" marT="18288" marB="18288">
+                    <a:solidFill>
+                      <a:srgbClr val="ECF1F6"/>
+                    </a:solidFill>
+                  </a:tcPr>
+                </a:tc>
+                <a:tc>
+                  <a:txBody>
+                    <a:bodyPr wrap="square"/>
+                    <a:lstStyle/>
+                    <a:p>
+                      <a:r>
+                        <a:rPr sz="1100" b="0">
+                          <a:solidFill>
+                            <a:srgbClr val="282828"/>
+                          </a:solidFill>
+                          <a:latin typeface="Arial"/>
+                        </a:rPr>
+                        <a:t>&lt; 0.1 px</a:t>
+                      </a:r>
+                    </a:p>
+                  </a:txBody>
+                  <a:tcPr marL="54864" marR="54864" marT="18288" marB="18288">
+                    <a:solidFill>
+                      <a:srgbClr val="ECF1F6"/>
+                    </a:solidFill>
+                  </a:tcPr>
+                </a:tc>
+                <a:tc>
+                  <a:txBody>
+                    <a:bodyPr wrap="square"/>
+                    <a:lstStyle/>
+                    <a:p>
+                      <a:r>
+                        <a:rPr sz="1100" b="0">
+                          <a:solidFill>
+                            <a:srgbClr val="282828"/>
+                          </a:solidFill>
+                          <a:latin typeface="Arial"/>
+                        </a:rPr>
+                        <a:t>0.009 px</a:t>
+                      </a:r>
+                    </a:p>
+                  </a:txBody>
+                  <a:tcPr marL="54864" marR="54864" marT="18288" marB="18288">
+                    <a:solidFill>
+                      <a:srgbClr val="ECF1F6"/>
+                    </a:solidFill>
+                  </a:tcPr>
+                </a:tc>
+                <a:tc>
+                  <a:txBody>
+                    <a:bodyPr wrap="square"/>
+                    <a:lstStyle/>
+                    <a:p>
+                      <a:r>
+                        <a:rPr sz="1100" b="0">
+                          <a:solidFill>
+                            <a:srgbClr val="282828"/>
+                          </a:solidFill>
+                          <a:latin typeface="Arial"/>
+                        </a:rPr>
+                        <a:t>–</a:t>
+                      </a:r>
+                    </a:p>
+                  </a:txBody>
+                  <a:tcPr marL="54864" marR="54864" marT="18288" marB="18288">
+                    <a:solidFill>
+                      <a:srgbClr val="ECF1F6"/>
+                    </a:solidFill>
+                  </a:tcPr>
+                </a:tc>
+                <a:tc>
+                  <a:txBody>
+                    <a:bodyPr wrap="square"/>
+                    <a:lstStyle/>
+                    <a:p>
+                      <a:r>
+                        <a:rPr sz="1100" b="0">
+                          <a:solidFill>
+                            <a:srgbClr val="282828"/>
+                          </a:solidFill>
+                          <a:latin typeface="Arial"/>
+                        </a:rPr>
+                        <a:t>0.01 px</a:t>
+                      </a:r>
+                    </a:p>
+                  </a:txBody>
+                  <a:tcPr marL="54864" marR="54864" marT="18288" marB="18288">
+                    <a:solidFill>
+                      <a:srgbClr val="ECF1F6"/>
+                    </a:solidFill>
+                  </a:tcPr>
+                </a:tc>
+              </a:tr>
+              <a:tr h="280035">
+                <a:tc>
+                  <a:txBody>
+                    <a:bodyPr wrap="square"/>
+                    <a:lstStyle/>
+                    <a:p>
+                      <a:r>
+                        <a:rPr sz="1100" b="0">
+                          <a:solidFill>
+                            <a:srgbClr val="282828"/>
+                          </a:solidFill>
+                          <a:latin typeface="Arial"/>
+                        </a:rPr>
+                        <a:t>CRF FWHM</a:t>
+                      </a:r>
+                    </a:p>
+                  </a:txBody>
+                  <a:tcPr marL="54864" marR="54864" marT="18288" marB="18288">
+                    <a:solidFill>
+                      <a:srgbClr val="FFFFFF"/>
+                    </a:solidFill>
+                  </a:tcPr>
+                </a:tc>
+                <a:tc>
+                  <a:txBody>
+                    <a:bodyPr wrap="square"/>
+                    <a:lstStyle/>
+                    <a:p>
+                      <a:r>
+                        <a:rPr sz="1100" b="0">
+                          <a:solidFill>
+                            <a:srgbClr val="282828"/>
+                          </a:solidFill>
+                          <a:latin typeface="Arial"/>
+                        </a:rPr>
+                        <a:t>&lt; 1.5 px</a:t>
+                      </a:r>
+                    </a:p>
+                  </a:txBody>
+                  <a:tcPr marL="54864" marR="54864" marT="18288" marB="18288">
+                    <a:solidFill>
+                      <a:srgbClr val="FFFFFF"/>
+                    </a:solidFill>
+                  </a:tcPr>
+                </a:tc>
+                <a:tc>
+                  <a:txBody>
+                    <a:bodyPr wrap="square"/>
+                    <a:lstStyle/>
+                    <a:p>
+                      <a:r>
+                        <a:rPr sz="1100" b="0">
+                          <a:solidFill>
+                            <a:srgbClr val="282828"/>
+                          </a:solidFill>
+                          <a:latin typeface="Arial"/>
+                        </a:rPr>
+                        <a:t>1.03 px</a:t>
+                      </a:r>
+                    </a:p>
+                  </a:txBody>
+                  <a:tcPr marL="54864" marR="54864" marT="18288" marB="18288">
+                    <a:solidFill>
+                      <a:srgbClr val="FFFFFF"/>
+                    </a:solidFill>
+                  </a:tcPr>
+                </a:tc>
+                <a:tc>
+                  <a:txBody>
+                    <a:bodyPr wrap="square"/>
+                    <a:lstStyle/>
+                    <a:p>
+                      <a:r>
+                        <a:rPr sz="1100" b="0">
+                          <a:solidFill>
+                            <a:srgbClr val="282828"/>
+                          </a:solidFill>
+                          <a:latin typeface="Arial"/>
+                        </a:rPr>
+                        <a:t>–</a:t>
+                      </a:r>
+                    </a:p>
+                  </a:txBody>
+                  <a:tcPr marL="54864" marR="54864" marT="18288" marB="18288">
+                    <a:solidFill>
+                      <a:srgbClr val="FFFFFF"/>
+                    </a:solidFill>
+                  </a:tcPr>
+                </a:tc>
+                <a:tc>
+                  <a:txBody>
+                    <a:bodyPr wrap="square"/>
+                    <a:lstStyle/>
+                    <a:p>
+                      <a:r>
+                        <a:rPr sz="1100" b="0">
+                          <a:solidFill>
+                            <a:srgbClr val="282828"/>
+                          </a:solidFill>
+                          <a:latin typeface="Arial"/>
+                        </a:rPr>
+                        <a:t>1.22 px</a:t>
+                      </a:r>
+                    </a:p>
+                  </a:txBody>
+                  <a:tcPr marL="54864" marR="54864" marT="18288" marB="18288">
+                    <a:solidFill>
+                      <a:srgbClr val="FFFFFF"/>
+                    </a:solidFill>
+                  </a:tcPr>
+                </a:tc>
+              </a:tr>
+              <a:tr h="280035">
+                <a:tc>
+                  <a:txBody>
+                    <a:bodyPr wrap="square"/>
+                    <a:lstStyle/>
+                    <a:p>
+                      <a:r>
+                        <a:rPr sz="1100" b="0">
+                          <a:solidFill>
+                            <a:srgbClr val="282828"/>
+                          </a:solidFill>
+                          <a:latin typeface="Arial"/>
+                        </a:rPr>
+                        <a:t>SRF FWHM</a:t>
+                      </a:r>
+                    </a:p>
+                  </a:txBody>
+                  <a:tcPr marL="54864" marR="54864" marT="18288" marB="18288">
+                    <a:solidFill>
+                      <a:srgbClr val="ECF1F6"/>
+                    </a:solidFill>
+                  </a:tcPr>
+                </a:tc>
+                <a:tc>
+                  <a:txBody>
+                    <a:bodyPr wrap="square"/>
+                    <a:lstStyle/>
+                    <a:p>
+                      <a:r>
+                        <a:rPr sz="1100" b="0">
+                          <a:solidFill>
+                            <a:srgbClr val="282828"/>
+                          </a:solidFill>
+                          <a:latin typeface="Arial"/>
+                        </a:rPr>
+                        <a:t>&lt; 1.5–2.0 px</a:t>
+                      </a:r>
+                    </a:p>
+                  </a:txBody>
+                  <a:tcPr marL="54864" marR="54864" marT="18288" marB="18288">
+                    <a:solidFill>
+                      <a:srgbClr val="ECF1F6"/>
+                    </a:solidFill>
+                  </a:tcPr>
+                </a:tc>
+                <a:tc>
+                  <a:txBody>
+                    <a:bodyPr wrap="square"/>
+                    <a:lstStyle/>
+                    <a:p>
+                      <a:r>
+                        <a:rPr sz="1100" b="0">
+                          <a:solidFill>
+                            <a:srgbClr val="282828"/>
+                          </a:solidFill>
+                          <a:latin typeface="Arial"/>
+                        </a:rPr>
+                        <a:t>2.02 px (2-pixel slit)</a:t>
+                      </a:r>
+                    </a:p>
+                  </a:txBody>
+                  <a:tcPr marL="54864" marR="54864" marT="18288" marB="18288">
+                    <a:solidFill>
+                      <a:srgbClr val="ECF1F6"/>
+                    </a:solidFill>
+                  </a:tcPr>
+                </a:tc>
+                <a:tc>
+                  <a:txBody>
+                    <a:bodyPr wrap="square"/>
+                    <a:lstStyle/>
+                    <a:p>
+                      <a:r>
+                        <a:rPr sz="1100" b="0">
+                          <a:solidFill>
+                            <a:srgbClr val="282828"/>
+                          </a:solidFill>
+                          <a:latin typeface="Arial"/>
+                        </a:rPr>
+                        <a:t>–</a:t>
+                      </a:r>
+                    </a:p>
+                  </a:txBody>
+                  <a:tcPr marL="54864" marR="54864" marT="18288" marB="18288">
+                    <a:solidFill>
+                      <a:srgbClr val="ECF1F6"/>
+                    </a:solidFill>
+                  </a:tcPr>
+                </a:tc>
+                <a:tc>
+                  <a:txBody>
+                    <a:bodyPr wrap="square"/>
+                    <a:lstStyle/>
+                    <a:p>
+                      <a:r>
+                        <a:rPr sz="1100" b="0">
+                          <a:solidFill>
+                            <a:srgbClr val="282828"/>
+                          </a:solidFill>
+                          <a:latin typeface="Arial"/>
+                        </a:rPr>
+                        <a:t>2.20 px</a:t>
+                      </a:r>
+                    </a:p>
+                  </a:txBody>
+                  <a:tcPr marL="54864" marR="54864" marT="18288" marB="18288">
+                    <a:solidFill>
+                      <a:srgbClr val="ECF1F6"/>
+                    </a:solidFill>
+                  </a:tcPr>
+                </a:tc>
+              </a:tr>
+              <a:tr h="468630">
+                <a:tc>
+                  <a:txBody>
+                    <a:bodyPr wrap="square"/>
+                    <a:lstStyle/>
+                    <a:p>
+                      <a:r>
+                        <a:rPr sz="1100" b="0">
+                          <a:solidFill>
+                            <a:srgbClr val="282828"/>
+                          </a:solidFill>
+                          <a:latin typeface="Arial"/>
+                        </a:rPr>
+                        <a:t>energy in one 18 µm pixel</a:t>
+                      </a:r>
+                    </a:p>
+                  </a:txBody>
+                  <a:tcPr marL="54864" marR="54864" marT="18288" marB="18288">
+                    <a:solidFill>
+                      <a:srgbClr val="FFFFFF"/>
+                    </a:solidFill>
+                  </a:tcPr>
+                </a:tc>
+                <a:tc>
+                  <a:txBody>
+                    <a:bodyPr wrap="square"/>
+                    <a:lstStyle/>
+                    <a:p>
+                      <a:r>
+                        <a:rPr sz="1100" b="0">
+                          <a:solidFill>
+                            <a:srgbClr val="282828"/>
+                          </a:solidFill>
+                          <a:latin typeface="Arial"/>
+                        </a:rPr>
+                        <a:t>&gt; 0.75 (design rule)</a:t>
+                      </a:r>
+                    </a:p>
+                  </a:txBody>
+                  <a:tcPr marL="54864" marR="54864" marT="18288" marB="18288">
+                    <a:solidFill>
+                      <a:srgbClr val="FFFFFF"/>
+                    </a:solidFill>
+                  </a:tcPr>
+                </a:tc>
+                <a:tc>
+                  <a:txBody>
+                    <a:bodyPr wrap="square"/>
+                    <a:lstStyle/>
+                    <a:p>
+                      <a:r>
+                        <a:rPr sz="1100" b="0">
+                          <a:solidFill>
+                            <a:srgbClr val="282828"/>
+                          </a:solidFill>
+                          <a:latin typeface="Arial"/>
+                        </a:rPr>
+                        <a:t>1.00</a:t>
+                      </a:r>
+                    </a:p>
+                  </a:txBody>
+                  <a:tcPr marL="54864" marR="54864" marT="18288" marB="18288">
+                    <a:solidFill>
+                      <a:srgbClr val="FFFFFF"/>
+                    </a:solidFill>
+                  </a:tcPr>
+                </a:tc>
+                <a:tc>
+                  <a:txBody>
+                    <a:bodyPr wrap="square"/>
+                    <a:lstStyle/>
+                    <a:p>
+                      <a:r>
+                        <a:rPr sz="1100" b="0">
+                          <a:solidFill>
+                            <a:srgbClr val="282828"/>
+                          </a:solidFill>
+                          <a:latin typeface="Arial"/>
+                        </a:rPr>
+                        <a:t>–</a:t>
+                      </a:r>
+                    </a:p>
+                  </a:txBody>
+                  <a:tcPr marL="54864" marR="54864" marT="18288" marB="18288">
+                    <a:solidFill>
+                      <a:srgbClr val="FFFFFF"/>
+                    </a:solidFill>
+                  </a:tcPr>
+                </a:tc>
+                <a:tc>
+                  <a:txBody>
+                    <a:bodyPr wrap="square"/>
+                    <a:lstStyle/>
+                    <a:p>
+                      <a:r>
+                        <a:rPr sz="1100" b="0">
+                          <a:solidFill>
+                            <a:srgbClr val="282828"/>
+                          </a:solidFill>
+                          <a:latin typeface="Arial"/>
+                        </a:rPr>
+                        <a:t>0.78–0.89 over the central third; 0.65 at ±9 mm; 0.30–0.48 at the ends</a:t>
+                      </a:r>
+                    </a:p>
+                  </a:txBody>
+                  <a:tcPr marL="54864" marR="54864" marT="18288" marB="18288">
+                    <a:solidFill>
+                      <a:srgbClr val="FFFFFF"/>
+                    </a:solidFill>
+                  </a:tcPr>
+                </a:tc>
+              </a:tr>
+              <a:tr h="468630">
+                <a:tc>
+                  <a:txBody>
+                    <a:bodyPr wrap="square"/>
+                    <a:lstStyle/>
+                    <a:p>
+                      <a:r>
+                        <a:rPr sz="1100" b="0">
+                          <a:solidFill>
+                            <a:srgbClr val="282828"/>
+                          </a:solidFill>
+                          <a:latin typeface="Arial"/>
+                        </a:rPr>
+                        <a:t>image blur (rms spot, as placed)</a:t>
+                      </a:r>
+                    </a:p>
+                  </a:txBody>
+                  <a:tcPr marL="54864" marR="54864" marT="18288" marB="18288">
+                    <a:solidFill>
+                      <a:srgbClr val="ECF1F6"/>
+                    </a:solidFill>
+                  </a:tcPr>
+                </a:tc>
+                <a:tc>
+                  <a:txBody>
+                    <a:bodyPr wrap="square"/>
+                    <a:lstStyle/>
+                    <a:p>
+                      <a:r>
+                        <a:rPr sz="1100" b="0">
+                          <a:solidFill>
+                            <a:srgbClr val="282828"/>
+                          </a:solidFill>
+                          <a:latin typeface="Arial"/>
+                        </a:rPr>
+                        <a:t>–</a:t>
+                      </a:r>
+                    </a:p>
+                  </a:txBody>
+                  <a:tcPr marL="54864" marR="54864" marT="18288" marB="18288">
+                    <a:solidFill>
+                      <a:srgbClr val="ECF1F6"/>
+                    </a:solidFill>
+                  </a:tcPr>
+                </a:tc>
+                <a:tc>
+                  <a:txBody>
+                    <a:bodyPr wrap="square"/>
+                    <a:lstStyle/>
+                    <a:p>
+                      <a:r>
+                        <a:rPr sz="1100" b="0">
+                          <a:solidFill>
+                            <a:srgbClr val="282828"/>
+                          </a:solidFill>
+                          <a:latin typeface="Arial"/>
+                        </a:rPr>
+                        <a:t>–</a:t>
+                      </a:r>
+                    </a:p>
+                  </a:txBody>
+                  <a:tcPr marL="54864" marR="54864" marT="18288" marB="18288">
+                    <a:solidFill>
+                      <a:srgbClr val="ECF1F6"/>
+                    </a:solidFill>
+                  </a:tcPr>
+                </a:tc>
+                <a:tc>
+                  <a:txBody>
+                    <a:bodyPr wrap="square"/>
+                    <a:lstStyle/>
+                    <a:p>
+                      <a:r>
+                        <a:rPr sz="1100" b="0">
+                          <a:solidFill>
+                            <a:srgbClr val="282828"/>
+                          </a:solidFill>
+                          <a:latin typeface="Arial"/>
+                        </a:rPr>
+                        <a:t>8 µm center, 14 µm at ±2.3° (0.4 / 0.8 px)</a:t>
+                      </a:r>
+                    </a:p>
+                  </a:txBody>
+                  <a:tcPr marL="54864" marR="54864" marT="18288" marB="18288">
+                    <a:solidFill>
+                      <a:srgbClr val="ECF1F6"/>
+                    </a:solidFill>
+                  </a:tcPr>
+                </a:tc>
+                <a:tc>
+                  <a:txBody>
+                    <a:bodyPr wrap="square"/>
+                    <a:lstStyle/>
+                    <a:p>
+                      <a:r>
+                        <a:rPr sz="1100" b="0">
+                          <a:solidFill>
+                            <a:srgbClr val="282828"/>
+                          </a:solidFill>
+                          <a:latin typeface="Arial"/>
+                        </a:rPr>
+                        <a:t>–</a:t>
+                      </a:r>
+                    </a:p>
+                  </a:txBody>
+                  <a:tcPr marL="54864" marR="54864" marT="18288" marB="18288">
+                    <a:solidFill>
+                      <a:srgbClr val="ECF1F6"/>
+                    </a:solidFill>
+                  </a:tcPr>
+                </a:tc>
+              </a:tr>
+              <a:tr h="280035">
+                <a:tc>
+                  <a:txBody>
+                    <a:bodyPr wrap="square"/>
+                    <a:lstStyle/>
+                    <a:p>
+                      <a:r>
+                        <a:rPr sz="1100" b="0">
+                          <a:solidFill>
+                            <a:srgbClr val="282828"/>
+                          </a:solidFill>
+                          <a:latin typeface="Arial"/>
+                        </a:rPr>
+                        <a:t>plate scale</a:t>
+                      </a:r>
+                    </a:p>
+                  </a:txBody>
+                  <a:tcPr marL="54864" marR="54864" marT="18288" marB="18288">
+                    <a:solidFill>
+                      <a:srgbClr val="FFFFFF"/>
+                    </a:solidFill>
+                  </a:tcPr>
+                </a:tc>
+                <a:tc>
+                  <a:txBody>
+                    <a:bodyPr wrap="square"/>
+                    <a:lstStyle/>
+                    <a:p>
+                      <a:r>
+                        <a:rPr sz="1100" b="0">
+                          <a:solidFill>
+                            <a:srgbClr val="282828"/>
+                          </a:solidFill>
+                          <a:latin typeface="Arial"/>
+                        </a:rPr>
+                        <a:t>330 mm</a:t>
+                      </a:r>
+                    </a:p>
+                  </a:txBody>
+                  <a:tcPr marL="54864" marR="54864" marT="18288" marB="18288">
+                    <a:solidFill>
+                      <a:srgbClr val="FFFFFF"/>
+                    </a:solidFill>
+                  </a:tcPr>
+                </a:tc>
+                <a:tc>
+                  <a:txBody>
+                    <a:bodyPr wrap="square"/>
+                    <a:lstStyle/>
+                    <a:p>
+                      <a:r>
+                        <a:rPr sz="1100" b="0">
+                          <a:solidFill>
+                            <a:srgbClr val="282828"/>
+                          </a:solidFill>
+                          <a:latin typeface="Arial"/>
+                        </a:rPr>
+                        <a:t>–</a:t>
+                      </a:r>
+                    </a:p>
+                  </a:txBody>
+                  <a:tcPr marL="54864" marR="54864" marT="18288" marB="18288">
+                    <a:solidFill>
+                      <a:srgbClr val="FFFFFF"/>
+                    </a:solidFill>
+                  </a:tcPr>
+                </a:tc>
+                <a:tc>
+                  <a:txBody>
+                    <a:bodyPr wrap="square"/>
+                    <a:lstStyle/>
+                    <a:p>
+                      <a:r>
+                        <a:rPr sz="1100" b="0">
+                          <a:solidFill>
+                            <a:srgbClr val="282828"/>
+                          </a:solidFill>
+                          <a:latin typeface="Arial"/>
+                        </a:rPr>
+                        <a:t>327 mm center, 331 mm edge</a:t>
+                      </a:r>
+                    </a:p>
+                  </a:txBody>
+                  <a:tcPr marL="54864" marR="54864" marT="18288" marB="18288">
+                    <a:solidFill>
+                      <a:srgbClr val="FFFFFF"/>
+                    </a:solidFill>
+                  </a:tcPr>
+                </a:tc>
+                <a:tc>
+                  <a:txBody>
+                    <a:bodyPr wrap="square"/>
+                    <a:lstStyle/>
+                    <a:p>
+                      <a:r>
+                        <a:rPr sz="1100" b="0">
+                          <a:solidFill>
+                            <a:srgbClr val="282828"/>
+                          </a:solidFill>
+                          <a:latin typeface="Arial"/>
+                        </a:rPr>
+                        <a:t>327 / 331 mm</a:t>
+                      </a:r>
+                    </a:p>
+                  </a:txBody>
+                  <a:tcPr marL="54864" marR="54864" marT="18288" marB="18288">
+                    <a:solidFill>
+                      <a:srgbClr val="FFFFFF"/>
+                    </a:solidFill>
+                  </a:tcPr>
+                </a:tc>
+              </a:tr>
+              <a:tr h="468630">
+                <a:tc>
+                  <a:txBody>
+                    <a:bodyPr wrap="square"/>
+                    <a:lstStyle/>
+                    <a:p>
+                      <a:r>
+                        <a:rPr sz="1100" b="0">
+                          <a:solidFill>
+                            <a:srgbClr val="282828"/>
+                          </a:solidFill>
+                          <a:latin typeface="Arial"/>
+                        </a:rPr>
+                        <a:t>light admitted by the grating stop</a:t>
+                      </a:r>
+                    </a:p>
+                  </a:txBody>
+                  <a:tcPr marL="54864" marR="54864" marT="18288" marB="18288">
+                    <a:solidFill>
+                      <a:srgbClr val="ECF1F6"/>
+                    </a:solidFill>
+                  </a:tcPr>
+                </a:tc>
+                <a:tc>
+                  <a:txBody>
+                    <a:bodyPr wrap="square"/>
+                    <a:lstStyle/>
+                    <a:p>
+                      <a:r>
+                        <a:rPr sz="1100" b="0">
+                          <a:solidFill>
+                            <a:srgbClr val="282828"/>
+                          </a:solidFill>
+                          <a:latin typeface="Arial"/>
+                        </a:rPr>
+                        <a:t>all</a:t>
+                      </a:r>
+                    </a:p>
+                  </a:txBody>
+                  <a:tcPr marL="54864" marR="54864" marT="18288" marB="18288">
+                    <a:solidFill>
+                      <a:srgbClr val="ECF1F6"/>
+                    </a:solidFill>
+                  </a:tcPr>
+                </a:tc>
+                <a:tc>
+                  <a:txBody>
+                    <a:bodyPr wrap="square"/>
+                    <a:lstStyle/>
+                    <a:p>
+                      <a:r>
+                        <a:rPr sz="1100" b="0">
+                          <a:solidFill>
+                            <a:srgbClr val="282828"/>
+                          </a:solidFill>
+                          <a:latin typeface="Arial"/>
+                        </a:rPr>
+                        <a:t>all</a:t>
+                      </a:r>
+                    </a:p>
+                  </a:txBody>
+                  <a:tcPr marL="54864" marR="54864" marT="18288" marB="18288">
+                    <a:solidFill>
+                      <a:srgbClr val="ECF1F6"/>
+                    </a:solidFill>
+                  </a:tcPr>
+                </a:tc>
+                <a:tc>
+                  <a:txBody>
+                    <a:bodyPr wrap="square"/>
+                    <a:lstStyle/>
+                    <a:p>
+                      <a:r>
+                        <a:rPr sz="1100" b="0">
+                          <a:solidFill>
+                            <a:srgbClr val="282828"/>
+                          </a:solidFill>
+                          <a:latin typeface="Arial"/>
+                        </a:rPr>
+                        <a:t>chiefs within 0.5° across the strip</a:t>
+                      </a:r>
+                    </a:p>
+                  </a:txBody>
+                  <a:tcPr marL="54864" marR="54864" marT="18288" marB="18288">
+                    <a:solidFill>
+                      <a:srgbClr val="ECF1F6"/>
+                    </a:solidFill>
+                  </a:tcPr>
+                </a:tc>
+                <a:tc>
+                  <a:txBody>
+                    <a:bodyPr wrap="square"/>
+                    <a:lstStyle/>
+                    <a:p>
+                      <a:r>
+                        <a:rPr sz="1100" b="0">
+                          <a:solidFill>
+                            <a:srgbClr val="282828"/>
+                          </a:solidFill>
+                          <a:latin typeface="Arial"/>
+                        </a:rPr>
+                        <a:t>100 % at every field</a:t>
+                      </a:r>
+                    </a:p>
+                  </a:txBody>
+                  <a:tcPr marL="54864" marR="54864" marT="18288" marB="18288">
+                    <a:solidFill>
+                      <a:srgbClr val="ECF1F6"/>
+                    </a:solidFill>
+                  </a:tcPr>
+                </a:tc>
+              </a:tr>
+              <a:tr h="468630">
+                <a:tc>
+                  <a:txBody>
+                    <a:bodyPr wrap="square"/>
+                    <a:lstStyle/>
+                    <a:p>
+                      <a:r>
+                        <a:rPr sz="1100" b="0">
+                          <a:solidFill>
+                            <a:srgbClr val="282828"/>
+                          </a:solidFill>
+                          <a:latin typeface="Arial"/>
+                        </a:rPr>
+                        <a:t>uncoated throughput</a:t>
+                      </a:r>
+                    </a:p>
+                  </a:txBody>
+                  <a:tcPr marL="54864" marR="54864" marT="18288" marB="18288">
+                    <a:solidFill>
+                      <a:srgbClr val="FFFFFF"/>
+                    </a:solidFill>
+                  </a:tcPr>
+                </a:tc>
+                <a:tc>
+                  <a:txBody>
+                    <a:bodyPr wrap="square"/>
+                    <a:lstStyle/>
+                    <a:p>
+                      <a:r>
+                        <a:rPr sz="1100" b="0">
+                          <a:solidFill>
+                            <a:srgbClr val="282828"/>
+                          </a:solidFill>
+                          <a:latin typeface="Arial"/>
+                        </a:rPr>
+                        <a:t>–</a:t>
+                      </a:r>
+                    </a:p>
+                  </a:txBody>
+                  <a:tcPr marL="54864" marR="54864" marT="18288" marB="18288">
+                    <a:solidFill>
+                      <a:srgbClr val="FFFFFF"/>
+                    </a:solidFill>
+                  </a:tcPr>
+                </a:tc>
+                <a:tc>
+                  <a:txBody>
+                    <a:bodyPr wrap="square"/>
+                    <a:lstStyle/>
+                    <a:p>
+                      <a:r>
+                        <a:rPr sz="1100" b="0">
+                          <a:solidFill>
+                            <a:srgbClr val="282828"/>
+                          </a:solidFill>
+                          <a:latin typeface="Arial"/>
+                        </a:rPr>
+                        <a:t>0.87 (four air-glass crossings)</a:t>
+                      </a:r>
+                    </a:p>
+                  </a:txBody>
+                  <a:tcPr marL="54864" marR="54864" marT="18288" marB="18288">
+                    <a:solidFill>
+                      <a:srgbClr val="FFFFFF"/>
+                    </a:solidFill>
+                  </a:tcPr>
+                </a:tc>
+                <a:tc>
+                  <a:txBody>
+                    <a:bodyPr wrap="square"/>
+                    <a:lstStyle/>
+                    <a:p>
+                      <a:r>
+                        <a:rPr sz="1100" b="0">
+                          <a:solidFill>
+                            <a:srgbClr val="282828"/>
+                          </a:solidFill>
+                          <a:latin typeface="Arial"/>
+                        </a:rPr>
+                        <a:t>three reflections, not scored</a:t>
+                      </a:r>
+                    </a:p>
+                  </a:txBody>
+                  <a:tcPr marL="54864" marR="54864" marT="18288" marB="18288">
+                    <a:solidFill>
+                      <a:srgbClr val="FFFFFF"/>
+                    </a:solidFill>
+                  </a:tcPr>
+                </a:tc>
+                <a:tc>
+                  <a:txBody>
+                    <a:bodyPr wrap="square"/>
+                    <a:lstStyle/>
+                    <a:p>
+                      <a:r>
+                        <a:rPr sz="1100" b="0">
+                          <a:solidFill>
+                            <a:srgbClr val="282828"/>
+                          </a:solidFill>
+                          <a:latin typeface="Arial"/>
+                        </a:rPr>
+                        <a:t>–</a:t>
+                      </a:r>
+                    </a:p>
+                  </a:txBody>
+                  <a:tcPr marL="54864" marR="54864" marT="18288" marB="18288">
+                    <a:solidFill>
+                      <a:srgbClr val="FFFFFF"/>
+                    </a:solidFill>
+                  </a:tcPr>
+                </a:tc>
+              </a:tr>
+              <a:tr h="468630">
+                <a:tc>
+                  <a:txBody>
+                    <a:bodyPr wrap="square"/>
+                    <a:lstStyle/>
+                    <a:p>
+                      <a:r>
+                        <a:rPr sz="1100" b="0">
+                          <a:solidFill>
+                            <a:srgbClr val="282828"/>
+                          </a:solidFill>
+                          <a:latin typeface="Arial"/>
+                        </a:rPr>
+                        <a:t>clearance, worst pair</a:t>
+                      </a:r>
+                    </a:p>
+                  </a:txBody>
+                  <a:tcPr marL="54864" marR="54864" marT="18288" marB="18288">
+                    <a:solidFill>
+                      <a:srgbClr val="ECF1F6"/>
+                    </a:solidFill>
+                  </a:tcPr>
+                </a:tc>
+                <a:tc>
+                  <a:txBody>
+                    <a:bodyPr wrap="square"/>
+                    <a:lstStyle/>
+                    <a:p>
+                      <a:r>
+                        <a:rPr sz="1100" b="0">
+                          <a:solidFill>
+                            <a:srgbClr val="282828"/>
+                          </a:solidFill>
+                          <a:latin typeface="Arial"/>
+                        </a:rPr>
+                        <a:t>&gt; 0</a:t>
+                      </a:r>
+                    </a:p>
+                  </a:txBody>
+                  <a:tcPr marL="54864" marR="54864" marT="18288" marB="18288">
+                    <a:solidFill>
+                      <a:srgbClr val="ECF1F6"/>
+                    </a:solidFill>
+                  </a:tcPr>
+                </a:tc>
+                <a:tc>
+                  <a:txBody>
+                    <a:bodyPr wrap="square"/>
+                    <a:lstStyle/>
+                    <a:p>
+                      <a:r>
+                        <a:rPr sz="1100" b="0">
+                          <a:solidFill>
+                            <a:srgbClr val="282828"/>
+                          </a:solidFill>
+                          <a:latin typeface="Arial"/>
+                        </a:rPr>
+                        <a:t>+0.38 mm (detector package vs block face)</a:t>
+                      </a:r>
+                    </a:p>
+                  </a:txBody>
+                  <a:tcPr marL="54864" marR="54864" marT="18288" marB="18288">
+                    <a:solidFill>
+                      <a:srgbClr val="ECF1F6"/>
+                    </a:solidFill>
+                  </a:tcPr>
+                </a:tc>
+                <a:tc>
+                  <a:txBody>
+                    <a:bodyPr wrap="square"/>
+                    <a:lstStyle/>
+                    <a:p>
+                      <a:r>
+                        <a:rPr sz="1100" b="0">
+                          <a:solidFill>
+                            <a:srgbClr val="282828"/>
+                          </a:solidFill>
+                          <a:latin typeface="Arial"/>
+                        </a:rPr>
+                        <a:t>+39 mm (M1→M2 beam vs M3)</a:t>
+                      </a:r>
+                    </a:p>
+                  </a:txBody>
+                  <a:tcPr marL="54864" marR="54864" marT="18288" marB="18288">
+                    <a:solidFill>
+                      <a:srgbClr val="ECF1F6"/>
+                    </a:solidFill>
+                  </a:tcPr>
+                </a:tc>
+                <a:tc>
+                  <a:txBody>
+                    <a:bodyPr wrap="square"/>
+                    <a:lstStyle/>
+                    <a:p>
+                      <a:r>
+                        <a:rPr sz="1100" b="0">
+                          <a:solidFill>
+                            <a:srgbClr val="282828"/>
+                          </a:solidFill>
+                          <a:latin typeface="Arial"/>
+                        </a:rPr>
+                        <a:t>+0.38 mm (the spectrometer's pair)</a:t>
+                      </a:r>
+                    </a:p>
+                  </a:txBody>
+                  <a:tcPr marL="54864" marR="54864" marT="18288" marB="18288">
+                    <a:solidFill>
+                      <a:srgbClr val="ECF1F6"/>
+                    </a:solidFill>
+                  </a:tcPr>
+                </a:tc>
+              </a:tr>
+              <a:tr h="280035">
+                <a:tc>
+                  <a:txBody>
+                    <a:bodyPr wrap="square"/>
+                    <a:lstStyle/>
+                    <a:p>
+                      <a:r>
+                        <a:rPr sz="1100" b="0">
+                          <a:solidFill>
+                            <a:srgbClr val="282828"/>
+                          </a:solidFill>
+                          <a:latin typeface="Arial"/>
+                        </a:rPr>
+                        <a:t>glass, mass</a:t>
+                      </a:r>
+                    </a:p>
+                  </a:txBody>
+                  <a:tcPr marL="54864" marR="54864" marT="18288" marB="18288">
+                    <a:solidFill>
+                      <a:srgbClr val="FFFFFF"/>
+                    </a:solidFill>
+                  </a:tcPr>
+                </a:tc>
+                <a:tc>
+                  <a:txBody>
+                    <a:bodyPr wrap="square"/>
+                    <a:lstStyle/>
+                    <a:p>
+                      <a:r>
+                        <a:rPr sz="1100" b="0">
+                          <a:solidFill>
+                            <a:srgbClr val="282828"/>
+                          </a:solidFill>
+                          <a:latin typeface="Arial"/>
+                        </a:rPr>
+                        <a:t>–</a:t>
+                      </a:r>
+                    </a:p>
+                  </a:txBody>
+                  <a:tcPr marL="54864" marR="54864" marT="18288" marB="18288">
+                    <a:solidFill>
+                      <a:srgbClr val="FFFFFF"/>
+                    </a:solidFill>
+                  </a:tcPr>
+                </a:tc>
+                <a:tc>
+                  <a:txBody>
+                    <a:bodyPr wrap="square"/>
+                    <a:lstStyle/>
+                    <a:p>
+                      <a:r>
+                        <a:rPr sz="1100" b="0">
+                          <a:solidFill>
+                            <a:srgbClr val="282828"/>
+                          </a:solidFill>
+                          <a:latin typeface="Arial"/>
+                        </a:rPr>
+                        <a:t>0.75 L, 1.6 kg</a:t>
+                      </a:r>
+                    </a:p>
+                  </a:txBody>
+                  <a:tcPr marL="54864" marR="54864" marT="18288" marB="18288">
+                    <a:solidFill>
+                      <a:srgbClr val="FFFFFF"/>
+                    </a:solidFill>
+                  </a:tcPr>
+                </a:tc>
+                <a:tc>
+                  <a:txBody>
+                    <a:bodyPr wrap="square"/>
+                    <a:lstStyle/>
+                    <a:p>
+                      <a:r>
+                        <a:rPr sz="1100" b="0">
+                          <a:solidFill>
+                            <a:srgbClr val="282828"/>
+                          </a:solidFill>
+                          <a:latin typeface="Arial"/>
+                        </a:rPr>
+                        <a:t>mirrors not yet sized</a:t>
+                      </a:r>
+                    </a:p>
+                  </a:txBody>
+                  <a:tcPr marL="54864" marR="54864" marT="18288" marB="18288">
+                    <a:solidFill>
+                      <a:srgbClr val="FFFFFF"/>
+                    </a:solidFill>
+                  </a:tcPr>
+                </a:tc>
+                <a:tc>
+                  <a:txBody>
+                    <a:bodyPr wrap="square"/>
+                    <a:lstStyle/>
+                    <a:p>
+                      <a:r>
+                        <a:rPr sz="1100" b="0">
+                          <a:solidFill>
+                            <a:srgbClr val="282828"/>
+                          </a:solidFill>
+                          <a:latin typeface="Arial"/>
+                        </a:rPr>
+                        <a:t>–</a:t>
+                      </a:r>
+                    </a:p>
+                  </a:txBody>
+                  <a:tcPr marL="54864" marR="54864" marT="18288" marB="18288">
+                    <a:solidFill>
+                      <a:srgbClr val="FFFFFF"/>
+                    </a:solidFill>
+                  </a:tcPr>
+                </a:tc>
+              </a:tr>
+            </a:tbl>
+          </a:graphicData>
+        </a:graphic>
+      </p:graphicFrame>
+      <p:sp>
+        <p:nvSpPr>
+          <p:cNvPr id="5" name="TextBox 4"/>
+          <p:cNvSpPr txBox="1"/>
+          <p:nvPr/>
+        </p:nvSpPr>
+        <p:spPr>
+          <a:xfrm>
+            <a:off x="411480" y="5936742"/>
+            <a:ext cx="11368735" cy="274320"/>
+          </a:xfrm>
+          <a:prstGeom prst="rect">
+            <a:avLst/>
+          </a:prstGeom>
+          <a:noFill/>
+        </p:spPr>
+        <p:txBody>
+          <a:bodyPr wrap="square">
+            <a:spAutoFit/>
+          </a:bodyPr>
+          <a:lstStyle/>
+          <a:p>
+            <a:pPr>
+              <a:spcAft>
+                <a:spcPts val="600"/>
+              </a:spcAft>
+            </a:pPr>
+            <a:r>
+              <a:rPr sz="1050" b="0">
+                <a:solidFill>
+                  <a:srgbClr val="6E6E6E"/>
+                </a:solidFill>
+                <a:latin typeface="Arial"/>
+              </a:rPr>
+              <a:t>Spectrometer: dyson5_size.txt row D (130 mm), dyson5_jim_3a.txt; telescope: dyson5_tA_GM_1k5_bAs.txt; together: dyson5_t5f_GM_1k5_bAs.txt, 7 fields × 7 wavelengths.  No coatings, no tolerances in any column.  The 3k module's columns: slide 9.</a:t>
+            </a:r>
+          </a:p>
+        </p:txBody>
+      </p:sp>
+    </p:spTree>
+  </p:cSld>
+  <p:clrMapOvr>
+    <a:masterClrMapping/>
+  </p:clrMapOvr>
+</p:sld>
+</file>
+
+<file path=ppt/slides/slide5.xml><?xml version="1.0" encoding="utf-8"?>
 <p:sld xmlns:a="http://schemas.openxmlformats.org/drawingml/2006/main" xmlns:p="http://schemas.openxmlformats.org/presentationml/2006/main" xmlns:r="http://schemas.openxmlformats.org/officeDocument/2006/relationships">
   <p:cSld>
     <p:spTree>
@@ -12016,7 +14088,7 @@
 </p:sld>
 </file>
 
-<file path=ppt/slides/slide5.xml><?xml version="1.0" encoding="utf-8"?>
+<file path=ppt/slides/slide6.xml><?xml version="1.0" encoding="utf-8"?>
 <p:sld xmlns:a="http://schemas.openxmlformats.org/drawingml/2006/main" xmlns:p="http://schemas.openxmlformats.org/presentationml/2006/main" xmlns:r="http://schemas.openxmlformats.org/officeDocument/2006/relationships">
   <p:cSld>
     <p:spTree>
@@ -12060,7 +14132,7 @@
                 </a:solidFill>
                 <a:latin typeface="Arial"/>
               </a:rPr>
-              <a:t>The telescope of record</a:t>
+              <a:t>The telescope so far: three off-axis aspheres</a:t>
             </a:r>
           </a:p>
           <a:p>
@@ -12076,7 +14148,7 @@
                 </a:solidFill>
                 <a:latin typeface="Arial"/>
               </a:rPr>
-              <a:t>f = 330 mm, 183 mm aperture, F/1.8: an unobscured section of a three-mirror parent, M3 ahead of the intermediate focus so the exit pupil sits at infinity, as the Dyson requires</a:t>
+              <a:t>f = 330 mm, 183 mm aperture, F/1.8: an unobscured section of a three-mirror parent, M3 ahead of the intermediate focus so the exit pupil sits at infinity, as the Dyson requires; a first design that reaches the pixel, not a finished one</a:t>
             </a:r>
           </a:p>
         </p:txBody>
@@ -12876,6 +14948,22 @@
                 <a:latin typeface="Arial"/>
               </a:rPr>
               <a:t>•  Image as placed: 8 µm rms at the strip center, 14 µm at the ±2.3° edge (0.4 / 0.8 pixel); every field admitted; the strip's chief rays within 0.5° of each other at the slit.</a:t>
+            </a:r>
+          </a:p>
+          <a:p>
+            <a:pPr>
+              <a:spcAft>
+                <a:spcPts val="600"/>
+              </a:spcAft>
+            </a:pPr>
+            <a:r>
+              <a:rPr sz="1200" b="0">
+                <a:solidFill>
+                  <a:srgbClr val="282828"/>
+                </a:solidFill>
+                <a:latin typeface="Arial"/>
+              </a:rPr>
+              <a:t>•  Not done: the strip ends sit at 0.8 px (0.3–0.5 of the energy in a pixel through the Dyson); M1 departs 2.1 mm from its best-fit sphere and M3 is tilted 6.6°; no tolerancing, no coatings, no stray-light or mirror sizing; the solve ran to a fixed budget and is not converged.  Help in bringing it home is one of the asks (slide 11).</a:t>
             </a:r>
           </a:p>
         </p:txBody>
@@ -12977,7 +15065,7 @@
                 </a:solidFill>
                 <a:latin typeface="Arial"/>
               </a:rPr>
-              <a:t>Radii are |R|; vertex z along the parent axis in the prescription's frame; the h⁴/h⁶ terms are about each mirror's own vertex and axis.  Prescription dyson5_tA_GM_1k5_bAs.in; solve record dyson5_tA_GM_1k5_bAs.txt.  How it was reached: Backup.</a:t>
+              <a:t>Radii are |R|; vertex z along the parent axis in the prescription's frame; the h⁴/h⁶ terms are about each mirror's own vertex and axis.  Prescription dyson5_tA_GM_1k5_bAs.in; solve record dyson5_tA_GM_1k5_bAs.txt.  How it was reached, and the forms that did not work: Backup.</a:t>
             </a:r>
           </a:p>
         </p:txBody>
@@ -12990,7 +15078,7 @@
 </p:sld>
 </file>
 
-<file path=ppt/slides/slide6.xml><?xml version="1.0" encoding="utf-8"?>
+<file path=ppt/slides/slide7.xml><?xml version="1.0" encoding="utf-8"?>
 <p:sld xmlns:a="http://schemas.openxmlformats.org/drawingml/2006/main" xmlns:p="http://schemas.openxmlformats.org/presentationml/2006/main" xmlns:r="http://schemas.openxmlformats.org/officeDocument/2006/relationships">
   <p:cSld>
     <p:spTree>
@@ -13280,7 +15368,7 @@
 </p:sld>
 </file>
 
-<file path=ppt/slides/slide7.xml><?xml version="1.0" encoding="utf-8"?>
+<file path=ppt/slides/slide8.xml><?xml version="1.0" encoding="utf-8"?>
 <p:sld xmlns:a="http://schemas.openxmlformats.org/drawingml/2006/main" xmlns:p="http://schemas.openxmlformats.org/presentationml/2006/main" xmlns:r="http://schemas.openxmlformats.org/officeDocument/2006/relationships">
   <p:cSld>
     <p:spTree>
@@ -14095,7 +16183,7 @@
                           </a:solidFill>
                           <a:latin typeface="Arial"/>
                         </a:rPr>
-                        <a:t>telescope of record</a:t>
+                        <a:t>telescope so far</a:t>
                       </a:r>
                     </a:p>
                   </a:txBody>
@@ -14139,7 +16227,7 @@
                           </a:solidFill>
                           <a:latin typeface="Arial"/>
                         </a:rPr>
-                        <a:t>three off-axis aspheres (slide 5)</a:t>
+                        <a:t>three off-axis aspheres (slide 6)</a:t>
                       </a:r>
                     </a:p>
                   </a:txBody>
@@ -14392,7 +16480,7 @@
                 </a:solidFill>
                 <a:latin typeface="Arial"/>
               </a:rPr>
-              <a:t>Carve = a cylinder of clear aperture + 20 mm by thickness + 20 mm; CaF2 is not priced here.  A cold detector adds a dewar window to every row alike; cementing it to the block keeps the count at four.  The 3k telescope is the freeform solve of 2026-10-05, scored before its next layout step (slide 8).  Records dyson5_jim_3a.txt, dyson5_t5f_GM_1k5_bAs.txt, dyson5_t5f_GM_3k_c.txt.</a:t>
+              <a:t>Carve = a cylinder of clear aperture + 20 mm by thickness + 20 mm; CaF2 is not priced here.  A cold detector adds a dewar window to every row alike; cementing it to the block keeps the count at four.  The 3k telescope is the freeform solve of 2026-10-05, scored before its next layout step (slide 9).  Records dyson5_jim_3a.txt, dyson5_t5f_GM_1k5_bAs.txt, dyson5_t5f_GM_3k_c.txt.</a:t>
             </a:r>
           </a:p>
         </p:txBody>
@@ -14405,7 +16493,7 @@
 </p:sld>
 </file>
 
-<file path=ppt/slides/slide8.xml><?xml version="1.0" encoding="utf-8"?>
+<file path=ppt/slides/slide9.xml><?xml version="1.0" encoding="utf-8"?>
 <p:sld xmlns:a="http://schemas.openxmlformats.org/drawingml/2006/main" xmlns:p="http://schemas.openxmlformats.org/presentationml/2006/main" xmlns:r="http://schemas.openxmlformats.org/officeDocument/2006/relationships">
   <p:cSld>
     <p:spTree>
@@ -14730,217 +16818,6 @@
                 <a:latin typeface="Arial"/>
               </a:rPr>
               <a:t>Record dyson5_t5f_GM_3k_c.txt; prescription dyson5_t5f_GM_3k_c_e2e.in.  The 3k solve ran to the same evaluation budget as the 1.5k and is not converged in the optimizer's sense.</a:t>
-            </a:r>
-          </a:p>
-        </p:txBody>
-      </p:sp>
-    </p:spTree>
-  </p:cSld>
-  <p:clrMapOvr>
-    <a:masterClrMapping/>
-  </p:clrMapOvr>
-</p:sld>
-</file>
-
-<file path=ppt/slides/slide9.xml><?xml version="1.0" encoding="utf-8"?>
-<p:sld xmlns:a="http://schemas.openxmlformats.org/drawingml/2006/main" xmlns:p="http://schemas.openxmlformats.org/presentationml/2006/main" xmlns:r="http://schemas.openxmlformats.org/officeDocument/2006/relationships">
-  <p:cSld>
-    <p:spTree>
-      <p:nvGrpSpPr>
-        <p:cNvPr id="1" name=""/>
-        <p:cNvGrpSpPr/>
-        <p:nvPr/>
-      </p:nvGrpSpPr>
-      <p:grpSpPr/>
-      <p:sp>
-        <p:nvSpPr>
-          <p:cNvPr id="2" name="TextBox 1"/>
-          <p:cNvSpPr txBox="1"/>
-          <p:nvPr/>
-        </p:nvSpPr>
-        <p:spPr>
-          <a:xfrm>
-            <a:off x="411480" y="201168"/>
-            <a:ext cx="11368735" cy="914400"/>
-          </a:xfrm>
-          <a:prstGeom prst="rect">
-            <a:avLst/>
-          </a:prstGeom>
-          <a:noFill/>
-        </p:spPr>
-        <p:txBody>
-          <a:bodyPr wrap="square">
-            <a:spAutoFit/>
-          </a:bodyPr>
-          <a:lstStyle/>
-          <a:p>
-            <a:pPr>
-              <a:spcAft>
-                <a:spcPts val="400"/>
-              </a:spcAft>
-            </a:pPr>
-            <a:r>
-              <a:rPr sz="2400" b="1">
-                <a:solidFill>
-                  <a:srgbClr val="1F4E79"/>
-                </a:solidFill>
-                <a:latin typeface="Arial"/>
-              </a:rPr>
-              <a:t>Questions for Jim</a:t>
-            </a:r>
-          </a:p>
-          <a:p>
-            <a:pPr>
-              <a:spcAft>
-                <a:spcPts val="0"/>
-              </a:spcAft>
-            </a:pPr>
-            <a:r>
-              <a:rPr sz="1250" b="0">
-                <a:solidFill>
-                  <a:srgbClr val="6E6E6E"/>
-                </a:solidFill>
-                <a:latin typeface="Arial"/>
-              </a:rPr>
-              <a:t>Two decisions the ray trace cannot make</a:t>
-            </a:r>
-          </a:p>
-        </p:txBody>
-      </p:sp>
-      <p:sp>
-        <p:nvSpPr>
-          <p:cNvPr id="3" name="Rectangle 2"/>
-          <p:cNvSpPr/>
-          <p:nvPr/>
-        </p:nvSpPr>
-        <p:spPr>
-          <a:xfrm>
-            <a:off x="411480" y="1133856"/>
-            <a:ext cx="11368735" cy="20320"/>
-          </a:xfrm>
-          <a:prstGeom prst="rect">
-            <a:avLst/>
-          </a:prstGeom>
-          <a:solidFill>
-            <a:srgbClr val="B8C6D4"/>
-          </a:solidFill>
-          <a:ln>
-            <a:noFill/>
-          </a:ln>
-          <a:effectLst/>
-        </p:spPr>
-        <p:style>
-          <a:lnRef idx="1">
-            <a:schemeClr val="accent1"/>
-          </a:lnRef>
-          <a:fillRef idx="3">
-            <a:schemeClr val="accent1"/>
-          </a:fillRef>
-          <a:effectRef idx="2">
-            <a:schemeClr val="accent1"/>
-          </a:effectRef>
-          <a:fontRef idx="minor">
-            <a:schemeClr val="lt1"/>
-          </a:fontRef>
-        </p:style>
-        <p:txBody>
-          <a:bodyPr rtlCol="0" anchor="ctr"/>
-          <a:lstStyle/>
-          <a:p>
-            <a:pPr algn="ctr"/>
-          </a:p>
-        </p:txBody>
-      </p:sp>
-      <p:sp>
-        <p:nvSpPr>
-          <p:cNvPr id="4" name="TextBox 3"/>
-          <p:cNvSpPr txBox="1"/>
-          <p:nvPr/>
-        </p:nvSpPr>
-        <p:spPr>
-          <a:xfrm>
-            <a:off x="411480" y="1298448"/>
-            <a:ext cx="11368735" cy="274320"/>
-          </a:xfrm>
-          <a:prstGeom prst="rect">
-            <a:avLst/>
-          </a:prstGeom>
-          <a:noFill/>
-        </p:spPr>
-        <p:txBody>
-          <a:bodyPr wrap="square">
-            <a:spAutoFit/>
-          </a:bodyPr>
-          <a:lstStyle/>
-          <a:p>
-            <a:pPr>
-              <a:spcAft>
-                <a:spcPts val="600"/>
-              </a:spcAft>
-            </a:pPr>
-            <a:r>
-              <a:rPr sz="1500" b="0">
-                <a:solidFill>
-                  <a:srgbClr val="282828"/>
-                </a:solidFill>
-                <a:latin typeface="Arial"/>
-              </a:rPr>
-              <a:t>•  Two modules or four.  The 1.5k module now has a telescope of record at the pixel end to end (slides 4–5); the 3k module does not yet (slide 8).  At the same 6000 cross-track pixels, four telescopes, spectrometers and detectors in 6.6 kg of fused silica against two in 28.5 kg of CaF2: is four a packaging the project would entertain?</a:t>
-            </a:r>
-          </a:p>
-          <a:p>
-            <a:pPr>
-              <a:spcAft>
-                <a:spcPts val="600"/>
-              </a:spcAft>
-            </a:pPr>
-            <a:r>
-              <a:rPr sz="1500" b="0">
-                <a:solidFill>
-                  <a:srgbClr val="282828"/>
-                </a:solidFill>
-                <a:latin typeface="Arial"/>
-              </a:rPr>
-              <a:t>•  The CaF2 volume.  Two 240 mm blocks need 12.4 L of single-crystal CaF2 to carve from (6.2 L each, clear aperture + 20 mm each way; 19.6 L at the 300 mm blocks that put all the energy in a pixel).  What does that cost against two to four fused-silica blocks of 0.75 L?</a:t>
-            </a:r>
-          </a:p>
-        </p:txBody>
-      </p:sp>
-      <p:sp>
-        <p:nvSpPr>
-          <p:cNvPr id="5" name="TextBox 4"/>
-          <p:cNvSpPr txBox="1"/>
-          <p:nvPr/>
-        </p:nvSpPr>
-        <p:spPr>
-          <a:xfrm>
-            <a:off x="411480" y="3101340"/>
-            <a:ext cx="11368735" cy="274320"/>
-          </a:xfrm>
-          <a:prstGeom prst="rect">
-            <a:avLst/>
-          </a:prstGeom>
-          <a:noFill/>
-        </p:spPr>
-        <p:txBody>
-          <a:bodyPr wrap="square">
-            <a:spAutoFit/>
-          </a:bodyPr>
-          <a:lstStyle/>
-          <a:p>
-            <a:pPr>
-              <a:spcAft>
-                <a:spcPts val="600"/>
-              </a:spcAft>
-            </a:pPr>
-            <a:r>
-              <a:rPr sz="1050" b="0">
-                <a:solidFill>
-                  <a:srgbClr val="6E6E6E"/>
-                </a:solidFill>
-                <a:latin typeface="Arial"/>
-              </a:rPr>
-              <a:t>Also open from the last round: whether the detector window is cemented to the block in the builds (six crossings and 0.81 uncoated, against four and 0.87).</a:t>
             </a:r>
           </a:p>
         </p:txBody>

</xml_diff>

<commit_message>
deck_dyson_record: the F/1.8 Offner result recorded on the alternatives slide (out: spectral blur 7-9 px at every R; best point R 0.5 m, CRF 2.24 px); the clearance-gate finding as the fifth row of the section findings
Co-Authored-By: Claude Fable 5.1 <noreply@anthropic.com>
</commit_message>
<xml_diff>
--- a/demo_session/deck_dyson_record.pptx
+++ b/demo_session/deck_dyson_record.pptx
@@ -4767,7 +4767,7 @@
                 </a:solidFill>
                 <a:latin typeface="Arial"/>
               </a:rPr>
-              <a:t>The Dyson was assumed for this challenge; at a 54 mm slit the literature offers three other forms, and the record's own result points at a fourth</a:t>
+              <a:t>The Dyson was assumed for this challenge; the literature offers three other forms at a 54 mm slit, and the record's own result points at a fourth; the Offner was tried at F/1.8 and is out</a:t>
             </a:r>
           </a:p>
         </p:txBody>
@@ -4850,7 +4850,7 @@
                 </a:solidFill>
                 <a:latin typeface="Arial"/>
               </a:rPr>
-              <a:t>•  The Offner (concave sphere used twice, convex grating at the stop).  All-reflective: no CaF2, no air-glass crossings, every leg in air, so a cold shield costs nothing.  The review's long-slit example is F/2.8 with a 48 mm slit at 30 µm pixels (smile 0.3 %, keystone 2 % of a pixel, 0.76 in a pixel).  The record's Offner at F/2.8 and 0.22 R, with the classical corrections, reaches keystone 0.028 px and CRF 1.20 px but SRF 3.69 px and 0.23 in a pixel; an F/1.8 Offner at a 54 mm slit has not been tried here.</a:t>
+              <a:t>•  The Offner (concave sphere used twice, convex grating at the stop): tried at F/1.8 and 54 mm, out.  All-reflective, no CaF2, no air-glass crossings, a cold shield for free; the review's long-slit example is F/2.8, 48 mm, 30 µm pixels.  At F/1.8 the grating is 0.28 R across and the slit must sit at 0.29–0.32 R to pass beside it.  With the classical corrections and the ring free, the best point (R = 0.5 m, 0.5 m long, 4.8 kg of blanks) reaches smile 0.17, keystone 0.18 and CRF 2.24 px, but the spectral blur is 7–9 px rms at every R to 1.25 m: an aberration along the dispersion the corrections do not touch (3–6 px, wavelength-independent) plus the grating's term at F/1.8 (+2–4 px by 2500 nm).  Energy in a pixel 0.01.  The next form of that family is the Offner–Chrisp (a third mirror), not tried.</a:t>
             </a:r>
           </a:p>
           <a:p>
@@ -4937,7 +4937,7 @@
                 </a:solidFill>
                 <a:latin typeface="Arial"/>
               </a:rPr>
-              <a:t>•  What the ray trace can settle quickly: the Offner has a layout solver in the chain (offner_solve), so an F/1.8, 54 mm Offner can be laid out, emitted and scored on the same scorer in about a day; the prism Dyson needs a dispersing prism added to the chain first (the engine traces it already).  Which is worth the time is a question for Jim and Joe.</a:t>
+              <a:t>•  What the ray trace can settle next: the prism Dyson needs a dispersing prism added to the layout chain (the engine traces one already); the Offner–Chrisp needs a three-mirror layout solver.  Each is a few days; whether either is worth it is a question for Jim and Joe.</a:t>
             </a:r>
           </a:p>
         </p:txBody>
@@ -4950,7 +4950,7 @@
         </p:nvSpPr>
         <p:spPr>
           <a:xfrm>
-            <a:off x="6400800" y="3596639"/>
+            <a:off x="6400800" y="3398519"/>
             <a:ext cx="5394960" cy="274320"/>
           </a:xfrm>
           <a:prstGeom prst="rect">
@@ -4976,7 +4976,7 @@
                 </a:solidFill>
                 <a:latin typeface="Arial"/>
               </a:rPr>
-              <a:t>Review: Mouroulis &amp; Green, Opt. Eng. 57(4) 040901 (2018), Table 2 and Table 5.  The Offner numbers are the record's dyson5_s1_offner (dyson5_s2.txt).  Nothing on this slide has been traced at the 3k slit except the Dyson rows of slide 10.</a:t>
+              <a:t>Review: Mouroulis &amp; Green, Opt. Eng. 57(4) 040901 (2018), Table 2 and Table 5.  Offner at F/1.8: dyson5_off18.txt, BRIEF_dyson5_jim.md 3c (seed, fixed-ring and free-ring rows at R = 0.5–1.25 m; mass as 10 mm Zerodur blanks).  The prism Dyson and the Offner–Chrisp are not traced here.</a:t>
             </a:r>
           </a:p>
         </p:txBody>
@@ -9273,7 +9273,7 @@
                 </a:solidFill>
                 <a:latin typeface="Arial"/>
               </a:rPr>
-              <a:t>•  16 Backup: how the telescope reached the pixel; the Dyson design ladder; the 54 mm design; the block-size trade; the methods and the checks; twelve engine findings; records</a:t>
+              <a:t>•  16 Backup: how the telescope reached the pixel; the Dyson design ladder; the 54 mm design; the block-size trade; the methods and the checks; thirteen engine findings; records</a:t>
             </a:r>
           </a:p>
         </p:txBody>
@@ -11601,7 +11601,7 @@
                 </a:solidFill>
                 <a:latin typeface="Arial"/>
               </a:rPr>
-              <a:t>Four more findings from the telescope's eccentric section</a:t>
+              <a:t>Five more findings from the telescope's eccentric section and the Offner</a:t>
             </a:r>
           </a:p>
           <a:p>
@@ -11617,7 +11617,7 @@
                 </a:solidFill>
                 <a:latin typeface="Arial"/>
               </a:rPr>
-              <a:t>Found 2026-10-04 to 10-05, each invisible on a coaxial design, each fixed the same day</a:t>
+              <a:t>Found 2026-10-04 to 10-06, each invisible on the designs before it, each fixed the same day</a:t>
             </a:r>
           </a:p>
         </p:txBody>
@@ -11676,7 +11676,7 @@
         </p:nvGraphicFramePr>
         <p:xfrm>
           <a:off x="411480" y="1298448"/>
-          <a:ext cx="11368734" cy="2154555"/>
+          <a:ext cx="11368734" cy="2811780"/>
         </p:xfrm>
         <a:graphic>
           <a:graphicData uri="http://schemas.openxmlformats.org/drawingml/2006/table">
@@ -11685,9 +11685,9 @@
                 <a:tableStyleId>{5C22544A-7EE6-4342-B048-85BDC9FD1C3A}</a:tableStyleId>
               </a:tblPr>
               <a:tblGrid>
-                <a:gridCol w="1894789"/>
-                <a:gridCol w="5581946"/>
-                <a:gridCol w="3891999"/>
+                <a:gridCol w="1551815"/>
+                <a:gridCol w="5667500"/>
+                <a:gridCol w="4149419"/>
               </a:tblGrid>
               <a:tr h="280035">
                 <a:tc>
@@ -12025,6 +12025,74 @@
                   <a:tcPr marL="54864" marR="54864" marT="18288" marB="18288">
                     <a:solidFill>
                       <a:srgbClr val="ECF1F6"/>
+                    </a:solidFill>
+                  </a:tcPr>
+                </a:tc>
+              </a:tr>
+              <a:tr h="657225">
+                <a:tc>
+                  <a:txBody>
+                    <a:bodyPr wrap="square"/>
+                    <a:lstStyle/>
+                    <a:p>
+                      <a:r>
+                        <a:rPr sz="1100" b="0">
+                          <a:solidFill>
+                            <a:srgbClr val="282828"/>
+                          </a:solidFill>
+                          <a:latin typeface="Arial"/>
+                        </a:rPr>
+                        <a:t>clearance check blind to a beam through a disc</a:t>
+                      </a:r>
+                    </a:p>
+                  </a:txBody>
+                  <a:tcPr marL="54864" marR="54864" marT="18288" marB="18288">
+                    <a:solidFill>
+                      <a:srgbClr val="FFFFFF"/>
+                    </a:solidFill>
+                  </a:tcPr>
+                </a:tc>
+                <a:tc>
+                  <a:txBody>
+                    <a:bodyPr wrap="square"/>
+                    <a:lstStyle/>
+                    <a:p>
+                      <a:r>
+                        <a:rPr sz="1100" b="0">
+                          <a:solidFill>
+                            <a:srgbClr val="282828"/>
+                          </a:solidFill>
+                          <a:latin typeface="Arial"/>
+                        </a:rPr>
+                        <a:t>the check measured distance to body samples, which cannot go negative for a mirror or grating disc: an F/1.8 Offner beam through its grating read +0.2 mm (it is −33 mm)</a:t>
+                      </a:r>
+                    </a:p>
+                  </a:txBody>
+                  <a:tcPr marL="54864" marR="54864" marT="18288" marB="18288">
+                    <a:solidFill>
+                      <a:srgbClr val="FFFFFF"/>
+                    </a:solidFill>
+                  </a:tcPr>
+                </a:tc>
+                <a:tc>
+                  <a:txBody>
+                    <a:bodyPr wrap="square"/>
+                    <a:lstStyle/>
+                    <a:p>
+                      <a:r>
+                        <a:rPr sz="1100" b="0">
+                          <a:solidFill>
+                            <a:srgbClr val="282828"/>
+                          </a:solidFill>
+                          <a:latin typeface="Arial"/>
+                        </a:rPr>
+                        <a:t>every beam segment is tested against the surface inside its aperture and mount; all 54 Dyson records re-check bit-identical</a:t>
+                      </a:r>
+                    </a:p>
+                  </a:txBody>
+                  <a:tcPr marL="54864" marR="54864" marT="18288" marB="18288">
+                    <a:solidFill>
+                      <a:srgbClr val="FFFFFF"/>
                     </a:solidFill>
                   </a:tcPr>
                 </a:tc>
@@ -12041,7 +12109,7 @@
         </p:nvSpPr>
         <p:spPr>
           <a:xfrm>
-            <a:off x="411480" y="3599307"/>
+            <a:off x="411480" y="4256532"/>
             <a:ext cx="11368735" cy="274320"/>
           </a:xfrm>
           <a:prstGeom prst="rect">
@@ -12067,7 +12135,7 @@
                 </a:solidFill>
                 <a:latin typeface="Arial"/>
               </a:rPr>
-              <a:t>Tests: tFwdRoot (5), tAsphHook (3), tStopApStop (4), tFreeformPole (3).  Each of the four passed every existing check (rays passed, solves converged, decks loaded); what exposed them was a section whose beam is 190 mm from its parent's vertex.</a:t>
+              <a:t>Tests: tFwdRoot (5), tAsphHook (3), tStopApStop (4), tFreeformPole (3), tSpectrometerRx/test_clearance_sees_a_beam_through_a_body.  Each passed every existing check (rays passed, solves converged, decks loaded); what exposed the first four was a section whose beam is 190 mm from its parent's vertex, the fifth a form whose stop sits in its own beams.</a:t>
             </a:r>
           </a:p>
         </p:txBody>

</xml_diff>

<commit_message>
deck_dyson_record: Dave's second edit pass folded -- wording (title note, swath question as the hinge title, '3k Dyson module', four question bullets), 14 pt column bullets on five slides, the 3k slide's figure placements; every slide render-checked
Co-Authored-By: Claude Fable 5.1 <noreply@anthropic.com>
</commit_message>
<xml_diff>
--- a/demo_session/deck_dyson_record.pptx
+++ b/demo_session/deck_dyson_record.pptx
@@ -3232,7 +3232,7 @@
                 </a:solidFill>
                 <a:latin typeface="Arial"/>
               </a:rPr>
-              <a:t>DRAFT for review, 2026-10-06.  The 1.5k module (1500 cross-track pixels, a 27 mm slit) has a spectrometer of record and a first telescope that together image at the pixel end to end: smile 0.51, keystone 0.01, CRF 1.22, SRF 2.20 pixels, every clearance positive; four such modules carry 6000 pixels in 6.6 kg of fused silica.  The telescope is not finished and the 3k module's is not yet at the pixel (CRF 4.2 pixels); the deck asks Jim's help with both.</a:t>
+              <a:t>DRAFT for review, 2026-10-06.  The 1.5k module (1500 cross-track pixels, a 27 mm slit) has a spectrometer of record and a first telescope that together image at the pixel end to end: smile 0.51, keystone 0.01, CRF 1.22, SRF 2.20 pixels, every clearance positive; four such modules carry 6000 pixels in 6.6 kg of fused silica.  The telescope is not finished and the 3k module's resolution is not yet at the pixel level (CRF 4.2 pixels); the deck asks for help with both.</a:t>
             </a:r>
           </a:p>
         </p:txBody>
@@ -3289,7 +3289,7 @@
                 </a:solidFill>
                 <a:latin typeface="Arial"/>
               </a:rPr>
-              <a:t>Two of 3k in CaF2 or four of 1.5k in silica</a:t>
+              <a:t>To fill the swath: two of 3k pixels in CaF2 or four of 1.5k in silica?</a:t>
             </a:r>
           </a:p>
           <a:p>
@@ -4414,7 +4414,7 @@
                 </a:solidFill>
                 <a:latin typeface="Arial"/>
               </a:rPr>
-              <a:t>The 3k module: where it stands</a:t>
+              <a:t>The 3k Dyson module: where it stands</a:t>
             </a:r>
           </a:p>
           <a:p>
@@ -4495,8 +4495,8 @@
         </p:blipFill>
         <p:spPr>
           <a:xfrm>
-            <a:off x="1800791" y="1298448"/>
-            <a:ext cx="3027817" cy="2348992"/>
+            <a:off x="1828800" y="1298448"/>
+            <a:ext cx="4343400" cy="3364992"/>
           </a:xfrm>
           <a:prstGeom prst="rect">
             <a:avLst/>
@@ -4511,8 +4511,8 @@
         </p:nvSpPr>
         <p:spPr>
           <a:xfrm>
-            <a:off x="411480" y="3665727"/>
-            <a:ext cx="5806440" cy="394208"/>
+            <a:off x="411480" y="4572000"/>
+            <a:ext cx="6903720" cy="394208"/>
           </a:xfrm>
           <a:prstGeom prst="rect">
             <a:avLst/>
@@ -4550,8 +4550,8 @@
         </p:nvSpPr>
         <p:spPr>
           <a:xfrm>
-            <a:off x="411480" y="4096511"/>
-            <a:ext cx="5806440" cy="274320"/>
+            <a:off x="411480" y="5001768"/>
+            <a:ext cx="6903720" cy="274320"/>
           </a:xfrm>
           <a:prstGeom prst="rect">
             <a:avLst/>
@@ -4613,8 +4613,8 @@
         </p:blipFill>
         <p:spPr>
           <a:xfrm>
-            <a:off x="7199490" y="1298448"/>
-            <a:ext cx="3797579" cy="3372612"/>
+            <a:off x="7543800" y="1298448"/>
+            <a:ext cx="4233672" cy="3758184"/>
           </a:xfrm>
           <a:prstGeom prst="rect">
             <a:avLst/>
@@ -4629,8 +4629,8 @@
         </p:nvSpPr>
         <p:spPr>
           <a:xfrm>
-            <a:off x="6400800" y="4689348"/>
-            <a:ext cx="5394960" cy="559307"/>
+            <a:off x="7543800" y="5239512"/>
+            <a:ext cx="4343400" cy="559307"/>
           </a:xfrm>
           <a:prstGeom prst="rect">
             <a:avLst/>
@@ -4668,8 +4668,8 @@
         </p:nvSpPr>
         <p:spPr>
           <a:xfrm>
-            <a:off x="6400800" y="5285231"/>
-            <a:ext cx="5394960" cy="274320"/>
+            <a:off x="7543800" y="5833872"/>
+            <a:ext cx="4343400" cy="274320"/>
           </a:xfrm>
           <a:prstGeom prst="rect">
             <a:avLst/>
@@ -4844,7 +4844,7 @@
               </a:spcAft>
             </a:pPr>
             <a:r>
-              <a:rPr sz="1200" b="0">
+              <a:rPr sz="1400" b="0">
                 <a:solidFill>
                   <a:srgbClr val="282828"/>
                 </a:solidFill>
@@ -4860,7 +4860,7 @@
               </a:spcAft>
             </a:pPr>
             <a:r>
-              <a:rPr sz="1200" b="0">
+              <a:rPr sz="1400" b="0">
                 <a:solidFill>
                   <a:srgbClr val="282828"/>
                 </a:solidFill>
@@ -4876,7 +4876,7 @@
               </a:spcAft>
             </a:pPr>
             <a:r>
-              <a:rPr sz="1200" b="0">
+              <a:rPr sz="1400" b="0">
                 <a:solidFill>
                   <a:srgbClr val="282828"/>
                 </a:solidFill>
@@ -4915,7 +4915,7 @@
               </a:spcAft>
             </a:pPr>
             <a:r>
-              <a:rPr sz="1200" b="0">
+              <a:rPr sz="1400" b="0">
                 <a:solidFill>
                   <a:srgbClr val="282828"/>
                 </a:solidFill>
@@ -4931,7 +4931,7 @@
               </a:spcAft>
             </a:pPr>
             <a:r>
-              <a:rPr sz="1200" b="0">
+              <a:rPr sz="1400" b="0">
                 <a:solidFill>
                   <a:srgbClr val="282828"/>
                 </a:solidFill>
@@ -4950,7 +4950,7 @@
         </p:nvSpPr>
         <p:spPr>
           <a:xfrm>
-            <a:off x="6400800" y="3398519"/>
+            <a:off x="6400800" y="4157979"/>
             <a:ext cx="5394960" cy="274320"/>
           </a:xfrm>
           <a:prstGeom prst="rect">
@@ -5132,7 +5132,7 @@
                 </a:solidFill>
                 <a:latin typeface="Arial"/>
               </a:rPr>
-              <a:t>•  Two modules or four.  The 1.5k module now has a telescope at the pixel end to end (slides 6–8); the 3k module does not yet (slide 11).  At the same 6000 cross-track pixels, four telescopes, spectrometers and detectors in 6.6 kg of fused silica against two in 28.5 kg of CaF2: is four a packaging the project would entertain?</a:t>
+              <a:t>•  Are four modules acceptable?  The 1.5k module now has a telescope at the pixel end to end (slides 6–8); the 3k module does not yet (slide 11).  At the same 6000 cross-track pixels, four telescopes, spectrometers and detectors in 6.6 kg of fused silica against two in 28.5 kg of CaF2: is four a packaging the project would entertain?</a:t>
             </a:r>
           </a:p>
           <a:p>
@@ -5148,7 +5148,7 @@
                 </a:solidFill>
                 <a:latin typeface="Arial"/>
               </a:rPr>
-              <a:t>•  The CaF2 volume.  Two 240 mm blocks need 12.4 L of single-crystal CaF2 to carve from (6.2 L each, clear aperture + 20 mm each way; 19.6 L at the 300 mm blocks that put all the energy in a pixel).  What does that cost against two to four fused-silica blocks of 0.75 L?</a:t>
+              <a:t>•  Is CaF2 a realistic option for the 3,000 option?  Two 240 mm blocks need 12.4 L of single-crystal CaF2 to carve from (6.2 L each, clear aperture + 20 mm each way; 19.6 L at the 300 mm blocks that put all the energy in a pixel).  What does that cost against two to four fused-silica blocks of 0.75 L?</a:t>
             </a:r>
           </a:p>
           <a:p>
@@ -5164,7 +5164,23 @@
                 </a:solidFill>
                 <a:latin typeface="Arial"/>
               </a:rPr>
-              <a:t>•  The telescope, and the tricks.  The telescope is a first design: the strip ends at 0.8 px, 2 mm of aspheric departure on M1, no tolerancing.  Help in bringing it home is asked for: the forms that have worked at 183 mm, F/1.8 and a 4.7–9.4° strip into a telecentric slit; and, more generally, the tricks for throughput (beyond cementing the window and a two-layer coating, 0.81 → 0.91) and for performance that the public record does not show.</a:t>
+              <a:t>•  The telescope is a first design, and does not meet all inferred requirements: the strip ends at 0.8 px, 2 mm of aspheric departure on M1, no tolerancing.</a:t>
+            </a:r>
+          </a:p>
+          <a:p>
+            <a:pPr>
+              <a:spcAft>
+                <a:spcPts val="600"/>
+              </a:spcAft>
+            </a:pPr>
+            <a:r>
+              <a:rPr sz="1500" b="0">
+                <a:solidFill>
+                  <a:srgbClr val="282828"/>
+                </a:solidFill>
+                <a:latin typeface="Arial"/>
+              </a:rPr>
+              <a:t>•  We ask for help in bringing it home: What telescope forms have worked at 183 mm, F/1.8 and a 4.7–9.4° strip into a telecentric slit?  More generally, what are we missing, for throughput (beyond cementing the window and a two-layer coating, 0.81 → 0.91) and for performance that the public record does not show?</a:t>
             </a:r>
           </a:p>
         </p:txBody>
@@ -5177,7 +5193,7 @@
         </p:nvSpPr>
         <p:spPr>
           <a:xfrm>
-            <a:off x="411480" y="4232148"/>
+            <a:off x="411480" y="4620006"/>
             <a:ext cx="11368735" cy="274320"/>
           </a:xfrm>
           <a:prstGeom prst="rect">
@@ -5353,7 +5369,7 @@
               </a:spcAft>
             </a:pPr>
             <a:r>
-              <a:rPr sz="1200" b="0">
+              <a:rPr sz="1400" b="0">
                 <a:solidFill>
                   <a:srgbClr val="282828"/>
                 </a:solidFill>
@@ -5369,7 +5385,7 @@
               </a:spcAft>
             </a:pPr>
             <a:r>
-              <a:rPr sz="1200" b="0">
+              <a:rPr sz="1400" b="0">
                 <a:solidFill>
                   <a:srgbClr val="282828"/>
                 </a:solidFill>
@@ -5385,7 +5401,7 @@
               </a:spcAft>
             </a:pPr>
             <a:r>
-              <a:rPr sz="1200" b="0">
+              <a:rPr sz="1400" b="0">
                 <a:solidFill>
                   <a:srgbClr val="282828"/>
                 </a:solidFill>
@@ -5424,7 +5440,7 @@
               </a:spcAft>
             </a:pPr>
             <a:r>
-              <a:rPr sz="1200" b="0">
+              <a:rPr sz="1400" b="0">
                 <a:solidFill>
                   <a:srgbClr val="282828"/>
                 </a:solidFill>
@@ -5440,7 +5456,7 @@
               </a:spcAft>
             </a:pPr>
             <a:r>
-              <a:rPr sz="1200" b="0">
+              <a:rPr sz="1400" b="0">
                 <a:solidFill>
                   <a:srgbClr val="282828"/>
                 </a:solidFill>
@@ -9036,7 +9052,7 @@
               </a:spcAft>
             </a:pPr>
             <a:r>
-              <a:rPr sz="1200" b="0">
+              <a:rPr sz="1400" b="0">
                 <a:solidFill>
                   <a:srgbClr val="282828"/>
                 </a:solidFill>
@@ -9052,7 +9068,7 @@
               </a:spcAft>
             </a:pPr>
             <a:r>
-              <a:rPr sz="1200" b="0">
+              <a:rPr sz="1400" b="0">
                 <a:solidFill>
                   <a:srgbClr val="282828"/>
                 </a:solidFill>
@@ -9068,7 +9084,7 @@
               </a:spcAft>
             </a:pPr>
             <a:r>
-              <a:rPr sz="1200" b="0">
+              <a:rPr sz="1400" b="0">
                 <a:solidFill>
                   <a:srgbClr val="282828"/>
                 </a:solidFill>
@@ -9084,7 +9100,7 @@
               </a:spcAft>
             </a:pPr>
             <a:r>
-              <a:rPr sz="1200" b="0">
+              <a:rPr sz="1400" b="0">
                 <a:solidFill>
                   <a:srgbClr val="282828"/>
                 </a:solidFill>
@@ -9100,7 +9116,7 @@
               </a:spcAft>
             </a:pPr>
             <a:r>
-              <a:rPr sz="1200" b="0">
+              <a:rPr sz="1400" b="0">
                 <a:solidFill>
                   <a:srgbClr val="282828"/>
                 </a:solidFill>
@@ -9116,7 +9132,7 @@
               </a:spcAft>
             </a:pPr>
             <a:r>
-              <a:rPr sz="1200" b="0">
+              <a:rPr sz="1400" b="0">
                 <a:solidFill>
                   <a:srgbClr val="282828"/>
                 </a:solidFill>
@@ -9155,7 +9171,7 @@
               </a:spcAft>
             </a:pPr>
             <a:r>
-              <a:rPr sz="1200" b="0">
+              <a:rPr sz="1400" b="0">
                 <a:solidFill>
                   <a:srgbClr val="282828"/>
                 </a:solidFill>
@@ -9171,13 +9187,13 @@
               </a:spcAft>
             </a:pPr>
             <a:r>
-              <a:rPr sz="1200" b="0">
+              <a:rPr sz="1400" b="0">
                 <a:solidFill>
                   <a:srgbClr val="282828"/>
                 </a:solidFill>
                 <a:latin typeface="Arial"/>
               </a:rPr>
-              <a:t>•  10 Two of 3k in CaF2 or four of 1.5k in silica</a:t>
+              <a:t>•  10 To fill the swath: two of 3k pixels in CaF2 or four of 1.5k in silica?</a:t>
             </a:r>
           </a:p>
           <a:p>
@@ -9187,13 +9203,13 @@
               </a:spcAft>
             </a:pPr>
             <a:r>
-              <a:rPr sz="1200" b="0">
+              <a:rPr sz="1400" b="0">
                 <a:solidFill>
                   <a:srgbClr val="282828"/>
                 </a:solidFill>
                 <a:latin typeface="Arial"/>
               </a:rPr>
-              <a:t>•  11 The 3k module: where it stands</a:t>
+              <a:t>•  11 The 3k Dyson module: where it stands</a:t>
             </a:r>
           </a:p>
           <a:p>
@@ -9203,7 +9219,7 @@
               </a:spcAft>
             </a:pPr>
             <a:r>
-              <a:rPr sz="1200" b="0">
+              <a:rPr sz="1400" b="0">
                 <a:solidFill>
                   <a:srgbClr val="282828"/>
                 </a:solidFill>
@@ -9219,7 +9235,7 @@
               </a:spcAft>
             </a:pPr>
             <a:r>
-              <a:rPr sz="1200" b="0">
+              <a:rPr sz="1400" b="0">
                 <a:solidFill>
                   <a:srgbClr val="282828"/>
                 </a:solidFill>
@@ -9235,7 +9251,7 @@
               </a:spcAft>
             </a:pPr>
             <a:r>
-              <a:rPr sz="1200" b="0">
+              <a:rPr sz="1400" b="0">
                 <a:solidFill>
                   <a:srgbClr val="282828"/>
                 </a:solidFill>
@@ -9251,7 +9267,7 @@
               </a:spcAft>
             </a:pPr>
             <a:r>
-              <a:rPr sz="1200" b="0">
+              <a:rPr sz="1400" b="0">
                 <a:solidFill>
                   <a:srgbClr val="282828"/>
                 </a:solidFill>
@@ -9267,7 +9283,7 @@
               </a:spcAft>
             </a:pPr>
             <a:r>
-              <a:rPr sz="1200" b="0">
+              <a:rPr sz="1400" b="0">
                 <a:solidFill>
                   <a:srgbClr val="282828"/>
                 </a:solidFill>
@@ -14068,7 +14084,7 @@
               </a:spcAft>
             </a:pPr>
             <a:r>
-              <a:rPr sz="1200" b="0">
+              <a:rPr sz="1400" b="0">
                 <a:solidFill>
                   <a:srgbClr val="282828"/>
                 </a:solidFill>
@@ -14084,7 +14100,7 @@
               </a:spcAft>
             </a:pPr>
             <a:r>
-              <a:rPr sz="1200" b="0">
+              <a:rPr sz="1400" b="0">
                 <a:solidFill>
                   <a:srgbClr val="282828"/>
                 </a:solidFill>
@@ -14100,7 +14116,7 @@
               </a:spcAft>
             </a:pPr>
             <a:r>
-              <a:rPr sz="1200" b="0">
+              <a:rPr sz="1400" b="0">
                 <a:solidFill>
                   <a:srgbClr val="282828"/>
                 </a:solidFill>

</xml_diff>

<commit_message>
make_brief_slides: bold runs from **lead-in** markers (DECK_STYLE), subscript digits in CaF2/SiO2/MgF2/Al2O3/Ta2O5 in text and table cells, per-block paragraph spacing ('sa') and caption alignment ('cal') from the sidecar -- Dave's 2026-10-06 edit pass; deck_dyson_record rebuilt with them
Co-Authored-By: Claude Fable 5.1 <noreply@anthropic.com>
</commit_message>
<xml_diff>
--- a/demo_session/deck_dyson_record.pptx
+++ b/demo_session/deck_dyson_record.pptx
@@ -3289,7 +3289,34 @@
                 </a:solidFill>
                 <a:latin typeface="Arial"/>
               </a:rPr>
-              <a:t>To fill the swath: two of 3k pixels in CaF2 or four of 1.5k in silica?</a:t>
+              <a:t>To fill the swath: two of 3k pixels in </a:t>
+            </a:r>
+            <a:r>
+              <a:rPr sz="2400" b="1">
+                <a:solidFill>
+                  <a:srgbClr val="1F4E79"/>
+                </a:solidFill>
+                <a:latin typeface="Arial"/>
+              </a:rPr>
+              <a:t>CaF</a:t>
+            </a:r>
+            <a:r>
+              <a:rPr sz="2400" b="1" baseline="-25000">
+                <a:solidFill>
+                  <a:srgbClr val="1F4E79"/>
+                </a:solidFill>
+                <a:latin typeface="Arial"/>
+              </a:rPr>
+              <a:t>2</a:t>
+            </a:r>
+            <a:r>
+              <a:rPr sz="2400" b="1">
+                <a:solidFill>
+                  <a:srgbClr val="1F4E79"/>
+                </a:solidFill>
+                <a:latin typeface="Arial"/>
+              </a:rPr>
+              <a:t> or four of 1.5k in silica?</a:t>
             </a:r>
           </a:p>
           <a:p>
@@ -3402,7 +3429,34 @@
                           </a:solidFill>
                           <a:latin typeface="Arial"/>
                         </a:rPr>
-                        <a:t>2 × CaF2, 3k, 54 mm slit</a:t>
+                        <a:t>2 × </a:t>
+                      </a:r>
+                      <a:r>
+                        <a:rPr sz="1100" b="1">
+                          <a:solidFill>
+                            <a:srgbClr val="FFFFFF"/>
+                          </a:solidFill>
+                          <a:latin typeface="Arial"/>
+                        </a:rPr>
+                        <a:t>CaF</a:t>
+                      </a:r>
+                      <a:r>
+                        <a:rPr sz="1100" b="1" baseline="-25000">
+                          <a:solidFill>
+                            <a:srgbClr val="FFFFFF"/>
+                          </a:solidFill>
+                          <a:latin typeface="Arial"/>
+                        </a:rPr>
+                        <a:t>2</a:t>
+                      </a:r>
+                      <a:r>
+                        <a:rPr sz="1100" b="1">
+                          <a:solidFill>
+                            <a:srgbClr val="FFFFFF"/>
+                          </a:solidFill>
+                          <a:latin typeface="Arial"/>
+                        </a:rPr>
+                        <a:t>, 3k, 54 mm slit</a:t>
                       </a:r>
                     </a:p>
                   </a:txBody>
@@ -3924,7 +3978,34 @@
                           </a:solidFill>
                           <a:latin typeface="Arial"/>
                         </a:rPr>
-                        <a:t>single-crystal CaF2 to carve from</a:t>
+                        <a:t>single-crystal </a:t>
+                      </a:r>
+                      <a:r>
+                        <a:rPr sz="1100" b="0">
+                          <a:solidFill>
+                            <a:srgbClr val="282828"/>
+                          </a:solidFill>
+                          <a:latin typeface="Arial"/>
+                        </a:rPr>
+                        <a:t>CaF</a:t>
+                      </a:r>
+                      <a:r>
+                        <a:rPr sz="1100" b="0" baseline="-25000">
+                          <a:solidFill>
+                            <a:srgbClr val="282828"/>
+                          </a:solidFill>
+                          <a:latin typeface="Arial"/>
+                        </a:rPr>
+                        <a:t>2</a:t>
+                      </a:r>
+                      <a:r>
+                        <a:rPr sz="1100" b="0">
+                          <a:solidFill>
+                            <a:srgbClr val="282828"/>
+                          </a:solidFill>
+                          <a:latin typeface="Arial"/>
+                        </a:rPr>
+                        <a:t> to carve from</a:t>
                       </a:r>
                     </a:p>
                   </a:txBody>
@@ -4357,7 +4438,34 @@
                 </a:solidFill>
                 <a:latin typeface="Arial"/>
               </a:rPr>
-              <a:t>Carve = a cylinder of clear aperture + 20 mm by thickness + 20 mm; CaF2 is not priced here.  A cold detector adds a dewar window to every row alike; cementing it to the block keeps the count at four.  The 3k telescope is the freeform solve of 2026-10-05, scored before its next layout step (slide 11).  Records dyson5_jim_3a.txt, dyson5_t5f_GM_1k5_bAs.txt, dyson5_t5f_GM_3k_c.txt.</a:t>
+              <a:t>Carve = a cylinder of clear aperture + 20 mm by thickness + 20 mm; </a:t>
+            </a:r>
+            <a:r>
+              <a:rPr sz="1050" b="0">
+                <a:solidFill>
+                  <a:srgbClr val="6E6E6E"/>
+                </a:solidFill>
+                <a:latin typeface="Arial"/>
+              </a:rPr>
+              <a:t>CaF</a:t>
+            </a:r>
+            <a:r>
+              <a:rPr sz="1050" b="0" baseline="-25000">
+                <a:solidFill>
+                  <a:srgbClr val="6E6E6E"/>
+                </a:solidFill>
+                <a:latin typeface="Arial"/>
+              </a:rPr>
+              <a:t>2</a:t>
+            </a:r>
+            <a:r>
+              <a:rPr sz="1050" b="0">
+                <a:solidFill>
+                  <a:srgbClr val="6E6E6E"/>
+                </a:solidFill>
+                <a:latin typeface="Arial"/>
+              </a:rPr>
+              <a:t> is not priced here.  A cold detector adds a dewar window to every row alike; cementing it to the block keeps the count at four.  The 3k telescope is the freeform solve of 2026-10-05, scored before its next layout step (slide 11).  Records dyson5_jim_3a.txt, dyson5_t5f_GM_1k5_bAs.txt, dyson5_t5f_GM_3k_c.txt.</a:t>
             </a:r>
           </a:p>
         </p:txBody>
@@ -4537,7 +4645,34 @@
                 </a:solidFill>
                 <a:latin typeface="Arial"/>
               </a:rPr>
-              <a:t>The 3k telescope through the 240 mm CaF2 Dyson as the engine traces it (meters): the same arrangement as the 1.5k module at twice the strip.</a:t>
+              <a:t>The 3k telescope through the 240 mm </a:t>
+            </a:r>
+            <a:r>
+              <a:rPr sz="1000" b="0">
+                <a:solidFill>
+                  <a:srgbClr val="6E6E6E"/>
+                </a:solidFill>
+                <a:latin typeface="Arial"/>
+              </a:rPr>
+              <a:t>CaF</a:t>
+            </a:r>
+            <a:r>
+              <a:rPr sz="1000" b="0" baseline="-25000">
+                <a:solidFill>
+                  <a:srgbClr val="6E6E6E"/>
+                </a:solidFill>
+                <a:latin typeface="Arial"/>
+              </a:rPr>
+              <a:t>2</a:t>
+            </a:r>
+            <a:r>
+              <a:rPr sz="1000" b="0">
+                <a:solidFill>
+                  <a:srgbClr val="6E6E6E"/>
+                </a:solidFill>
+                <a:latin typeface="Arial"/>
+              </a:rPr>
+              <a:t> Dyson as the engine traces it (meters): the same arrangement as the 1.5k module at twice the strip.</a:t>
             </a:r>
           </a:p>
         </p:txBody>
@@ -4576,7 +4711,25 @@
                 </a:solidFill>
                 <a:latin typeface="Arial"/>
               </a:rPr>
-              <a:t>•  What the solve gave: Zernike freeform terms on all three mirrors (M2 carries 1.7 mm of departure at 126 mrad of slope) with the same merit and geometry freedoms as the 1.5k: smile 2.05, keystone 0.05, CRF 4.22, SRF 4.90 px; 98 % of the light admitted at the strip ends; the beam between M2 and M3 passes the block's face by 0.06 mm.</a:t>
+              <a:t>•  </a:t>
+            </a:r>
+            <a:r>
+              <a:rPr sz="1200" b="1">
+                <a:solidFill>
+                  <a:srgbClr val="282828"/>
+                </a:solidFill>
+                <a:latin typeface="Arial"/>
+              </a:rPr>
+              <a:t>What the solve gave:</a:t>
+            </a:r>
+            <a:r>
+              <a:rPr sz="1200" b="0">
+                <a:solidFill>
+                  <a:srgbClr val="282828"/>
+                </a:solidFill>
+                <a:latin typeface="Arial"/>
+              </a:rPr>
+              <a:t> Zernike freeform terms on all three mirrors (M2 carries 1.7 mm of departure at 126 mrad of slope) with the same merit and geometry freedoms as the 1.5k: smile 2.05, keystone 0.05, CRF 4.22, SRF 4.90 px; 98 % of the light admitted at the strip ends; the beam between M2 and M3 passes the block's face by 0.06 mm.</a:t>
             </a:r>
           </a:p>
           <a:p>
@@ -4592,7 +4745,43 @@
                 </a:solidFill>
                 <a:latin typeface="Arial"/>
               </a:rPr>
-              <a:t>•  Why it stalls: on this section the figure terms and the mirror positions work against each other (the freeform norm grows as the geometry moves), which points at the stop's position.  Next: the stop at M2 instead of M1; an asphere-only solve from the same seed; the field weighting across the strip as a project ruling.</a:t>
+              <a:t>•  </a:t>
+            </a:r>
+            <a:r>
+              <a:rPr sz="1200" b="1">
+                <a:solidFill>
+                  <a:srgbClr val="282828"/>
+                </a:solidFill>
+                <a:latin typeface="Arial"/>
+              </a:rPr>
+              <a:t>Why it stalls:</a:t>
+            </a:r>
+            <a:r>
+              <a:rPr sz="1200" b="0">
+                <a:solidFill>
+                  <a:srgbClr val="282828"/>
+                </a:solidFill>
+                <a:latin typeface="Arial"/>
+              </a:rPr>
+              <a:t> on this section the figure terms and the mirror positions work against each other (the freeform norm grows as the geometry moves), which points at the stop's position.  </a:t>
+            </a:r>
+            <a:r>
+              <a:rPr sz="1200" b="1">
+                <a:solidFill>
+                  <a:srgbClr val="282828"/>
+                </a:solidFill>
+                <a:latin typeface="Arial"/>
+              </a:rPr>
+              <a:t>Next:</a:t>
+            </a:r>
+            <a:r>
+              <a:rPr sz="1200" b="0">
+                <a:solidFill>
+                  <a:srgbClr val="282828"/>
+                </a:solidFill>
+                <a:latin typeface="Arial"/>
+              </a:rPr>
+              <a:t> the stop at M2 instead of M1; an asphere-only solve from the same seed; the field weighting across the strip as a project ruling.</a:t>
             </a:r>
           </a:p>
         </p:txBody>
@@ -4840,7 +5029,7 @@
           <a:p>
             <a:pPr>
               <a:spcAft>
-                <a:spcPts val="600"/>
+                <a:spcPts val="1400"/>
               </a:spcAft>
             </a:pPr>
             <a:r>
@@ -4850,13 +5039,58 @@
                 </a:solidFill>
                 <a:latin typeface="Arial"/>
               </a:rPr>
-              <a:t>•  The Offner (concave sphere used twice, convex grating at the stop): tried at F/1.8 and 54 mm, out.  All-reflective, no CaF2, no air-glass crossings, a cold shield for free; the review's long-slit example is F/2.8, 48 mm, 30 µm pixels.  At F/1.8 the grating is 0.28 R across and the slit must sit at 0.29–0.32 R to pass beside it.  With the classical corrections and the ring free, the best point (R = 0.5 m, 0.5 m long, 4.8 kg of blanks) reaches smile 0.17, keystone 0.18 and CRF 2.24 px, but the spectral blur is 7–9 px rms at every R to 1.25 m: an aberration along the dispersion the corrections do not touch (3–6 px, wavelength-independent) plus the grating's term at F/1.8 (+2–4 px by 2500 nm).  Energy in a pixel 0.01.  The next form of that family is the Offner–Chrisp (a third mirror), not tried.</a:t>
+              <a:t>•  </a:t>
+            </a:r>
+            <a:r>
+              <a:rPr sz="1400" b="1">
+                <a:solidFill>
+                  <a:srgbClr val="282828"/>
+                </a:solidFill>
+                <a:latin typeface="Arial"/>
+              </a:rPr>
+              <a:t>The Offner (concave sphere used twice, convex grating at the stop): tried at F/1.8 and 54 mm, out.</a:t>
+            </a:r>
+            <a:r>
+              <a:rPr sz="1400" b="0">
+                <a:solidFill>
+                  <a:srgbClr val="282828"/>
+                </a:solidFill>
+                <a:latin typeface="Arial"/>
+              </a:rPr>
+              <a:t>  All-reflective, no </a:t>
+            </a:r>
+            <a:r>
+              <a:rPr sz="1400" b="0">
+                <a:solidFill>
+                  <a:srgbClr val="282828"/>
+                </a:solidFill>
+                <a:latin typeface="Arial"/>
+              </a:rPr>
+              <a:t>CaF</a:t>
+            </a:r>
+            <a:r>
+              <a:rPr sz="1400" b="0" baseline="-25000">
+                <a:solidFill>
+                  <a:srgbClr val="282828"/>
+                </a:solidFill>
+                <a:latin typeface="Arial"/>
+              </a:rPr>
+              <a:t>2</a:t>
+            </a:r>
+            <a:r>
+              <a:rPr sz="1400" b="0">
+                <a:solidFill>
+                  <a:srgbClr val="282828"/>
+                </a:solidFill>
+                <a:latin typeface="Arial"/>
+              </a:rPr>
+              <a:t>, no air-glass crossings, a cold shield for free; the review's long-slit example is F/2.8, 48 mm, 30 µm pixels.  At F/1.8 the grating is 0.28 R across and the slit must sit at 0.29–0.32 R to pass beside it.  With the classical corrections and the ring free, the best point (R = 0.5 m, 0.5 m long, 4.8 kg of blanks) reaches smile 0.17, keystone 0.18 and CRF 2.24 px, but the spectral blur is 7–9 px rms at every R to 1.25 m: an aberration along the dispersion the corrections do not touch (3–6 px, wavelength-independent) plus the grating's term at F/1.8 (+2–4 px by 2500 nm).  Energy in a pixel 0.01.  The next form of that family is the Offner–Chrisp (a third mirror), not tried.</a:t>
             </a:r>
           </a:p>
           <a:p>
             <a:pPr>
               <a:spcAft>
-                <a:spcPts val="600"/>
+                <a:spcPts val="1400"/>
               </a:spcAft>
             </a:pPr>
             <a:r>
@@ -4866,13 +5100,31 @@
                 </a:solidFill>
                 <a:latin typeface="Arial"/>
               </a:rPr>
-              <a:t>•  The prism Dyson (the review's BPDS, 3200 px, 18 µm, F/2, 57.6 mm slit): a freeform prism in place of the grating, 54 cm long with a 19 cm prism; achieved smile 3 % and keystone 1 % of a pixel.  It is the published answer in this regime, and its size is the price.</a:t>
+              <a:t>•  </a:t>
+            </a:r>
+            <a:r>
+              <a:rPr sz="1400" b="1">
+                <a:solidFill>
+                  <a:srgbClr val="282828"/>
+                </a:solidFill>
+                <a:latin typeface="Arial"/>
+              </a:rPr>
+              <a:t>The prism Dyson (the review's BPDS, 3200 px, 18 µm, F/2, 57.6 mm slit):</a:t>
+            </a:r>
+            <a:r>
+              <a:rPr sz="1400" b="0">
+                <a:solidFill>
+                  <a:srgbClr val="282828"/>
+                </a:solidFill>
+                <a:latin typeface="Arial"/>
+              </a:rPr>
+              <a:t> a freeform prism in place of the grating, 54 cm long with a 19 cm prism; achieved smile 3 % and keystone 1 % of a pixel.  It is the published answer in this regime, and its size is the price.</a:t>
             </a:r>
           </a:p>
           <a:p>
             <a:pPr>
               <a:spcAft>
-                <a:spcPts val="600"/>
+                <a:spcPts val="1400"/>
               </a:spcAft>
             </a:pPr>
             <a:r>
@@ -4882,7 +5134,25 @@
                 </a:solidFill>
                 <a:latin typeface="Arial"/>
               </a:rPr>
-              <a:t>•  A long-slit Dyson with a separate mirror and a meniscus (the review's compact variant, about 60 % of the BPDS's size, six more air-glass faces): the family the 220 mm meniscus design belongs to.</a:t>
+              <a:t>•  </a:t>
+            </a:r>
+            <a:r>
+              <a:rPr sz="1400" b="1">
+                <a:solidFill>
+                  <a:srgbClr val="282828"/>
+                </a:solidFill>
+                <a:latin typeface="Arial"/>
+              </a:rPr>
+              <a:t>A long-slit Dyson with a separate mirror and a meniscus</a:t>
+            </a:r>
+            <a:r>
+              <a:rPr sz="1400" b="0">
+                <a:solidFill>
+                  <a:srgbClr val="282828"/>
+                </a:solidFill>
+                <a:latin typeface="Arial"/>
+              </a:rPr>
+              <a:t> (the review's compact variant, about 60 % of the BPDS's size, six more air-glass faces): the family the 220 mm meniscus design belongs to.</a:t>
             </a:r>
           </a:p>
         </p:txBody>
@@ -4911,7 +5181,7 @@
           <a:p>
             <a:pPr>
               <a:spcAft>
-                <a:spcPts val="600"/>
+                <a:spcPts val="1400"/>
               </a:spcAft>
             </a:pPr>
             <a:r>
@@ -4921,13 +5191,58 @@
                 </a:solidFill>
                 <a:latin typeface="Arial"/>
               </a:rPr>
-              <a:t>•  Split the slit, keep one telescope.  The record's own finding is that at 3k the spectrometer closes (CaF2 at 240 mm, or silica with the meniscus) and the telescope does not.  A 3k telescope feeding two 1.5k Dysons through a split slit keeps two telescopes and four small silica blocks, but it needs the 3k telescope, which is the open item.</a:t>
+              <a:t>•  </a:t>
+            </a:r>
+            <a:r>
+              <a:rPr sz="1400" b="1">
+                <a:solidFill>
+                  <a:srgbClr val="282828"/>
+                </a:solidFill>
+                <a:latin typeface="Arial"/>
+              </a:rPr>
+              <a:t>Split the slit, keep one telescope.</a:t>
+            </a:r>
+            <a:r>
+              <a:rPr sz="1400" b="0">
+                <a:solidFill>
+                  <a:srgbClr val="282828"/>
+                </a:solidFill>
+                <a:latin typeface="Arial"/>
+              </a:rPr>
+              <a:t>  The record's own finding is that at 3k the spectrometer closes (</a:t>
+            </a:r>
+            <a:r>
+              <a:rPr sz="1400" b="0">
+                <a:solidFill>
+                  <a:srgbClr val="282828"/>
+                </a:solidFill>
+                <a:latin typeface="Arial"/>
+              </a:rPr>
+              <a:t>CaF</a:t>
+            </a:r>
+            <a:r>
+              <a:rPr sz="1400" b="0" baseline="-25000">
+                <a:solidFill>
+                  <a:srgbClr val="282828"/>
+                </a:solidFill>
+                <a:latin typeface="Arial"/>
+              </a:rPr>
+              <a:t>2</a:t>
+            </a:r>
+            <a:r>
+              <a:rPr sz="1400" b="0">
+                <a:solidFill>
+                  <a:srgbClr val="282828"/>
+                </a:solidFill>
+                <a:latin typeface="Arial"/>
+              </a:rPr>
+              <a:t> at 240 mm, or silica with the meniscus) and the telescope does not.  A 3k telescope feeding two 1.5k Dysons through a split slit keeps two telescopes and four small silica blocks, but it needs the 3k telescope, which is the open item.</a:t>
             </a:r>
           </a:p>
           <a:p>
             <a:pPr>
               <a:spcAft>
-                <a:spcPts val="600"/>
+                <a:spcPts val="1400"/>
               </a:spcAft>
             </a:pPr>
             <a:r>
@@ -4937,7 +5252,25 @@
                 </a:solidFill>
                 <a:latin typeface="Arial"/>
               </a:rPr>
-              <a:t>•  What the ray trace can settle next: the prism Dyson needs a dispersing prism added to the layout chain (the engine traces one already); the Offner–Chrisp needs a three-mirror layout solver.  Each is a few days; whether either is worth it is a question for Jim and Joe.</a:t>
+              <a:t>•  </a:t>
+            </a:r>
+            <a:r>
+              <a:rPr sz="1400" b="1">
+                <a:solidFill>
+                  <a:srgbClr val="282828"/>
+                </a:solidFill>
+                <a:latin typeface="Arial"/>
+              </a:rPr>
+              <a:t>What the ray trace can settle next:</a:t>
+            </a:r>
+            <a:r>
+              <a:rPr sz="1400" b="0">
+                <a:solidFill>
+                  <a:srgbClr val="282828"/>
+                </a:solidFill>
+                <a:latin typeface="Arial"/>
+              </a:rPr>
+              <a:t> the prism Dyson needs a dispersing prism added to the layout chain (the engine traces one already); the Offner–Chrisp needs a three-mirror layout solver.  Each is a few days; whether either is worth it is a question for Jim and Joe.</a:t>
             </a:r>
           </a:p>
         </p:txBody>
@@ -4950,7 +5283,7 @@
         </p:nvSpPr>
         <p:spPr>
           <a:xfrm>
-            <a:off x="6400800" y="4157979"/>
+            <a:off x="6400800" y="4361180"/>
             <a:ext cx="5394960" cy="274320"/>
           </a:xfrm>
           <a:prstGeom prst="rect">
@@ -5132,7 +5465,52 @@
                 </a:solidFill>
                 <a:latin typeface="Arial"/>
               </a:rPr>
-              <a:t>•  Are four modules acceptable?  The 1.5k module now has a telescope at the pixel end to end (slides 6–8); the 3k module does not yet (slide 11).  At the same 6000 cross-track pixels, four telescopes, spectrometers and detectors in 6.6 kg of fused silica against two in 28.5 kg of CaF2: is four a packaging the project would entertain?</a:t>
+              <a:t>•  </a:t>
+            </a:r>
+            <a:r>
+              <a:rPr sz="1500" b="1">
+                <a:solidFill>
+                  <a:srgbClr val="282828"/>
+                </a:solidFill>
+                <a:latin typeface="Arial"/>
+              </a:rPr>
+              <a:t>Are four modules acceptable?</a:t>
+            </a:r>
+            <a:r>
+              <a:rPr sz="1500" b="0">
+                <a:solidFill>
+                  <a:srgbClr val="282828"/>
+                </a:solidFill>
+                <a:latin typeface="Arial"/>
+              </a:rPr>
+              <a:t>  The 1.5k module now has a telescope at the pixel end to end (slides 6–8); the 3k module does not yet (slide 11).  At the same 6000 cross-track pixels, four telescopes, spectrometers and detectors in 6.6 kg of fused silica against two in 28.5 kg of </a:t>
+            </a:r>
+            <a:r>
+              <a:rPr sz="1500" b="0">
+                <a:solidFill>
+                  <a:srgbClr val="282828"/>
+                </a:solidFill>
+                <a:latin typeface="Arial"/>
+              </a:rPr>
+              <a:t>CaF</a:t>
+            </a:r>
+            <a:r>
+              <a:rPr sz="1500" b="0" baseline="-25000">
+                <a:solidFill>
+                  <a:srgbClr val="282828"/>
+                </a:solidFill>
+                <a:latin typeface="Arial"/>
+              </a:rPr>
+              <a:t>2</a:t>
+            </a:r>
+            <a:r>
+              <a:rPr sz="1500" b="0">
+                <a:solidFill>
+                  <a:srgbClr val="282828"/>
+                </a:solidFill>
+                <a:latin typeface="Arial"/>
+              </a:rPr>
+              <a:t>: is four a packaging the project would entertain?</a:t>
             </a:r>
           </a:p>
           <a:p>
@@ -5148,7 +5526,79 @@
                 </a:solidFill>
                 <a:latin typeface="Arial"/>
               </a:rPr>
-              <a:t>•  Is CaF2 a realistic option for the 3,000 option?  Two 240 mm blocks need 12.4 L of single-crystal CaF2 to carve from (6.2 L each, clear aperture + 20 mm each way; 19.6 L at the 300 mm blocks that put all the energy in a pixel).  What does that cost against two to four fused-silica blocks of 0.75 L?</a:t>
+              <a:t>•  </a:t>
+            </a:r>
+            <a:r>
+              <a:rPr sz="1500" b="1">
+                <a:solidFill>
+                  <a:srgbClr val="282828"/>
+                </a:solidFill>
+                <a:latin typeface="Arial"/>
+              </a:rPr>
+              <a:t>Is </a:t>
+            </a:r>
+            <a:r>
+              <a:rPr sz="1500" b="1">
+                <a:solidFill>
+                  <a:srgbClr val="282828"/>
+                </a:solidFill>
+                <a:latin typeface="Arial"/>
+              </a:rPr>
+              <a:t>CaF</a:t>
+            </a:r>
+            <a:r>
+              <a:rPr sz="1500" b="1" baseline="-25000">
+                <a:solidFill>
+                  <a:srgbClr val="282828"/>
+                </a:solidFill>
+                <a:latin typeface="Arial"/>
+              </a:rPr>
+              <a:t>2</a:t>
+            </a:r>
+            <a:r>
+              <a:rPr sz="1500" b="1">
+                <a:solidFill>
+                  <a:srgbClr val="282828"/>
+                </a:solidFill>
+                <a:latin typeface="Arial"/>
+              </a:rPr>
+              <a:t> a realistic option for the 3,000 option?</a:t>
+            </a:r>
+            <a:r>
+              <a:rPr sz="1500" b="0">
+                <a:solidFill>
+                  <a:srgbClr val="282828"/>
+                </a:solidFill>
+                <a:latin typeface="Arial"/>
+              </a:rPr>
+              <a:t>  Two 240 mm blocks need 12.4 L of single-crystal </a:t>
+            </a:r>
+            <a:r>
+              <a:rPr sz="1500" b="0">
+                <a:solidFill>
+                  <a:srgbClr val="282828"/>
+                </a:solidFill>
+                <a:latin typeface="Arial"/>
+              </a:rPr>
+              <a:t>CaF</a:t>
+            </a:r>
+            <a:r>
+              <a:rPr sz="1500" b="0" baseline="-25000">
+                <a:solidFill>
+                  <a:srgbClr val="282828"/>
+                </a:solidFill>
+                <a:latin typeface="Arial"/>
+              </a:rPr>
+              <a:t>2</a:t>
+            </a:r>
+            <a:r>
+              <a:rPr sz="1500" b="0">
+                <a:solidFill>
+                  <a:srgbClr val="282828"/>
+                </a:solidFill>
+                <a:latin typeface="Arial"/>
+              </a:rPr>
+              <a:t> to carve from (6.2 L each, clear aperture + 20 mm each way; 19.6 L at the 300 mm blocks that put all the energy in a pixel).  What does that cost against two to four fused-silica blocks of 0.75 L?</a:t>
             </a:r>
           </a:p>
           <a:p>
@@ -5164,7 +5614,25 @@
                 </a:solidFill>
                 <a:latin typeface="Arial"/>
               </a:rPr>
-              <a:t>•  The telescope is a first design, and does not meet all inferred requirements: the strip ends at 0.8 px, 2 mm of aspheric departure on M1, no tolerancing.</a:t>
+              <a:t>•  </a:t>
+            </a:r>
+            <a:r>
+              <a:rPr sz="1500" b="1">
+                <a:solidFill>
+                  <a:srgbClr val="282828"/>
+                </a:solidFill>
+                <a:latin typeface="Arial"/>
+              </a:rPr>
+              <a:t>The telescope is a first design, and does not meet all inferred requirements:</a:t>
+            </a:r>
+            <a:r>
+              <a:rPr sz="1500" b="0">
+                <a:solidFill>
+                  <a:srgbClr val="282828"/>
+                </a:solidFill>
+                <a:latin typeface="Arial"/>
+              </a:rPr>
+              <a:t> the strip ends at 0.8 px, 2 mm of aspheric departure on M1, no tolerancing.</a:t>
             </a:r>
           </a:p>
           <a:p>
@@ -5180,7 +5648,25 @@
                 </a:solidFill>
                 <a:latin typeface="Arial"/>
               </a:rPr>
-              <a:t>•  We ask for help in bringing it home: What telescope forms have worked at 183 mm, F/1.8 and a 4.7–9.4° strip into a telecentric slit?  More generally, what are we missing, for throughput (beyond cementing the window and a two-layer coating, 0.81 → 0.91) and for performance that the public record does not show?</a:t>
+              <a:t>•  </a:t>
+            </a:r>
+            <a:r>
+              <a:rPr sz="1500" b="1">
+                <a:solidFill>
+                  <a:srgbClr val="282828"/>
+                </a:solidFill>
+                <a:latin typeface="Arial"/>
+              </a:rPr>
+              <a:t>We ask for help in bringing it home:</a:t>
+            </a:r>
+            <a:r>
+              <a:rPr sz="1500" b="0">
+                <a:solidFill>
+                  <a:srgbClr val="282828"/>
+                </a:solidFill>
+                <a:latin typeface="Arial"/>
+              </a:rPr>
+              <a:t> What telescope forms have worked at 183 mm, F/1.8 and a 4.7–9.4° strip into a telecentric slit?  More generally, what are we missing, for throughput (beyond cementing the window and a two-layer coating, 0.81 → 0.91) and for performance that the public record does not show?</a:t>
             </a:r>
           </a:p>
         </p:txBody>
@@ -5365,7 +5851,7 @@
           <a:p>
             <a:pPr>
               <a:spcAft>
-                <a:spcPts val="600"/>
+                <a:spcPts val="1400"/>
               </a:spcAft>
             </a:pPr>
             <a:r>
@@ -5375,13 +5861,31 @@
                 </a:solidFill>
                 <a:latin typeface="Arial"/>
               </a:rPr>
-              <a:t>•  The 3k telescope: the stop at M2; an asphere-only solve from the freeform seed; a merit written on the response-function width for the final step; the field weighting across the strip as a ruling.</a:t>
+              <a:t>•  </a:t>
+            </a:r>
+            <a:r>
+              <a:rPr sz="1400" b="1">
+                <a:solidFill>
+                  <a:srgbClr val="282828"/>
+                </a:solidFill>
+                <a:latin typeface="Arial"/>
+              </a:rPr>
+              <a:t>The 3k telescope:</a:t>
+            </a:r>
+            <a:r>
+              <a:rPr sz="1400" b="0">
+                <a:solidFill>
+                  <a:srgbClr val="282828"/>
+                </a:solidFill>
+                <a:latin typeface="Arial"/>
+              </a:rPr>
+              <a:t> the stop at M2; an asphere-only solve from the freeform seed; a merit written on the response-function width for the final step; the field weighting across the strip as a ruling.</a:t>
             </a:r>
           </a:p>
           <a:p>
             <a:pPr>
               <a:spcAft>
-                <a:spcPts val="600"/>
+                <a:spcPts val="1400"/>
               </a:spcAft>
             </a:pPr>
             <a:r>
@@ -5391,13 +5895,31 @@
                 </a:solidFill>
                 <a:latin typeface="Arial"/>
               </a:rPr>
-              <a:t>•  The 1.5k module's package: the cold window cemented as the block's exit face with the shield as the detector housing behind it, under the same clearance check; the 1.5 mm of working distance the 130 mm module tolerates is where it goes.</a:t>
+              <a:t>•  </a:t>
+            </a:r>
+            <a:r>
+              <a:rPr sz="1400" b="1">
+                <a:solidFill>
+                  <a:srgbClr val="282828"/>
+                </a:solidFill>
+                <a:latin typeface="Arial"/>
+              </a:rPr>
+              <a:t>The 1.5k module's package:</a:t>
+            </a:r>
+            <a:r>
+              <a:rPr sz="1400" b="0">
+                <a:solidFill>
+                  <a:srgbClr val="282828"/>
+                </a:solidFill>
+                <a:latin typeface="Arial"/>
+              </a:rPr>
+              <a:t> the cold window cemented as the block's exit face with the shield as the detector housing behind it, under the same clearance check; the 1.5 mm of working distance the 130 mm module tolerates is where it goes.</a:t>
             </a:r>
           </a:p>
           <a:p>
             <a:pPr>
               <a:spcAft>
-                <a:spcPts val="600"/>
+                <a:spcPts val="1400"/>
               </a:spcAft>
             </a:pPr>
             <a:r>
@@ -5407,7 +5929,25 @@
                 </a:solidFill>
                 <a:latin typeface="Arial"/>
               </a:rPr>
-              <a:t>•  The radiometric chain against the band: throughput, grating efficiency, detector quantum efficiency and the slit's diffraction loss (0.3 % at 380 nm to 1.8 % at 2500 nm past the grating, before the telescope's cone).</a:t>
+              <a:t>•  </a:t>
+            </a:r>
+            <a:r>
+              <a:rPr sz="1400" b="1">
+                <a:solidFill>
+                  <a:srgbClr val="282828"/>
+                </a:solidFill>
+                <a:latin typeface="Arial"/>
+              </a:rPr>
+              <a:t>The radiometric chain against the band:</a:t>
+            </a:r>
+            <a:r>
+              <a:rPr sz="1400" b="0">
+                <a:solidFill>
+                  <a:srgbClr val="282828"/>
+                </a:solidFill>
+                <a:latin typeface="Arial"/>
+              </a:rPr>
+              <a:t> throughput, grating efficiency, detector quantum efficiency and the slit's diffraction loss (0.3 % at 380 nm to 1.8 % at 2500 nm past the grating, before the telescope's cone).</a:t>
             </a:r>
           </a:p>
         </p:txBody>
@@ -5436,7 +5976,7 @@
           <a:p>
             <a:pPr>
               <a:spcAft>
-                <a:spcPts val="600"/>
+                <a:spcPts val="1400"/>
               </a:spcAft>
             </a:pPr>
             <a:r>
@@ -5446,13 +5986,31 @@
                 </a:solidFill>
                 <a:latin typeface="Arial"/>
               </a:rPr>
-              <a:t>•  In the engine: a fixed-station reference sphere for the wavefront merit on telecentric designs; an asphere-plus-Zernike surface in one declaration; a short-line guard for every multi-value prescription keyword.</a:t>
+              <a:t>•  </a:t>
+            </a:r>
+            <a:r>
+              <a:rPr sz="1400" b="1">
+                <a:solidFill>
+                  <a:srgbClr val="282828"/>
+                </a:solidFill>
+                <a:latin typeface="Arial"/>
+              </a:rPr>
+              <a:t>In the engine:</a:t>
+            </a:r>
+            <a:r>
+              <a:rPr sz="1400" b="0">
+                <a:solidFill>
+                  <a:srgbClr val="282828"/>
+                </a:solidFill>
+                <a:latin typeface="Arial"/>
+              </a:rPr>
+              <a:t> a fixed-station reference sphere for the wavefront merit on telecentric designs; an asphere-plus-Zernike surface in one declaration; a short-line guard for every multi-value prescription keyword.</a:t>
             </a:r>
           </a:p>
           <a:p>
             <a:pPr>
               <a:spcAft>
-                <a:spcPts val="600"/>
+                <a:spcPts val="1400"/>
               </a:spcAft>
             </a:pPr>
             <a:r>
@@ -5462,7 +6020,25 @@
                 </a:solidFill>
                 <a:latin typeface="Arial"/>
               </a:rPr>
-              <a:t>•  Later, once the design of record is stable: full diffraction from the slit through the grating to the detector (the slit's truncation of the telescope's image, about 10 % on the response functions in the literature); polarization sensitivity of the Dyson against the Offner; a surface-by-surface tour of the prescription.</a:t>
+              <a:t>•  </a:t>
+            </a:r>
+            <a:r>
+              <a:rPr sz="1400" b="1">
+                <a:solidFill>
+                  <a:srgbClr val="282828"/>
+                </a:solidFill>
+                <a:latin typeface="Arial"/>
+              </a:rPr>
+              <a:t>Later, once the design of record is stable:</a:t>
+            </a:r>
+            <a:r>
+              <a:rPr sz="1400" b="0">
+                <a:solidFill>
+                  <a:srgbClr val="282828"/>
+                </a:solidFill>
+                <a:latin typeface="Arial"/>
+              </a:rPr>
+              <a:t> full diffraction from the slit through the grating to the detector (the slit's truncation of the telescope's image, about 10 % on the response functions in the literature); polarization sensitivity of the Dyson against the Offner; a surface-by-surface tour of the prescription.</a:t>
             </a:r>
           </a:p>
         </p:txBody>
@@ -5773,7 +6349,25 @@
                 </a:solidFill>
                 <a:latin typeface="Arial"/>
               </a:rPr>
-              <a:t>•  Changeable design parameters live in one file, dyson5_params.m: F-number, pixel count and pitch, band, slit width, block radius, glass, diffraction order, the ladder's steps and weights, the aperture and mount margins, the detector package, the telescope deck and the Dyson it feeds.  Every record in this deck is a stage output under challenges/dyson5/.</a:t>
+              <a:t>•  </a:t>
+            </a:r>
+            <a:r>
+              <a:rPr sz="1500" b="1">
+                <a:solidFill>
+                  <a:srgbClr val="282828"/>
+                </a:solidFill>
+                <a:latin typeface="Arial"/>
+              </a:rPr>
+              <a:t>Changeable design parameters live in one file, dyson5_params.m:</a:t>
+            </a:r>
+            <a:r>
+              <a:rPr sz="1500" b="0">
+                <a:solidFill>
+                  <a:srgbClr val="282828"/>
+                </a:solidFill>
+                <a:latin typeface="Arial"/>
+              </a:rPr>
+              <a:t> F-number, pixel count and pitch, band, slit width, block radius, glass, diffraction order, the ladder's steps and weights, the aperture and mount margins, the detector package, the telescope deck and the Dyson it feeds.  Every record in this deck is a stage output under challenges/dyson5/.</a:t>
             </a:r>
           </a:p>
           <a:p>
@@ -5789,7 +6383,25 @@
                 </a:solidFill>
                 <a:latin typeface="Arial"/>
               </a:rPr>
-              <a:t>•  Checks: ./run_mmacos_tests.sh tSpectrometerRx tTelescopeRx and the grating, glass, propagation and root-pick classes, all in the fast suite (536 pass, 0 fail, 2026-10-05).</a:t>
+              <a:t>•  </a:t>
+            </a:r>
+            <a:r>
+              <a:rPr sz="1500" b="1">
+                <a:solidFill>
+                  <a:srgbClr val="282828"/>
+                </a:solidFill>
+                <a:latin typeface="Arial"/>
+              </a:rPr>
+              <a:t>Checks:</a:t>
+            </a:r>
+            <a:r>
+              <a:rPr sz="1500" b="0">
+                <a:solidFill>
+                  <a:srgbClr val="282828"/>
+                </a:solidFill>
+                <a:latin typeface="Arial"/>
+              </a:rPr>
+              <a:t> ./run_mmacos_tests.sh tSpectrometerRx tTelescopeRx and the grating, glass, propagation and root-pick classes, all in the fast suite (536 pass, 0 fail, 2026-10-05).</a:t>
             </a:r>
           </a:p>
         </p:txBody>
@@ -6085,7 +6697,25 @@
                 </a:solidFill>
                 <a:latin typeface="Arial"/>
               </a:rPr>
-              <a:t>•  The pupil is a first-order condition.  The Dyson accepts chief rays within 0.09° of its own, so the telescope's exit pupil must sit near infinity.  A three-mirror with a real intermediate focus between M2 and M3 cannot be telecentric; with M3 ahead of that focus the chiefs sit within 0.5° across the strip and every field is admitted.</a:t>
+              <a:t>•  </a:t>
+            </a:r>
+            <a:r>
+              <a:rPr sz="1200" b="1">
+                <a:solidFill>
+                  <a:srgbClr val="282828"/>
+                </a:solidFill>
+                <a:latin typeface="Arial"/>
+              </a:rPr>
+              <a:t>The pupil is a first-order condition.</a:t>
+            </a:r>
+            <a:r>
+              <a:rPr sz="1200" b="0">
+                <a:solidFill>
+                  <a:srgbClr val="282828"/>
+                </a:solidFill>
+                <a:latin typeface="Arial"/>
+              </a:rPr>
+              <a:t>  The Dyson accepts chief rays within 0.09° of its own, so the telescope's exit pupil must sit near infinity.  A three-mirror with a real intermediate focus between M2 and M3 cannot be telecentric; with M3 ahead of that focus the chiefs sit within 0.5° across the strip and every field is admitted.</a:t>
             </a:r>
           </a:p>
           <a:p>
@@ -6101,7 +6731,25 @@
                 </a:solidFill>
                 <a:latin typeface="Arial"/>
               </a:rPr>
-              <a:t>•  It was not focus or the mirrors' power split: along the strip the along-track focus is flat, the cross-track focus curves 2–4 mm and the two line foci at the edge sit 2–5 mm apart; no secondary magnification flattens both, and a field lens has no leverage at the slit.</a:t>
+              <a:t>•  </a:t>
+            </a:r>
+            <a:r>
+              <a:rPr sz="1200" b="1">
+                <a:solidFill>
+                  <a:srgbClr val="282828"/>
+                </a:solidFill>
+                <a:latin typeface="Arial"/>
+              </a:rPr>
+              <a:t>It was not focus or the mirrors' power split:</a:t>
+            </a:r>
+            <a:r>
+              <a:rPr sz="1200" b="0">
+                <a:solidFill>
+                  <a:srgbClr val="282828"/>
+                </a:solidFill>
+                <a:latin typeface="Arial"/>
+              </a:rPr>
+              <a:t> along the strip the along-track focus is flat, the cross-track focus curves 2–4 mm and the two line foci at the edge sit 2–5 mm apart; no secondary magnification flattens both, and a field lens has no leverage at the slit.</a:t>
             </a:r>
           </a:p>
           <a:p>
@@ -6117,7 +6765,25 @@
                 </a:solidFill>
                 <a:latin typeface="Arial"/>
               </a:rPr>
-              <a:t>•  Figure terms alone trade the center for the edge: Zernike departures on all three mirrors took the 1.5k edge 291 → 170 µm while the center went 29 → 73 µm.  A control with the wavefront merit written per ray gave the same trade: the merit, not the surfaces, set it.</a:t>
+              <a:t>•  </a:t>
+            </a:r>
+            <a:r>
+              <a:rPr sz="1200" b="1">
+                <a:solidFill>
+                  <a:srgbClr val="282828"/>
+                </a:solidFill>
+                <a:latin typeface="Arial"/>
+              </a:rPr>
+              <a:t>Figure terms alone trade the center for the edge:</a:t>
+            </a:r>
+            <a:r>
+              <a:rPr sz="1200" b="0">
+                <a:solidFill>
+                  <a:srgbClr val="282828"/>
+                </a:solidFill>
+                <a:latin typeface="Arial"/>
+              </a:rPr>
+              <a:t> Zernike departures on all three mirrors took the 1.5k edge 291 → 170 µm while the center went 29 → 73 µm.  A control with the wavefront merit written per ray gave the same trade: the merit, not the surfaces, set it.</a:t>
             </a:r>
           </a:p>
           <a:p>
@@ -6133,7 +6799,25 @@
                 </a:solidFill>
                 <a:latin typeface="Arial"/>
               </a:rPr>
-              <a:t>•  Two levers removed it, neither a figure term: the merit written on the per-ray transverse spot at the slit with the per-field image positions (at F/1.8 with tens of µm of path error the wavefront rms flattens the field by trading the center), and M2/M3 tilt, decenter and the focus as variables.  With both, the freeform terms collapsed to a re-fitted set of off-axis aspheres, re-solved as aspheres: the record.</a:t>
+              <a:t>•  </a:t>
+            </a:r>
+            <a:r>
+              <a:rPr sz="1200" b="1">
+                <a:solidFill>
+                  <a:srgbClr val="282828"/>
+                </a:solidFill>
+                <a:latin typeface="Arial"/>
+              </a:rPr>
+              <a:t>Two levers removed it, neither a figure term:</a:t>
+            </a:r>
+            <a:r>
+              <a:rPr sz="1200" b="0">
+                <a:solidFill>
+                  <a:srgbClr val="282828"/>
+                </a:solidFill>
+                <a:latin typeface="Arial"/>
+              </a:rPr>
+              <a:t> the merit written on the per-ray transverse spot at the slit with the per-field image positions (at F/1.8 with tens of µm of path error the wavefront rms flattens the field by trading the center), and M2/M3 tilt, decenter and the focus as variables.  With both, the freeform terms collapsed to a re-fitted set of off-axis aspheres, re-solved as aspheres: the record.</a:t>
             </a:r>
           </a:p>
         </p:txBody>
@@ -8752,7 +9436,25 @@
                 </a:solidFill>
                 <a:latin typeface="Arial"/>
               </a:rPr>
-              <a:t>•  Eleven surfaces: the block's flat and spherical faces, a 4 mm meniscus in the air gap, the grating, and the same faces on the way back; block radius 220 mm, grating 269 mm across on a 0.69 m radius, slit plane to grating 694 mm.</a:t>
+              <a:t>•  </a:t>
+            </a:r>
+            <a:r>
+              <a:rPr sz="1200" b="1">
+                <a:solidFill>
+                  <a:srgbClr val="282828"/>
+                </a:solidFill>
+                <a:latin typeface="Arial"/>
+              </a:rPr>
+              <a:t>Eleven surfaces:</a:t>
+            </a:r>
+            <a:r>
+              <a:rPr sz="1200" b="0">
+                <a:solidFill>
+                  <a:srgbClr val="282828"/>
+                </a:solidFill>
+                <a:latin typeface="Arial"/>
+              </a:rPr>
+              <a:t> the block's flat and spherical faces, a 4 mm meniscus in the air gap, the grating, and the same faces on the way back; block radius 220 mm, grating 269 mm across on a 0.69 m radius, slit plane to grating 694 mm.</a:t>
             </a:r>
           </a:p>
           <a:p>
@@ -8768,7 +9470,25 @@
                 </a:solidFill>
                 <a:latin typeface="Arial"/>
               </a:rPr>
-              <a:t>•  Decentering the block solves the distortion; the meniscus buys the blur.  Keystone 0.095 → 0.011 px comes from the block's center moving off the grating's along the dispersion; the corner blur does not move on any step without the meniscus or a 341 mm block.  A global search over the meniscus (12 starts) found no better basin on the detector.</a:t>
+              <a:t>•  </a:t>
+            </a:r>
+            <a:r>
+              <a:rPr sz="1200" b="1">
+                <a:solidFill>
+                  <a:srgbClr val="282828"/>
+                </a:solidFill>
+                <a:latin typeface="Arial"/>
+              </a:rPr>
+              <a:t>Decentering the block solves the distortion; the meniscus buys the blur.</a:t>
+            </a:r>
+            <a:r>
+              <a:rPr sz="1200" b="0">
+                <a:solidFill>
+                  <a:srgbClr val="282828"/>
+                </a:solidFill>
+                <a:latin typeface="Arial"/>
+              </a:rPr>
+              <a:t>  Keystone 0.095 → 0.011 px comes from the block's center moving off the grating's along the dispersion; the corner blur does not move on any step without the meniscus or a 341 mm block.  A global search over the meniscus (12 starts) found no better basin on the detector.</a:t>
             </a:r>
           </a:p>
           <a:p>
@@ -8784,7 +9504,25 @@
                 </a:solidFill>
                 <a:latin typeface="Arial"/>
               </a:rPr>
-              <a:t>•  Checked by propagation: the point-spread function's centroid equals the ray centroid to 0.002 px at every slit position and wavelength.</a:t>
+              <a:t>•  </a:t>
+            </a:r>
+            <a:r>
+              <a:rPr sz="1200" b="1">
+                <a:solidFill>
+                  <a:srgbClr val="282828"/>
+                </a:solidFill>
+                <a:latin typeface="Arial"/>
+              </a:rPr>
+              <a:t>Checked by propagation:</a:t>
+            </a:r>
+            <a:r>
+              <a:rPr sz="1200" b="0">
+                <a:solidFill>
+                  <a:srgbClr val="282828"/>
+                </a:solidFill>
+                <a:latin typeface="Arial"/>
+              </a:rPr>
+              <a:t> the point-spread function's centroid equals the ray centroid to 0.002 px at every slit position and wavelength.</a:t>
             </a:r>
           </a:p>
           <a:p>
@@ -8800,7 +9538,25 @@
                 </a:solidFill>
                 <a:latin typeface="Arial"/>
               </a:rPr>
-              <a:t>•  A cold shield cannot be bought in this form: every millimeter of air before the detector costs about 0.5 px of CRF; a fold prism takes the detector out of the slit's plane at CRF 1.27 px and 0.70 in one pixel.</a:t>
+              <a:t>•  </a:t>
+            </a:r>
+            <a:r>
+              <a:rPr sz="1200" b="1">
+                <a:solidFill>
+                  <a:srgbClr val="282828"/>
+                </a:solidFill>
+                <a:latin typeface="Arial"/>
+              </a:rPr>
+              <a:t>A cold shield cannot be bought in this form:</a:t>
+            </a:r>
+            <a:r>
+              <a:rPr sz="1200" b="0">
+                <a:solidFill>
+                  <a:srgbClr val="282828"/>
+                </a:solidFill>
+                <a:latin typeface="Arial"/>
+              </a:rPr>
+              <a:t> every millimeter of air before the detector costs about 0.5 px of CRF; a fold prism takes the detector out of the slit's plane at CRF 1.27 px and 0.70 in one pixel.</a:t>
             </a:r>
           </a:p>
         </p:txBody>
@@ -9058,7 +9814,25 @@
                 </a:solidFill>
                 <a:latin typeface="Arial"/>
               </a:rPr>
-              <a:t>•  3 The target and how it is scored</a:t>
+              <a:t>•  </a:t>
+            </a:r>
+            <a:r>
+              <a:rPr sz="1400" b="1">
+                <a:solidFill>
+                  <a:srgbClr val="282828"/>
+                </a:solidFill>
+                <a:latin typeface="Arial"/>
+              </a:rPr>
+              <a:t>3</a:t>
+            </a:r>
+            <a:r>
+              <a:rPr sz="1400" b="0">
+                <a:solidFill>
+                  <a:srgbClr val="282828"/>
+                </a:solidFill>
+                <a:latin typeface="Arial"/>
+              </a:rPr>
+              <a:t> The target and how it is scored</a:t>
             </a:r>
           </a:p>
           <a:p>
@@ -9074,7 +9848,25 @@
                 </a:solidFill>
                 <a:latin typeface="Arial"/>
               </a:rPr>
-              <a:t>•  4 What the instrument does, and two ways to build it</a:t>
+              <a:t>•  </a:t>
+            </a:r>
+            <a:r>
+              <a:rPr sz="1400" b="1">
+                <a:solidFill>
+                  <a:srgbClr val="282828"/>
+                </a:solidFill>
+                <a:latin typeface="Arial"/>
+              </a:rPr>
+              <a:t>4</a:t>
+            </a:r>
+            <a:r>
+              <a:rPr sz="1400" b="0">
+                <a:solidFill>
+                  <a:srgbClr val="282828"/>
+                </a:solidFill>
+                <a:latin typeface="Arial"/>
+              </a:rPr>
+              <a:t> What the instrument does, and two ways to build it</a:t>
             </a:r>
           </a:p>
           <a:p>
@@ -9090,7 +9882,25 @@
                 </a:solidFill>
                 <a:latin typeface="Arial"/>
               </a:rPr>
-              <a:t>•  5 Four 1.5k modules fill the swath</a:t>
+              <a:t>•  </a:t>
+            </a:r>
+            <a:r>
+              <a:rPr sz="1400" b="1">
+                <a:solidFill>
+                  <a:srgbClr val="282828"/>
+                </a:solidFill>
+                <a:latin typeface="Arial"/>
+              </a:rPr>
+              <a:t>5</a:t>
+            </a:r>
+            <a:r>
+              <a:rPr sz="1400" b="0">
+                <a:solidFill>
+                  <a:srgbClr val="282828"/>
+                </a:solidFill>
+                <a:latin typeface="Arial"/>
+              </a:rPr>
+              <a:t> Four 1.5k modules fill the swath</a:t>
             </a:r>
           </a:p>
           <a:p>
@@ -9106,7 +9916,25 @@
                 </a:solidFill>
                 <a:latin typeface="Arial"/>
               </a:rPr>
-              <a:t>•  6 The 1.5k module, scored: spectrometer, telescope, and the two together</a:t>
+              <a:t>•  </a:t>
+            </a:r>
+            <a:r>
+              <a:rPr sz="1400" b="1">
+                <a:solidFill>
+                  <a:srgbClr val="282828"/>
+                </a:solidFill>
+                <a:latin typeface="Arial"/>
+              </a:rPr>
+              <a:t>6</a:t>
+            </a:r>
+            <a:r>
+              <a:rPr sz="1400" b="0">
+                <a:solidFill>
+                  <a:srgbClr val="282828"/>
+                </a:solidFill>
+                <a:latin typeface="Arial"/>
+              </a:rPr>
+              <a:t> The 1.5k module, scored: spectrometer, telescope, and the two together</a:t>
             </a:r>
           </a:p>
           <a:p>
@@ -9122,7 +9950,25 @@
                 </a:solidFill>
                 <a:latin typeface="Arial"/>
               </a:rPr>
-              <a:t>•  7 The 1.5k module, end to end</a:t>
+              <a:t>•  </a:t>
+            </a:r>
+            <a:r>
+              <a:rPr sz="1400" b="1">
+                <a:solidFill>
+                  <a:srgbClr val="282828"/>
+                </a:solidFill>
+                <a:latin typeface="Arial"/>
+              </a:rPr>
+              <a:t>7</a:t>
+            </a:r>
+            <a:r>
+              <a:rPr sz="1400" b="0">
+                <a:solidFill>
+                  <a:srgbClr val="282828"/>
+                </a:solidFill>
+                <a:latin typeface="Arial"/>
+              </a:rPr>
+              <a:t> The 1.5k module, end to end</a:t>
             </a:r>
           </a:p>
           <a:p>
@@ -9138,7 +9984,25 @@
                 </a:solidFill>
                 <a:latin typeface="Arial"/>
               </a:rPr>
-              <a:t>•  8 The telescope so far: three off-axis aspheres</a:t>
+              <a:t>•  </a:t>
+            </a:r>
+            <a:r>
+              <a:rPr sz="1400" b="1">
+                <a:solidFill>
+                  <a:srgbClr val="282828"/>
+                </a:solidFill>
+                <a:latin typeface="Arial"/>
+              </a:rPr>
+              <a:t>8</a:t>
+            </a:r>
+            <a:r>
+              <a:rPr sz="1400" b="0">
+                <a:solidFill>
+                  <a:srgbClr val="282828"/>
+                </a:solidFill>
+                <a:latin typeface="Arial"/>
+              </a:rPr>
+              <a:t> The telescope so far: three off-axis aspheres</a:t>
             </a:r>
           </a:p>
         </p:txBody>
@@ -9177,7 +10041,25 @@
                 </a:solidFill>
                 <a:latin typeface="Arial"/>
               </a:rPr>
-              <a:t>•  9 The spectrometer of record for the 1.5k module</a:t>
+              <a:t>•  </a:t>
+            </a:r>
+            <a:r>
+              <a:rPr sz="1400" b="1">
+                <a:solidFill>
+                  <a:srgbClr val="282828"/>
+                </a:solidFill>
+                <a:latin typeface="Arial"/>
+              </a:rPr>
+              <a:t>9</a:t>
+            </a:r>
+            <a:r>
+              <a:rPr sz="1400" b="0">
+                <a:solidFill>
+                  <a:srgbClr val="282828"/>
+                </a:solidFill>
+                <a:latin typeface="Arial"/>
+              </a:rPr>
+              <a:t> The spectrometer of record for the 1.5k module</a:t>
             </a:r>
           </a:p>
           <a:p>
@@ -9193,7 +10075,52 @@
                 </a:solidFill>
                 <a:latin typeface="Arial"/>
               </a:rPr>
-              <a:t>•  10 To fill the swath: two of 3k pixels in CaF2 or four of 1.5k in silica?</a:t>
+              <a:t>•  </a:t>
+            </a:r>
+            <a:r>
+              <a:rPr sz="1400" b="1">
+                <a:solidFill>
+                  <a:srgbClr val="282828"/>
+                </a:solidFill>
+                <a:latin typeface="Arial"/>
+              </a:rPr>
+              <a:t>10</a:t>
+            </a:r>
+            <a:r>
+              <a:rPr sz="1400" b="0">
+                <a:solidFill>
+                  <a:srgbClr val="282828"/>
+                </a:solidFill>
+                <a:latin typeface="Arial"/>
+              </a:rPr>
+              <a:t> To fill the swath: two of 3k pixels in </a:t>
+            </a:r>
+            <a:r>
+              <a:rPr sz="1400" b="0">
+                <a:solidFill>
+                  <a:srgbClr val="282828"/>
+                </a:solidFill>
+                <a:latin typeface="Arial"/>
+              </a:rPr>
+              <a:t>CaF</a:t>
+            </a:r>
+            <a:r>
+              <a:rPr sz="1400" b="0" baseline="-25000">
+                <a:solidFill>
+                  <a:srgbClr val="282828"/>
+                </a:solidFill>
+                <a:latin typeface="Arial"/>
+              </a:rPr>
+              <a:t>2</a:t>
+            </a:r>
+            <a:r>
+              <a:rPr sz="1400" b="0">
+                <a:solidFill>
+                  <a:srgbClr val="282828"/>
+                </a:solidFill>
+                <a:latin typeface="Arial"/>
+              </a:rPr>
+              <a:t> or four of 1.5k in silica?</a:t>
             </a:r>
           </a:p>
           <a:p>
@@ -9209,7 +10136,25 @@
                 </a:solidFill>
                 <a:latin typeface="Arial"/>
               </a:rPr>
-              <a:t>•  11 The 3k Dyson module: where it stands</a:t>
+              <a:t>•  </a:t>
+            </a:r>
+            <a:r>
+              <a:rPr sz="1400" b="1">
+                <a:solidFill>
+                  <a:srgbClr val="282828"/>
+                </a:solidFill>
+                <a:latin typeface="Arial"/>
+              </a:rPr>
+              <a:t>11</a:t>
+            </a:r>
+            <a:r>
+              <a:rPr sz="1400" b="0">
+                <a:solidFill>
+                  <a:srgbClr val="282828"/>
+                </a:solidFill>
+                <a:latin typeface="Arial"/>
+              </a:rPr>
+              <a:t> The 3k Dyson module: where it stands</a:t>
             </a:r>
           </a:p>
           <a:p>
@@ -9225,7 +10170,25 @@
                 </a:solidFill>
                 <a:latin typeface="Arial"/>
               </a:rPr>
-              <a:t>•  12 Alternatives to the Dyson for the 3k slit</a:t>
+              <a:t>•  </a:t>
+            </a:r>
+            <a:r>
+              <a:rPr sz="1400" b="1">
+                <a:solidFill>
+                  <a:srgbClr val="282828"/>
+                </a:solidFill>
+                <a:latin typeface="Arial"/>
+              </a:rPr>
+              <a:t>12</a:t>
+            </a:r>
+            <a:r>
+              <a:rPr sz="1400" b="0">
+                <a:solidFill>
+                  <a:srgbClr val="282828"/>
+                </a:solidFill>
+                <a:latin typeface="Arial"/>
+              </a:rPr>
+              <a:t> Alternatives to the Dyson for the 3k slit</a:t>
             </a:r>
           </a:p>
           <a:p>
@@ -9241,7 +10204,25 @@
                 </a:solidFill>
                 <a:latin typeface="Arial"/>
               </a:rPr>
-              <a:t>•  13 Questions</a:t>
+              <a:t>•  </a:t>
+            </a:r>
+            <a:r>
+              <a:rPr sz="1400" b="1">
+                <a:solidFill>
+                  <a:srgbClr val="282828"/>
+                </a:solidFill>
+                <a:latin typeface="Arial"/>
+              </a:rPr>
+              <a:t>13</a:t>
+            </a:r>
+            <a:r>
+              <a:rPr sz="1400" b="0">
+                <a:solidFill>
+                  <a:srgbClr val="282828"/>
+                </a:solidFill>
+                <a:latin typeface="Arial"/>
+              </a:rPr>
+              <a:t> Questions</a:t>
             </a:r>
           </a:p>
           <a:p>
@@ -9257,7 +10238,25 @@
                 </a:solidFill>
                 <a:latin typeface="Arial"/>
               </a:rPr>
-              <a:t>•  14 Next steps</a:t>
+              <a:t>•  </a:t>
+            </a:r>
+            <a:r>
+              <a:rPr sz="1400" b="1">
+                <a:solidFill>
+                  <a:srgbClr val="282828"/>
+                </a:solidFill>
+                <a:latin typeface="Arial"/>
+              </a:rPr>
+              <a:t>14</a:t>
+            </a:r>
+            <a:r>
+              <a:rPr sz="1400" b="0">
+                <a:solidFill>
+                  <a:srgbClr val="282828"/>
+                </a:solidFill>
+                <a:latin typeface="Arial"/>
+              </a:rPr>
+              <a:t> Next steps</a:t>
             </a:r>
           </a:p>
           <a:p>
@@ -9273,7 +10272,25 @@
                 </a:solidFill>
                 <a:latin typeface="Arial"/>
               </a:rPr>
-              <a:t>•  15 Run it yourself</a:t>
+              <a:t>•  </a:t>
+            </a:r>
+            <a:r>
+              <a:rPr sz="1400" b="1">
+                <a:solidFill>
+                  <a:srgbClr val="282828"/>
+                </a:solidFill>
+                <a:latin typeface="Arial"/>
+              </a:rPr>
+              <a:t>15</a:t>
+            </a:r>
+            <a:r>
+              <a:rPr sz="1400" b="0">
+                <a:solidFill>
+                  <a:srgbClr val="282828"/>
+                </a:solidFill>
+                <a:latin typeface="Arial"/>
+              </a:rPr>
+              <a:t> Run it yourself</a:t>
             </a:r>
           </a:p>
           <a:p>
@@ -9289,7 +10306,25 @@
                 </a:solidFill>
                 <a:latin typeface="Arial"/>
               </a:rPr>
-              <a:t>•  16 Backup: how the telescope reached the pixel; the Dyson design ladder; the 54 mm design; the block-size trade; the methods and the checks; thirteen engine findings; records</a:t>
+              <a:t>•  </a:t>
+            </a:r>
+            <a:r>
+              <a:rPr sz="1400" b="1">
+                <a:solidFill>
+                  <a:srgbClr val="282828"/>
+                </a:solidFill>
+                <a:latin typeface="Arial"/>
+              </a:rPr>
+              <a:t>16</a:t>
+            </a:r>
+            <a:r>
+              <a:rPr sz="1400" b="0">
+                <a:solidFill>
+                  <a:srgbClr val="282828"/>
+                </a:solidFill>
+                <a:latin typeface="Arial"/>
+              </a:rPr>
+              <a:t> Backup: how the telescope reached the pixel; the Dyson design ladder; the 54 mm design; the block-size trade; the methods and the checks; thirteen engine findings; records</a:t>
             </a:r>
           </a:p>
         </p:txBody>
@@ -9763,7 +10798,25 @@
                           </a:solidFill>
                           <a:latin typeface="Arial"/>
                         </a:rPr>
-                        <a:t>CaF2, one 54 mm slit, no meniscus</a:t>
+                        <a:t>CaF</a:t>
+                      </a:r>
+                      <a:r>
+                        <a:rPr sz="1100" b="0" baseline="-25000">
+                          <a:solidFill>
+                            <a:srgbClr val="282828"/>
+                          </a:solidFill>
+                          <a:latin typeface="Arial"/>
+                        </a:rPr>
+                        <a:t>2</a:t>
+                      </a:r>
+                      <a:r>
+                        <a:rPr sz="1100" b="0">
+                          <a:solidFill>
+                            <a:srgbClr val="282828"/>
+                          </a:solidFill>
+                          <a:latin typeface="Arial"/>
+                        </a:rPr>
+                        <a:t>, one 54 mm slit, no meniscus</a:t>
                       </a:r>
                     </a:p>
                   </a:txBody>
@@ -10231,7 +11284,25 @@
                           </a:solidFill>
                           <a:latin typeface="Arial"/>
                         </a:rPr>
-                        <a:t>CaF2, two 27 mm slits, smallest matching R4</a:t>
+                        <a:t>CaF</a:t>
+                      </a:r>
+                      <a:r>
+                        <a:rPr sz="1100" b="0" baseline="-25000">
+                          <a:solidFill>
+                            <a:srgbClr val="282828"/>
+                          </a:solidFill>
+                          <a:latin typeface="Arial"/>
+                        </a:rPr>
+                        <a:t>2</a:t>
+                      </a:r>
+                      <a:r>
+                        <a:rPr sz="1100" b="0">
+                          <a:solidFill>
+                            <a:srgbClr val="282828"/>
+                          </a:solidFill>
+                          <a:latin typeface="Arial"/>
+                        </a:rPr>
+                        <a:t>, two 27 mm slits, smallest matching R4</a:t>
                       </a:r>
                     </a:p>
                   </a:txBody>
@@ -10412,7 +11483,79 @@
                 </a:solidFill>
                 <a:latin typeface="Arial"/>
               </a:rPr>
-              <a:t>•  The meniscus was paying for the long slit.  With one 54 mm slit, silica closes only with the meniscus; without one, a single module closes only in CaF2 at 240 mm.  With two modules the plain block matches R4 from 220 mm down to 100 mm in silica and 80 mm in CaF2, with four crossings where R4 has eight and no thin part to make, mount or shake.  Halving the glass path also halves the wavefront error from index inhomogeneity and thermal gradients (0.4 waves each at 220 mm).</a:t>
+              <a:t>•  </a:t>
+            </a:r>
+            <a:r>
+              <a:rPr sz="1500" b="1">
+                <a:solidFill>
+                  <a:srgbClr val="282828"/>
+                </a:solidFill>
+                <a:latin typeface="Arial"/>
+              </a:rPr>
+              <a:t>The meniscus was paying for the long slit.</a:t>
+            </a:r>
+            <a:r>
+              <a:rPr sz="1500" b="0">
+                <a:solidFill>
+                  <a:srgbClr val="282828"/>
+                </a:solidFill>
+                <a:latin typeface="Arial"/>
+              </a:rPr>
+              <a:t>  With one 54 mm slit, silica closes only with the meniscus; without one, a single module closes only in </a:t>
+            </a:r>
+            <a:r>
+              <a:rPr sz="1500" b="0">
+                <a:solidFill>
+                  <a:srgbClr val="282828"/>
+                </a:solidFill>
+                <a:latin typeface="Arial"/>
+              </a:rPr>
+              <a:t>CaF</a:t>
+            </a:r>
+            <a:r>
+              <a:rPr sz="1500" b="0" baseline="-25000">
+                <a:solidFill>
+                  <a:srgbClr val="282828"/>
+                </a:solidFill>
+                <a:latin typeface="Arial"/>
+              </a:rPr>
+              <a:t>2</a:t>
+            </a:r>
+            <a:r>
+              <a:rPr sz="1500" b="0">
+                <a:solidFill>
+                  <a:srgbClr val="282828"/>
+                </a:solidFill>
+                <a:latin typeface="Arial"/>
+              </a:rPr>
+              <a:t> at 240 mm.  With two modules the plain block matches R4 from 220 mm down to 100 mm in silica and 80 mm in </a:t>
+            </a:r>
+            <a:r>
+              <a:rPr sz="1500" b="0">
+                <a:solidFill>
+                  <a:srgbClr val="282828"/>
+                </a:solidFill>
+                <a:latin typeface="Arial"/>
+              </a:rPr>
+              <a:t>CaF</a:t>
+            </a:r>
+            <a:r>
+              <a:rPr sz="1500" b="0" baseline="-25000">
+                <a:solidFill>
+                  <a:srgbClr val="282828"/>
+                </a:solidFill>
+                <a:latin typeface="Arial"/>
+              </a:rPr>
+              <a:t>2</a:t>
+            </a:r>
+            <a:r>
+              <a:rPr sz="1500" b="0">
+                <a:solidFill>
+                  <a:srgbClr val="282828"/>
+                </a:solidFill>
+                <a:latin typeface="Arial"/>
+              </a:rPr>
+              <a:t>, with four crossings where R4 has eight and no thin part to make, mount or shake.  Halving the glass path also halves the wavefront error from index inhomogeneity and thermal gradients (0.4 waves each at 220 mm).</a:t>
             </a:r>
           </a:p>
           <a:p>
@@ -10428,7 +11571,25 @@
                 </a:solidFill>
                 <a:latin typeface="Arial"/>
               </a:rPr>
-              <a:t>•  Throughput routes measured on the 130 mm module: cementing the dewar window to the block, 6 → 4 crossings, 0.81 → 0.87; a two-layer broadband anti-reflection coating, +4 % (a 6:1 band is wide for a simple stack); the two together about 0.91.</a:t>
+              <a:t>•  </a:t>
+            </a:r>
+            <a:r>
+              <a:rPr sz="1500" b="1">
+                <a:solidFill>
+                  <a:srgbClr val="282828"/>
+                </a:solidFill>
+                <a:latin typeface="Arial"/>
+              </a:rPr>
+              <a:t>Throughput routes measured on the 130 mm module:</a:t>
+            </a:r>
+            <a:r>
+              <a:rPr sz="1500" b="0">
+                <a:solidFill>
+                  <a:srgbClr val="282828"/>
+                </a:solidFill>
+                <a:latin typeface="Arial"/>
+              </a:rPr>
+              <a:t> cementing the dewar window to the block, 6 → 4 crossings, 0.81 → 0.87; a two-layer broadband anti-reflection coating, +4 % (a 6:1 band is wide for a simple stack); the two together about 0.91.</a:t>
             </a:r>
           </a:p>
         </p:txBody>
@@ -10613,7 +11774,7 @@
           <a:p>
             <a:pPr>
               <a:spcAft>
-                <a:spcPts val="600"/>
+                <a:spcPts val="1400"/>
               </a:spcAft>
             </a:pPr>
             <a:r>
@@ -10623,13 +11784,31 @@
                 </a:solidFill>
                 <a:latin typeface="Arial"/>
               </a:rPr>
-              <a:t>•  Ray tracing (MACOS): rays leave a point on the slit at one wavelength, refract through the block, diffract at the grating into the design order and land on the detector; the centroid per slit position and wavelength gives smile and keystone, the spread convolved with the slit and the pixel gives the response functions.  End to end, the rays leave the sky and the grating is the stop.</a:t>
+              <a:t>•  </a:t>
+            </a:r>
+            <a:r>
+              <a:rPr sz="1300" b="1">
+                <a:solidFill>
+                  <a:srgbClr val="282828"/>
+                </a:solidFill>
+                <a:latin typeface="Arial"/>
+              </a:rPr>
+              <a:t>Ray tracing (MACOS):</a:t>
+            </a:r>
+            <a:r>
+              <a:rPr sz="1300" b="0">
+                <a:solidFill>
+                  <a:srgbClr val="282828"/>
+                </a:solidFill>
+                <a:latin typeface="Arial"/>
+              </a:rPr>
+              <a:t> rays leave a point on the slit at one wavelength, refract through the block, diffract at the grating into the design order and land on the detector; the centroid per slit position and wavelength gives smile and keystone, the spread convolved with the slit and the pixel gives the response functions.  End to end, the rays leave the sky and the grating is the stop.</a:t>
             </a:r>
           </a:p>
           <a:p>
             <a:pPr>
               <a:spcAft>
-                <a:spcPts val="600"/>
+                <a:spcPts val="1400"/>
               </a:spcAft>
             </a:pPr>
             <a:r>
@@ -10639,13 +11818,31 @@
                 </a:solidFill>
                 <a:latin typeface="Arial"/>
               </a:rPr>
-              <a:t>•  Wave propagation: the same prescription carried as a complex wavefront to the detector; its point-spread function's centroid equals the ray centroid to 0.002 px at every slit position and wavelength, so a detector sees the ray numbers.  Across a grating the comparison is made in phase (modulo λ).</a:t>
+              <a:t>•  </a:t>
+            </a:r>
+            <a:r>
+              <a:rPr sz="1300" b="1">
+                <a:solidFill>
+                  <a:srgbClr val="282828"/>
+                </a:solidFill>
+                <a:latin typeface="Arial"/>
+              </a:rPr>
+              <a:t>Wave propagation:</a:t>
+            </a:r>
+            <a:r>
+              <a:rPr sz="1300" b="0">
+                <a:solidFill>
+                  <a:srgbClr val="282828"/>
+                </a:solidFill>
+                <a:latin typeface="Arial"/>
+              </a:rPr>
+              <a:t> the same prescription carried as a complex wavefront to the detector; its point-spread function's centroid equals the ray centroid to 0.002 px at every slit position and wavelength, so a detector sees the ray numbers.  Across a grating the comparison is made in phase (modulo λ).</a:t>
             </a:r>
           </a:p>
           <a:p>
             <a:pPr>
               <a:spcAft>
-                <a:spcPts val="600"/>
+                <a:spcPts val="1400"/>
               </a:spcAft>
             </a:pPr>
             <a:r>
@@ -10655,7 +11852,25 @@
                 </a:solidFill>
                 <a:latin typeface="Arial"/>
               </a:rPr>
-              <a:t>•  Two programs, one prescription: the design solver (MATLAB) lays out each form and writes the prescription; MACOS traces it on its own; every ray is re-traced by the solver and the two agree to 1e-9 m at every surface (1e-12 m with the aspheric block face, where a solver that ignores the asphere misses by 0.26 mm).  For the freeform telescope decks, which the solver cannot model, the end-to-end join is placed from engine traces and reproduces the solver's join on an aspheric deck to every printed digit.</a:t>
+              <a:t>•  </a:t>
+            </a:r>
+            <a:r>
+              <a:rPr sz="1300" b="1">
+                <a:solidFill>
+                  <a:srgbClr val="282828"/>
+                </a:solidFill>
+                <a:latin typeface="Arial"/>
+              </a:rPr>
+              <a:t>Two programs, one prescription:</a:t>
+            </a:r>
+            <a:r>
+              <a:rPr sz="1300" b="0">
+                <a:solidFill>
+                  <a:srgbClr val="282828"/>
+                </a:solidFill>
+                <a:latin typeface="Arial"/>
+              </a:rPr>
+              <a:t> the design solver (MATLAB) lays out each form and writes the prescription; MACOS traces it on its own; every ray is re-traced by the solver and the two agree to 1e-9 m at every surface (1e-12 m with the aspheric block face, where a solver that ignores the asphere misses by 0.26 mm).  For the freeform telescope decks, which the solver cannot model, the end-to-end join is placed from engine traces and reproduces the solver's join on an aspheric deck to every printed digit.</a:t>
             </a:r>
           </a:p>
         </p:txBody>
@@ -10684,7 +11899,7 @@
           <a:p>
             <a:pPr>
               <a:spcAft>
-                <a:spcPts val="600"/>
+                <a:spcPts val="1400"/>
               </a:spcAft>
             </a:pPr>
             <a:r>
@@ -10694,13 +11909,31 @@
                 </a:solidFill>
                 <a:latin typeface="Arial"/>
               </a:rPr>
-              <a:t>•  The optimizer: the design layer's native multi-field solve (MACOS CALIB) for the conics and aspheres; a Levenberg–Marquardt solve on the engine's own per-ray spot residuals, with Jacobian scaling, for the freeform and geometry steps.  Solves run to a fixed evaluation budget.</a:t>
+              <a:t>•  </a:t>
+            </a:r>
+            <a:r>
+              <a:rPr sz="1300" b="1">
+                <a:solidFill>
+                  <a:srgbClr val="282828"/>
+                </a:solidFill>
+                <a:latin typeface="Arial"/>
+              </a:rPr>
+              <a:t>The optimizer:</a:t>
+            </a:r>
+            <a:r>
+              <a:rPr sz="1300" b="0">
+                <a:solidFill>
+                  <a:srgbClr val="282828"/>
+                </a:solidFill>
+                <a:latin typeface="Arial"/>
+              </a:rPr>
+              <a:t> the design layer's native multi-field solve (MACOS CALIB) for the conics and aspheres; a Levenberg–Marquardt solve on the engine's own per-ray spot residuals, with Jacobian scaling, for the freeform and geometry steps.  Solves run to a fixed evaluation budget.</a:t>
             </a:r>
           </a:p>
           <a:p>
             <a:pPr>
               <a:spcAft>
-                <a:spcPts val="600"/>
+                <a:spcPts val="1400"/>
               </a:spcAft>
             </a:pPr>
             <a:r>
@@ -10710,13 +11943,31 @@
                 </a:solidFill>
                 <a:latin typeface="Arial"/>
               </a:rPr>
-              <a:t>•  Clearance: every design passes a check of each beam leg against every body (mirror blanks on their best-fit spheres, the block, the slit mask, the detector package with a 5 mm carrier); the number quoted is the worst pair's margin.</a:t>
+              <a:t>•  </a:t>
+            </a:r>
+            <a:r>
+              <a:rPr sz="1300" b="1">
+                <a:solidFill>
+                  <a:srgbClr val="282828"/>
+                </a:solidFill>
+                <a:latin typeface="Arial"/>
+              </a:rPr>
+              <a:t>Clearance:</a:t>
+            </a:r>
+            <a:r>
+              <a:rPr sz="1300" b="0">
+                <a:solidFill>
+                  <a:srgbClr val="282828"/>
+                </a:solidFill>
+                <a:latin typeface="Arial"/>
+              </a:rPr>
+              <a:t> every design passes a check of each beam leg against every body (mirror blanks on their best-fit spheres, the block, the slit mask, the detector package with a 5 mm carrier); the number quoted is the worst pair's margin.</a:t>
             </a:r>
           </a:p>
           <a:p>
             <a:pPr>
               <a:spcAft>
-                <a:spcPts val="600"/>
+                <a:spcPts val="1400"/>
               </a:spcAft>
             </a:pPr>
             <a:r>
@@ -10726,7 +11977,25 @@
                 </a:solidFill>
                 <a:latin typeface="Arial"/>
               </a:rPr>
-              <a:t>•  Slit diffraction loss: a 36 µm slit at F/1.8 loses 0.3 % of the light past the grating at 380 nm and 1.8 % at 2500 nm, by the engine's far-field leg and by the closed sinc² form alike.</a:t>
+              <a:t>•  </a:t>
+            </a:r>
+            <a:r>
+              <a:rPr sz="1300" b="1">
+                <a:solidFill>
+                  <a:srgbClr val="282828"/>
+                </a:solidFill>
+                <a:latin typeface="Arial"/>
+              </a:rPr>
+              <a:t>Slit diffraction loss:</a:t>
+            </a:r>
+            <a:r>
+              <a:rPr sz="1300" b="0">
+                <a:solidFill>
+                  <a:srgbClr val="282828"/>
+                </a:solidFill>
+                <a:latin typeface="Arial"/>
+              </a:rPr>
+              <a:t> a 36 µm slit at F/1.8 loses 0.3 % of the light past the grating at 380 nm and 1.8 % at 2500 nm, by the engine's far-field leg and by the closed sinc² form alike.</a:t>
             </a:r>
           </a:p>
         </p:txBody>
@@ -13831,7 +15100,43 @@
                 </a:solidFill>
                 <a:latin typeface="Arial"/>
               </a:rPr>
-              <a:t>•  Smile: centroid drift along the slit at fixed wavelength; keystone: drift across wavelength at fixed slit position; both in pixels from ray centroids.</a:t>
+              <a:t>•  </a:t>
+            </a:r>
+            <a:r>
+              <a:rPr sz="1200" b="1">
+                <a:solidFill>
+                  <a:srgbClr val="282828"/>
+                </a:solidFill>
+                <a:latin typeface="Arial"/>
+              </a:rPr>
+              <a:t>Smile:</a:t>
+            </a:r>
+            <a:r>
+              <a:rPr sz="1200" b="0">
+                <a:solidFill>
+                  <a:srgbClr val="282828"/>
+                </a:solidFill>
+                <a:latin typeface="Arial"/>
+              </a:rPr>
+              <a:t> centroid drift along the slit at fixed wavelength; </a:t>
+            </a:r>
+            <a:r>
+              <a:rPr sz="1200" b="1">
+                <a:solidFill>
+                  <a:srgbClr val="282828"/>
+                </a:solidFill>
+                <a:latin typeface="Arial"/>
+              </a:rPr>
+              <a:t>keystone:</a:t>
+            </a:r>
+            <a:r>
+              <a:rPr sz="1200" b="0">
+                <a:solidFill>
+                  <a:srgbClr val="282828"/>
+                </a:solidFill>
+                <a:latin typeface="Arial"/>
+              </a:rPr>
+              <a:t> drift across wavelength at fixed slit position; both in pixels from ray centroids.</a:t>
             </a:r>
           </a:p>
           <a:p>
@@ -13847,7 +15152,25 @@
                 </a:solidFill>
                 <a:latin typeface="Arial"/>
               </a:rPr>
-              <a:t>•  SRF, CRF: slit ⊗ line-spread function ⊗ pixel ⊗ Airy, FWHM in pixels (Mouroulis &amp; Green 2018); the Airy diameter at 2500 nm is 11 µm, under the pixel, so the incoherent chain is valid.</a:t>
+              <a:t>•  </a:t>
+            </a:r>
+            <a:r>
+              <a:rPr sz="1200" b="1">
+                <a:solidFill>
+                  <a:srgbClr val="282828"/>
+                </a:solidFill>
+                <a:latin typeface="Arial"/>
+              </a:rPr>
+              <a:t>SRF, CRF:</a:t>
+            </a:r>
+            <a:r>
+              <a:rPr sz="1200" b="0">
+                <a:solidFill>
+                  <a:srgbClr val="282828"/>
+                </a:solidFill>
+                <a:latin typeface="Arial"/>
+              </a:rPr>
+              <a:t> slit ⊗ line-spread function ⊗ pixel ⊗ Airy, FWHM in pixels (Mouroulis &amp; Green 2018); the Airy diameter at 2500 nm is 11 µm, under the pixel, so the incoherent chain is valid.</a:t>
             </a:r>
           </a:p>
           <a:p>
@@ -13863,7 +15186,25 @@
                 </a:solidFill>
                 <a:latin typeface="Arial"/>
               </a:rPr>
-              <a:t>•  Energy in one pixel: the fraction of a point image inside one 18 µm pixel; the literature's design rule is 0.75.</a:t>
+              <a:t>•  </a:t>
+            </a:r>
+            <a:r>
+              <a:rPr sz="1200" b="1">
+                <a:solidFill>
+                  <a:srgbClr val="282828"/>
+                </a:solidFill>
+                <a:latin typeface="Arial"/>
+              </a:rPr>
+              <a:t>Energy in one pixel:</a:t>
+            </a:r>
+            <a:r>
+              <a:rPr sz="1200" b="0">
+                <a:solidFill>
+                  <a:srgbClr val="282828"/>
+                </a:solidFill>
+                <a:latin typeface="Arial"/>
+              </a:rPr>
+              <a:t> the fraction of a point image inside one 18 µm pixel; the literature's design rule is 0.75.</a:t>
             </a:r>
           </a:p>
           <a:p>
@@ -13879,7 +15220,43 @@
                 </a:solidFill>
                 <a:latin typeface="Arial"/>
               </a:rPr>
-              <a:t>•  A module is one telescope, one spectrometer and one detector; end to end is one prescription from the sky to the detector, the grating its stop, scored by the spectrometer's own scorer.</a:t>
+              <a:t>•  </a:t>
+            </a:r>
+            <a:r>
+              <a:rPr sz="1200" b="1">
+                <a:solidFill>
+                  <a:srgbClr val="282828"/>
+                </a:solidFill>
+                <a:latin typeface="Arial"/>
+              </a:rPr>
+              <a:t>A module</a:t>
+            </a:r>
+            <a:r>
+              <a:rPr sz="1200" b="0">
+                <a:solidFill>
+                  <a:srgbClr val="282828"/>
+                </a:solidFill>
+                <a:latin typeface="Arial"/>
+              </a:rPr>
+              <a:t> is one telescope, one spectrometer and one detector; </a:t>
+            </a:r>
+            <a:r>
+              <a:rPr sz="1200" b="1">
+                <a:solidFill>
+                  <a:srgbClr val="282828"/>
+                </a:solidFill>
+                <a:latin typeface="Arial"/>
+              </a:rPr>
+              <a:t>end to end</a:t>
+            </a:r>
+            <a:r>
+              <a:rPr sz="1200" b="0">
+                <a:solidFill>
+                  <a:srgbClr val="282828"/>
+                </a:solidFill>
+                <a:latin typeface="Arial"/>
+              </a:rPr>
+              <a:t> is one prescription from the sky to the detector, the grating its stop, scored by the spectrometer's own scorer.</a:t>
             </a:r>
           </a:p>
           <a:p>
@@ -13895,7 +15272,25 @@
                 </a:solidFill>
                 <a:latin typeface="Arial"/>
               </a:rPr>
-              <a:t>•  As-built realism (Jim): SRF 2.5–3 pixels, slits 2 pixels wide, photon-limited systems; smile and keystone drive the design.</a:t>
+              <a:t>•  </a:t>
+            </a:r>
+            <a:r>
+              <a:rPr sz="1200" b="1">
+                <a:solidFill>
+                  <a:srgbClr val="282828"/>
+                </a:solidFill>
+                <a:latin typeface="Arial"/>
+              </a:rPr>
+              <a:t>As-built realism (Jim):</a:t>
+            </a:r>
+            <a:r>
+              <a:rPr sz="1200" b="0">
+                <a:solidFill>
+                  <a:srgbClr val="282828"/>
+                </a:solidFill>
+                <a:latin typeface="Arial"/>
+              </a:rPr>
+              <a:t> SRF 2.5–3 pixels, slits 2 pixels wide, photon-limited systems; smile and keystone drive the design.</a:t>
             </a:r>
           </a:p>
         </p:txBody>
@@ -14080,7 +15475,7 @@
           <a:p>
             <a:pPr>
               <a:spcAft>
-                <a:spcPts val="600"/>
+                <a:spcPts val="1400"/>
               </a:spcAft>
             </a:pPr>
             <a:r>
@@ -14090,13 +15485,31 @@
                 </a:solidFill>
                 <a:latin typeface="Arial"/>
               </a:rPr>
-              <a:t>•  What it does: from 550 km, each 18 µm pixel sees 30 m on the ground; a line of 6000 pixels across the track is a 180 km swath, 18.8° wide; the spacecraft's motion sweeps the line along the track; the spectrometer spreads each pixel's light over 500 bands at 4.24 nm per band from 380 to 2500 nm, at F/1.8.  Smile and keystone under 0.1 pixel keep every band of a pixel on the same ground, and the response widths near 1–2 pixels keep the bands and the pixels distinct.</a:t>
+              <a:t>•  </a:t>
+            </a:r>
+            <a:r>
+              <a:rPr sz="1400" b="1">
+                <a:solidFill>
+                  <a:srgbClr val="282828"/>
+                </a:solidFill>
+                <a:latin typeface="Arial"/>
+              </a:rPr>
+              <a:t>What it does:</a:t>
+            </a:r>
+            <a:r>
+              <a:rPr sz="1400" b="0">
+                <a:solidFill>
+                  <a:srgbClr val="282828"/>
+                </a:solidFill>
+                <a:latin typeface="Arial"/>
+              </a:rPr>
+              <a:t> from 550 km, each 18 µm pixel sees 30 m on the ground; a line of 6000 pixels across the track is a 180 km swath, 18.8° wide; the spacecraft's motion sweeps the line along the track; the spectrometer spreads each pixel's light over 500 bands at 4.24 nm per band from 380 to 2500 nm, at F/1.8.  Smile and keystone under 0.1 pixel keep every band of a pixel on the same ground, and the response widths near 1–2 pixels keep the bands and the pixels distinct.</a:t>
             </a:r>
           </a:p>
           <a:p>
             <a:pPr>
               <a:spcAft>
-                <a:spcPts val="600"/>
+                <a:spcPts val="1400"/>
               </a:spcAft>
             </a:pPr>
             <a:r>
@@ -14106,13 +15519,31 @@
                 </a:solidFill>
                 <a:latin typeface="Arial"/>
               </a:rPr>
-              <a:t>•  A module is one telescope, one slit, one spectrometer, one detector.  The swath is divided among the modules; each telescope points at its own strip and the strips abut.  The spec is met module by module, and the whole swath is the sum.</a:t>
+              <a:t>•  </a:t>
+            </a:r>
+            <a:r>
+              <a:rPr sz="1400" b="1">
+                <a:solidFill>
+                  <a:srgbClr val="282828"/>
+                </a:solidFill>
+                <a:latin typeface="Arial"/>
+              </a:rPr>
+              <a:t>A module</a:t>
+            </a:r>
+            <a:r>
+              <a:rPr sz="1400" b="0">
+                <a:solidFill>
+                  <a:srgbClr val="282828"/>
+                </a:solidFill>
+                <a:latin typeface="Arial"/>
+              </a:rPr>
+              <a:t> is one telescope, one slit, one spectrometer, one detector.  The swath is divided among the modules; each telescope points at its own strip and the strips abut.  The spec is met module by module, and the whole swath is the sum.</a:t>
             </a:r>
           </a:p>
           <a:p>
             <a:pPr>
               <a:spcAft>
-                <a:spcPts val="600"/>
+                <a:spcPts val="1400"/>
               </a:spcAft>
             </a:pPr>
             <a:r>
@@ -14122,7 +15553,25 @@
                 </a:solidFill>
                 <a:latin typeface="Arial"/>
               </a:rPr>
-              <a:t>•  Two ways to cut it: two modules of 3000 pixels (a 54 mm slit, a 9.4° telescope each) or four of 1500 (27 mm, 4.7°).  Same pixels, same ground sample, same bands, same F-number, same outer edge of the swath (9.4° off nadir either way); they differ in slit length, and everything on the right follows from that.</a:t>
+              <a:t>•  </a:t>
+            </a:r>
+            <a:r>
+              <a:rPr sz="1400" b="1">
+                <a:solidFill>
+                  <a:srgbClr val="282828"/>
+                </a:solidFill>
+                <a:latin typeface="Arial"/>
+              </a:rPr>
+              <a:t>Two ways to cut it:</a:t>
+            </a:r>
+            <a:r>
+              <a:rPr sz="1400" b="0">
+                <a:solidFill>
+                  <a:srgbClr val="282828"/>
+                </a:solidFill>
+                <a:latin typeface="Arial"/>
+              </a:rPr>
+              <a:t> two modules of 3000 pixels (a 54 mm slit, a 9.4° telescope each) or four of 1500 (27 mm, 4.7°).  Same pixels, same ground sample, same bands, same F-number, same outer edge of the swath (9.4° off nadir either way); they differ in slit length, and everything on the right follows from that.</a:t>
             </a:r>
           </a:p>
         </p:txBody>
@@ -14379,7 +15828,25 @@
                           </a:solidFill>
                           <a:latin typeface="Arial"/>
                         </a:rPr>
-                        <a:t>CaF2, 240 mm</a:t>
+                        <a:t>CaF</a:t>
+                      </a:r>
+                      <a:r>
+                        <a:rPr sz="1000" b="0" baseline="-25000">
+                          <a:solidFill>
+                            <a:srgbClr val="282828"/>
+                          </a:solidFill>
+                          <a:latin typeface="Arial"/>
+                        </a:rPr>
+                        <a:t>2</a:t>
+                      </a:r>
+                      <a:r>
+                        <a:rPr sz="1000" b="0">
+                          <a:solidFill>
+                            <a:srgbClr val="282828"/>
+                          </a:solidFill>
+                          <a:latin typeface="Arial"/>
+                        </a:rPr>
+                        <a:t>, 240 mm</a:t>
                       </a:r>
                     </a:p>
                   </a:txBody>
@@ -14654,7 +16121,34 @@
                 </a:solidFill>
                 <a:latin typeface="Arial"/>
               </a:rPr>
-              <a:t>The block follows the slit (slide 9): halving the slit halves the block's thickness and drops the meniscus and the CaF2; the telescope's field halves with it, which is what made the 1.5k telescope reachable first.  The 6000-pixel swath is Jim's framing of the trade; Joe's specification is written per 3000-pixel module.</a:t>
+              <a:t>The block follows the slit (slide 9): halving the slit halves the block's thickness and drops the meniscus and the </a:t>
+            </a:r>
+            <a:r>
+              <a:rPr sz="1050" b="0">
+                <a:solidFill>
+                  <a:srgbClr val="6E6E6E"/>
+                </a:solidFill>
+                <a:latin typeface="Arial"/>
+              </a:rPr>
+              <a:t>CaF</a:t>
+            </a:r>
+            <a:r>
+              <a:rPr sz="1050" b="0" baseline="-25000">
+                <a:solidFill>
+                  <a:srgbClr val="6E6E6E"/>
+                </a:solidFill>
+                <a:latin typeface="Arial"/>
+              </a:rPr>
+              <a:t>2</a:t>
+            </a:r>
+            <a:r>
+              <a:rPr sz="1050" b="0">
+                <a:solidFill>
+                  <a:srgbClr val="6E6E6E"/>
+                </a:solidFill>
+                <a:latin typeface="Arial"/>
+              </a:rPr>
+              <a:t>; the telescope's field halves with it, which is what made the 1.5k telescope reachable first.  The 6000-pixel swath is Jim's framing of the trade; Joe's specification is written per 3000-pixel module.</a:t>
             </a:r>
           </a:p>
         </p:txBody>
@@ -17750,7 +19244,25 @@
                 </a:solidFill>
                 <a:latin typeface="Arial"/>
               </a:rPr>
-              <a:t>•  Geometry: the beam passes 190 mm from the parent axis, the strip is biased 4° and the Dyson is rolled 180° about the chief ray; from the first-order layout M2 is tilted 0.95° and moved 6 mm, M3 tilted 6.6° and moved 24 mm, the focal plane 8.5 mm along the axis.  No hole, no central obstruction.</a:t>
+              <a:t>•  </a:t>
+            </a:r>
+            <a:r>
+              <a:rPr sz="1200" b="1">
+                <a:solidFill>
+                  <a:srgbClr val="282828"/>
+                </a:solidFill>
+                <a:latin typeface="Arial"/>
+              </a:rPr>
+              <a:t>Geometry:</a:t>
+            </a:r>
+            <a:r>
+              <a:rPr sz="1200" b="0">
+                <a:solidFill>
+                  <a:srgbClr val="282828"/>
+                </a:solidFill>
+                <a:latin typeface="Arial"/>
+              </a:rPr>
+              <a:t> the beam passes 190 mm from the parent axis, the strip is biased 4° and the Dyson is rolled 180° about the chief ray; from the first-order layout M2 is tilted 0.95° and moved 6 mm, M3 tilted 6.6° and moved 24 mm, the focal plane 8.5 mm along the axis.  No hole, no central obstruction.</a:t>
             </a:r>
           </a:p>
           <a:p>
@@ -17766,7 +19278,25 @@
                 </a:solidFill>
                 <a:latin typeface="Arial"/>
               </a:rPr>
-              <a:t>•  Image as placed: 8 µm rms at the strip center, 14 µm at the ±2.3° edge (0.4 / 0.8 pixel); every field admitted; the strip's chief rays within 0.5° of each other at the slit.</a:t>
+              <a:t>•  </a:t>
+            </a:r>
+            <a:r>
+              <a:rPr sz="1200" b="1">
+                <a:solidFill>
+                  <a:srgbClr val="282828"/>
+                </a:solidFill>
+                <a:latin typeface="Arial"/>
+              </a:rPr>
+              <a:t>Image as placed:</a:t>
+            </a:r>
+            <a:r>
+              <a:rPr sz="1200" b="0">
+                <a:solidFill>
+                  <a:srgbClr val="282828"/>
+                </a:solidFill>
+                <a:latin typeface="Arial"/>
+              </a:rPr>
+              <a:t> 8 µm rms at the strip center, 14 µm at the ±2.3° edge (0.4 / 0.8 pixel); every field admitted; the strip's chief rays within 0.5° of each other at the slit.</a:t>
             </a:r>
           </a:p>
           <a:p>
@@ -17782,7 +19312,25 @@
                 </a:solidFill>
                 <a:latin typeface="Arial"/>
               </a:rPr>
-              <a:t>•  Not done: the strip ends sit at 0.8 px (0.3–0.5 of the energy in a pixel through the Dyson); M1 departs 2.1 mm from its best-fit sphere and M3 is tilted 6.6°; no tolerancing, no coatings, no stray-light or mirror sizing; the solve ran to a fixed budget and is not converged.  Help in bringing it home is one of the questions (slide 13).</a:t>
+              <a:t>•  </a:t>
+            </a:r>
+            <a:r>
+              <a:rPr sz="1200" b="1">
+                <a:solidFill>
+                  <a:srgbClr val="282828"/>
+                </a:solidFill>
+                <a:latin typeface="Arial"/>
+              </a:rPr>
+              <a:t>Not done:</a:t>
+            </a:r>
+            <a:r>
+              <a:rPr sz="1200" b="0">
+                <a:solidFill>
+                  <a:srgbClr val="282828"/>
+                </a:solidFill>
+                <a:latin typeface="Arial"/>
+              </a:rPr>
+              <a:t> the strip ends sit at 0.8 px (0.3–0.5 of the energy in a pixel through the Dyson); M1 departs 2.1 mm from its best-fit sphere and M3 is tilted 6.6°; no tolerancing, no coatings, no stray-light or mirror sizing; the solve ran to a fixed budget and is not converged.  Help in bringing it home is one of the questions (slide 13).</a:t>
             </a:r>
           </a:p>
         </p:txBody>
@@ -17833,7 +19381,7 @@
           </a:bodyPr>
           <a:lstStyle/>
           <a:p>
-            <a:pPr algn="ctr">
+            <a:pPr algn="r">
               <a:spcAft>
                 <a:spcPts val="0"/>
               </a:spcAft>
@@ -18040,7 +19588,25 @@
                 </a:solidFill>
                 <a:latin typeface="Arial"/>
               </a:rPr>
-              <a:t>•  The block follows the slit.  In the Dyson form the flat face sits at the center of curvature, so the block's thickness is its radius, and the corner blur grows as h⁴/r³ with the slit's half-length h.  Halving the slit from 54 to 27 mm lets the block fall from 220 mm to 130 mm and drops the meniscus.</a:t>
+              <a:t>•  </a:t>
+            </a:r>
+            <a:r>
+              <a:rPr sz="1200" b="1">
+                <a:solidFill>
+                  <a:srgbClr val="282828"/>
+                </a:solidFill>
+                <a:latin typeface="Arial"/>
+              </a:rPr>
+              <a:t>The block follows the slit.</a:t>
+            </a:r>
+            <a:r>
+              <a:rPr sz="1200" b="0">
+                <a:solidFill>
+                  <a:srgbClr val="282828"/>
+                </a:solidFill>
+                <a:latin typeface="Arial"/>
+              </a:rPr>
+              <a:t>  In the Dyson form the flat face sits at the center of curvature, so the block's thickness is its radius, and the corner blur grows as h⁴/r³ with the slit's half-length h.  Halving the slit from 54 to 27 mm lets the block fall from 220 mm to 130 mm and drops the meniscus.</a:t>
             </a:r>
           </a:p>
           <a:p>
@@ -18056,7 +19622,25 @@
                 </a:solidFill>
                 <a:latin typeface="Arial"/>
               </a:rPr>
-              <a:t>•  The 27 mm module, at 130 mm: CRF 1.03 px, SRF 2.02 px, smile 0.007, keystone 0.009 px, 1.00 of the energy in one pixel; grating 171 mm across on a 0.41 m radius; slit plane to grating 414 mm; 0.75 L, 1.6 kg edged; uncoated throughput 0.87 over four crossings.  It tolerates 1.5 mm of air at the slit and detector for free (CRF 1.04 px).</a:t>
+              <a:t>•  </a:t>
+            </a:r>
+            <a:r>
+              <a:rPr sz="1200" b="1">
+                <a:solidFill>
+                  <a:srgbClr val="282828"/>
+                </a:solidFill>
+                <a:latin typeface="Arial"/>
+              </a:rPr>
+              <a:t>The 27 mm module, at 130 mm:</a:t>
+            </a:r>
+            <a:r>
+              <a:rPr sz="1200" b="0">
+                <a:solidFill>
+                  <a:srgbClr val="282828"/>
+                </a:solidFill>
+                <a:latin typeface="Arial"/>
+              </a:rPr>
+              <a:t> CRF 1.03 px, SRF 2.02 px, smile 0.007, keystone 0.009 px, 1.00 of the energy in one pixel; grating 171 mm across on a 0.41 m radius; slit plane to grating 414 mm; 0.75 L, 1.6 kg edged; uncoated throughput 0.87 over four crossings.  It tolerates 1.5 mm of air at the slit and detector for free (CRF 1.04 px).</a:t>
             </a:r>
           </a:p>
           <a:p>
@@ -18072,7 +19656,52 @@
                 </a:solidFill>
                 <a:latin typeface="Arial"/>
               </a:rPr>
-              <a:t>•  The 54 mm single module, for comparison: silica needs the 220 mm block and a 4 mm meniscus (CRF 1.33 px, 0.76 in one pixel, eight crossings, 8.2 kg); CaF2 at 240 mm needs none (CRF 1.21 px, 0.82, 14.3 kg).</a:t>
+              <a:t>•  </a:t>
+            </a:r>
+            <a:r>
+              <a:rPr sz="1200" b="1">
+                <a:solidFill>
+                  <a:srgbClr val="282828"/>
+                </a:solidFill>
+                <a:latin typeface="Arial"/>
+              </a:rPr>
+              <a:t>The 54 mm single module, for comparison:</a:t>
+            </a:r>
+            <a:r>
+              <a:rPr sz="1200" b="0">
+                <a:solidFill>
+                  <a:srgbClr val="282828"/>
+                </a:solidFill>
+                <a:latin typeface="Arial"/>
+              </a:rPr>
+              <a:t> silica needs the 220 mm block and a 4 mm meniscus (CRF 1.33 px, 0.76 in one pixel, eight crossings, 8.2 kg); </a:t>
+            </a:r>
+            <a:r>
+              <a:rPr sz="1200" b="0">
+                <a:solidFill>
+                  <a:srgbClr val="282828"/>
+                </a:solidFill>
+                <a:latin typeface="Arial"/>
+              </a:rPr>
+              <a:t>CaF</a:t>
+            </a:r>
+            <a:r>
+              <a:rPr sz="1200" b="0" baseline="-25000">
+                <a:solidFill>
+                  <a:srgbClr val="282828"/>
+                </a:solidFill>
+                <a:latin typeface="Arial"/>
+              </a:rPr>
+              <a:t>2</a:t>
+            </a:r>
+            <a:r>
+              <a:rPr sz="1200" b="0">
+                <a:solidFill>
+                  <a:srgbClr val="282828"/>
+                </a:solidFill>
+                <a:latin typeface="Arial"/>
+              </a:rPr>
+              <a:t> at 240 mm needs none (CRF 1.21 px, 0.82, 14.3 kg).</a:t>
             </a:r>
           </a:p>
         </p:txBody>

</xml_diff>

<commit_message>
deck_dyson_record: rows re-scored with the grating's aperture enforced (1.5k smile 0.50, 99 % admitted; 3k smile 1.64 / CRF 4.02, 95-98 % admitted; the F/1.2 cone named on the 3k slide); the grating-aperture finding as the sixth row; sidecar keys follow the renamed figures
Co-Authored-By: Claude Fable 5.1 <noreply@anthropic.com>
</commit_message>
<xml_diff>
--- a/demo_session/deck_dyson_record.pptx
+++ b/demo_session/deck_dyson_record.pptx
@@ -3233,7 +3233,7 @@
                 </a:solidFill>
                 <a:latin typeface="Arial"/>
               </a:rPr>
-              <a:t>DRAFT for review, 2026-10-06.  The 1.5k module (1500 cross-track pixels, a 27 mm slit) has a spectrometer of record and a first telescope that together image at the pixel end to end: smile 0.51, keystone 0.01, CRF 1.22, SRF 2.20 pixels, every clearance positive; four such modules carry 6000 pixels in 6.6 kg of fused silica.  The telescope is not finished and the 3k module's resolution is not yet at the pixel level (CRF 4.2 pixels); the deck asks for help with both.</a:t>
+              <a:t>DRAFT for review, 2026-10-06.  The 1.5k module (1500 cross-track pixels, a 27 mm slit) has a spectrometer of record and a first telescope that together image at the pixel end to end: smile 0.50, keystone 0.01, CRF 1.22, SRF 2.20 pixels, every clearance positive; four such modules carry 6000 pixels in 6.6 kg of fused silica.  The telescope is not finished and the 3k module's resolution is not yet at the pixel level (CRF 4.2 pixels); the deck asks for help with both.</a:t>
             </a:r>
           </a:p>
         </p:txBody>
@@ -3763,7 +3763,7 @@
         </p:nvGraphicFramePr>
         <p:xfrm>
           <a:off x="411480" y="1298448"/>
-          <a:ext cx="11368734" cy="3920490"/>
+          <a:ext cx="11368734" cy="4200525"/>
         </p:xfrm>
         <a:graphic>
           <a:graphicData uri="http://schemas.openxmlformats.org/drawingml/2006/table">
@@ -4603,7 +4603,7 @@
                           </a:solidFill>
                           <a:latin typeface="Arial"/>
                         </a:rPr>
-                        <a:t>2.05 / 0.05 / 4.22 / 4.90 px</a:t>
+                        <a:t>1.64 / 0.05 / 4.02 / 4.99 px</a:t>
                       </a:r>
                     </a:p>
                   </a:txBody>
@@ -4625,7 +4625,7 @@
                           </a:solidFill>
                           <a:latin typeface="Arial"/>
                         </a:rPr>
-                        <a:t>0.51 / 0.01 / 1.22 / 2.20 px</a:t>
+                        <a:t>0.50 / 0.01 / 1.22 / 2.20 px</a:t>
                       </a:r>
                     </a:p>
                   </a:txBody>
@@ -4671,7 +4671,7 @@
                           </a:solidFill>
                           <a:latin typeface="Arial"/>
                         </a:rPr>
-                        <a:t>0.05–0.09</a:t>
+                        <a:t>0.04–0.10</a:t>
                       </a:r>
                     </a:p>
                   </a:txBody>
@@ -4768,6 +4768,74 @@
                   <a:tcPr marL="54864" marR="54864" marT="18288" marB="18288">
                     <a:solidFill>
                       <a:srgbClr val="FFFFFF"/>
+                    </a:solidFill>
+                  </a:tcPr>
+                </a:tc>
+              </a:tr>
+              <a:tr h="280035">
+                <a:tc>
+                  <a:txBody>
+                    <a:bodyPr wrap="square"/>
+                    <a:lstStyle/>
+                    <a:p>
+                      <a:r>
+                        <a:rPr sz="1100" b="0">
+                          <a:solidFill>
+                            <a:srgbClr val="282828"/>
+                          </a:solidFill>
+                          <a:latin typeface="Arial"/>
+                        </a:rPr>
+                        <a:t>light admitted by the grating</a:t>
+                      </a:r>
+                    </a:p>
+                  </a:txBody>
+                  <a:tcPr marL="54864" marR="54864" marT="18288" marB="18288">
+                    <a:solidFill>
+                      <a:srgbClr val="ECF1F6"/>
+                    </a:solidFill>
+                  </a:tcPr>
+                </a:tc>
+                <a:tc>
+                  <a:txBody>
+                    <a:bodyPr wrap="square"/>
+                    <a:lstStyle/>
+                    <a:p>
+                      <a:r>
+                        <a:rPr sz="1100" b="0">
+                          <a:solidFill>
+                            <a:srgbClr val="282828"/>
+                          </a:solidFill>
+                          <a:latin typeface="Arial"/>
+                        </a:rPr>
+                        <a:t>95–98 % per field</a:t>
+                      </a:r>
+                    </a:p>
+                  </a:txBody>
+                  <a:tcPr marL="54864" marR="54864" marT="18288" marB="18288">
+                    <a:solidFill>
+                      <a:srgbClr val="ECF1F6"/>
+                    </a:solidFill>
+                  </a:tcPr>
+                </a:tc>
+                <a:tc>
+                  <a:txBody>
+                    <a:bodyPr wrap="square"/>
+                    <a:lstStyle/>
+                    <a:p>
+                      <a:r>
+                        <a:rPr sz="1100" b="0">
+                          <a:solidFill>
+                            <a:srgbClr val="282828"/>
+                          </a:solidFill>
+                          <a:latin typeface="Arial"/>
+                        </a:rPr>
+                        <a:t>99 % per field</a:t>
+                      </a:r>
+                    </a:p>
+                  </a:txBody>
+                  <a:tcPr marL="54864" marR="54864" marT="18288" marB="18288">
+                    <a:solidFill>
+                      <a:srgbClr val="ECF1F6"/>
                     </a:solidFill>
                   </a:tcPr>
                 </a:tc>
@@ -4784,7 +4852,7 @@
         </p:nvSpPr>
         <p:spPr>
           <a:xfrm>
-            <a:off x="411480" y="5365242"/>
+            <a:off x="411480" y="5645277"/>
             <a:ext cx="11368735" cy="274320"/>
           </a:xfrm>
           <a:prstGeom prst="rect">
@@ -4837,7 +4905,7 @@
                 </a:solidFill>
                 <a:latin typeface="Arial"/>
               </a:rPr>
-              <a:t> is not priced here.  A cold detector adds a dewar window to every row alike; cementing it to the block keeps the count at four.  The 3k telescope is the freeform solve of 2026-10-05, scored before its next layout step (slide 12).  Records dyson5_jim_3a.txt, dyson5_t5f_GM_1k5_bAs.txt, dyson5_t5f_GM_3k_c.txt.</a:t>
+              <a:t> is not priced here.  A cold detector adds a dewar window to every row alike; cementing it to the block keeps the count at four.  The 3k telescope is the freeform solve of 2026-10-05, scored before its next layout step (slide 12).  Records dyson5_jim_3a.txt, dyson5_t5f_GM_1k5_bAs_ap.txt, dyson5_t5f_GM_3k_c_ap.txt.</a:t>
             </a:r>
           </a:p>
         </p:txBody>
@@ -4910,7 +4978,7 @@
                 </a:solidFill>
                 <a:latin typeface="Arial"/>
               </a:rPr>
-              <a:t>The same parent with a 9.4° strip needs freeform mirrors and is not yet at the pixel: CRF 2.3–4.2 px, 5–9 % of the energy in one pixel, clearance +0.06 mm</a:t>
+              <a:t>The same parent with a 9.4° strip needs freeform mirrors and is not yet at the pixel: CRF 2.2–4.0 px, 4–10 % of the energy in one pixel, 95–98 % of the light through the grating, clearance +0.06 mm</a:t>
             </a:r>
           </a:p>
         </p:txBody>
@@ -5044,7 +5112,7 @@
                 </a:solidFill>
                 <a:latin typeface="Arial"/>
               </a:rPr>
-              <a:t> Dyson as the engine traces it (meters): the same arrangement as the 1.5k module at twice the strip.</a:t>
+              <a:t> Dyson as the engine traces it (meters); the beam overfills the grating (E7), which clips 2–5 % of the light per field.</a:t>
             </a:r>
           </a:p>
         </p:txBody>
@@ -5058,7 +5126,7 @@
         <p:spPr>
           <a:xfrm>
             <a:off x="411480" y="5001768"/>
-            <a:ext cx="6903720" cy="274320"/>
+            <a:ext cx="6675120" cy="274320"/>
           </a:xfrm>
           <a:prstGeom prst="rect">
             <a:avLst/>
@@ -5101,7 +5169,7 @@
                 </a:solidFill>
                 <a:latin typeface="Arial"/>
               </a:rPr>
-              <a:t> Zernike freeform terms on all three mirrors (M2 carries 1.7 mm of departure at 126 mrad of slope) with the same merit and geometry freedoms as the 1.5k: smile 2.05, keystone 0.05, CRF 4.22, SRF 4.90 px; 98 % of the light admitted at the strip ends; the beam between M2 and M3 passes the block's face by 0.06 mm.</a:t>
+              <a:t> Zernike freeform terms on all three mirrors (M2 carries 1.7 mm of departure at 126 mrad of slope) with the same merit and geometry freedoms as the 1.5k: smile 1.64, keystone 0.05, CRF 4.02, SRF 4.99 px.  Its marginal rays leave at up to F/1.2, so the grating, sized for F/1.8, passes 95–98 % of the light; the beam between M2 and M3 passes the block's face by 0.06 mm.</a:t>
             </a:r>
           </a:p>
           <a:p>
@@ -5160,7 +5228,7 @@
       </p:sp>
       <p:pic>
         <p:nvPicPr>
-          <p:cNvPr id="7" name="Picture 6" descr="dyson5_t5f_GM_3k_c_maps_rc.png"/>
+          <p:cNvPr id="7" name="Picture 6" descr="dyson5_t5f_GM_3k_c_ap_maps_rc.png"/>
           <p:cNvPicPr>
             <a:picLocks noChangeAspect="1"/>
           </p:cNvPicPr>
@@ -5216,7 +5284,7 @@
                 </a:solidFill>
                 <a:latin typeface="Arial"/>
               </a:rPr>
-              <a:t>Per slit position and wavelength: the CRF is 2.3–3.7 px off center and 4.0–4.2 px at the strip center, the signature of a solve that traded the center for the ends under equal field weights.</a:t>
+              <a:t>Per slit position and wavelength: the CRF is 2.2–2.6 px at mid-strip and 3.8–4.0 px at the center and the ends, the signature of a solve that traded under equal field weights.</a:t>
             </a:r>
           </a:p>
         </p:txBody>
@@ -5229,8 +5297,8 @@
         </p:nvSpPr>
         <p:spPr>
           <a:xfrm>
-            <a:off x="7543800" y="5833872"/>
-            <a:ext cx="4343400" cy="274320"/>
+            <a:off x="6400800" y="5835396"/>
+            <a:ext cx="5394960" cy="274320"/>
           </a:xfrm>
           <a:prstGeom prst="rect">
             <a:avLst/>
@@ -5255,7 +5323,7 @@
                 </a:solidFill>
                 <a:latin typeface="Arial"/>
               </a:rPr>
-              <a:t>Record dyson5_t5f_GM_3k_c.txt; prescription dyson5_t5f_GM_3k_c_e2e.in.  The 3k solve ran to the same evaluation budget as the 1.5k and is not converged in the optimizer's sense.</a:t>
+              <a:t>Record dyson5_t5f_GM_3k_c_ap.txt (the grating's aperture enforced; Backup); prescription dyson5_t5f_GM_3k_c_e2e.in.  The solve ran to the 1.5k's evaluation budget and is not converged in the optimizer's sense.</a:t>
             </a:r>
           </a:p>
         </p:txBody>
@@ -10352,7 +10420,7 @@
                 </a:solidFill>
                 <a:latin typeface="Arial"/>
               </a:rPr>
-              <a:t> Backup: how the telescope reached the pixel; the Dyson design ladder; the 54 mm design; the block-size trade; the methods and the checks; thirteen engine findings; records</a:t>
+              <a:t> Backup: how the telescope reached the pixel; the Dyson design ladder; the 54 mm design; the block-size trade; the methods and the checks; fourteen engine findings; records</a:t>
             </a:r>
           </a:p>
         </p:txBody>
@@ -13292,7 +13360,7 @@
                 </a:solidFill>
                 <a:latin typeface="Arial"/>
               </a:rPr>
-              <a:t>Five more findings from the telescope's eccentric section and the Offner</a:t>
+              <a:t>Six more findings: the eccentric section, the Offner, the 3k join</a:t>
             </a:r>
           </a:p>
           <a:p>
@@ -13367,7 +13435,7 @@
         </p:nvGraphicFramePr>
         <p:xfrm>
           <a:off x="411480" y="1298448"/>
-          <a:ext cx="11368734" cy="2811780"/>
+          <a:ext cx="11368734" cy="3846195"/>
         </p:xfrm>
         <a:graphic>
           <a:graphicData uri="http://schemas.openxmlformats.org/drawingml/2006/table">
@@ -13376,9 +13444,9 @@
                 <a:tableStyleId>{5C22544A-7EE6-4342-B048-85BDC9FD1C3A}</a:tableStyleId>
               </a:tblPr>
               <a:tblGrid>
-                <a:gridCol w="1551815"/>
-                <a:gridCol w="5667500"/>
-                <a:gridCol w="4149419"/>
+                <a:gridCol w="1317284"/>
+                <a:gridCol w="6529147"/>
+                <a:gridCol w="3522303"/>
               </a:tblGrid>
               <a:tr h="280035">
                 <a:tc>
@@ -13448,7 +13516,7 @@
                   </a:tcPr>
                 </a:tc>
               </a:tr>
-              <a:tr h="468630">
+              <a:tr h="657225">
                 <a:tc>
                   <a:txBody>
                     <a:bodyPr wrap="square"/>
@@ -13512,6 +13580,74 @@
                   <a:tcPr marL="54864" marR="54864" marT="18288" marB="18288">
                     <a:solidFill>
                       <a:srgbClr val="FFFFFF"/>
+                    </a:solidFill>
+                  </a:tcPr>
+                </a:tc>
+              </a:tr>
+              <a:tr h="657225">
+                <a:tc>
+                  <a:txBody>
+                    <a:bodyPr wrap="square"/>
+                    <a:lstStyle/>
+                    <a:p>
+                      <a:r>
+                        <a:rPr sz="1100" b="0">
+                          <a:solidFill>
+                            <a:srgbClr val="282828"/>
+                          </a:solidFill>
+                          <a:latin typeface="Arial"/>
+                        </a:rPr>
+                        <a:t>optimizer aperture sized at one field</a:t>
+                      </a:r>
+                    </a:p>
+                  </a:txBody>
+                  <a:tcPr marL="54864" marR="54864" marT="18288" marB="18288">
+                    <a:solidFill>
+                      <a:srgbClr val="ECF1F6"/>
+                    </a:solidFill>
+                  </a:tcPr>
+                </a:tc>
+                <a:tc>
+                  <a:txBody>
+                    <a:bodyPr wrap="square"/>
+                    <a:lstStyle/>
+                    <a:p>
+                      <a:r>
+                        <a:rPr sz="1100" b="0">
+                          <a:solidFill>
+                            <a:srgbClr val="282828"/>
+                          </a:solidFill>
+                          <a:latin typeface="Arial"/>
+                        </a:rPr>
+                        <a:t>the strip-edge fields lost every ray on M3 and were dropped by the solve</a:t>
+                      </a:r>
+                    </a:p>
+                  </a:txBody>
+                  <a:tcPr marL="54864" marR="54864" marT="18288" marB="18288">
+                    <a:solidFill>
+                      <a:srgbClr val="ECF1F6"/>
+                    </a:solidFill>
+                  </a:tcPr>
+                </a:tc>
+                <a:tc>
+                  <a:txBody>
+                    <a:bodyPr wrap="square"/>
+                    <a:lstStyle/>
+                    <a:p>
+                      <a:r>
+                        <a:rPr sz="1100" b="0">
+                          <a:solidFill>
+                            <a:srgbClr val="282828"/>
+                          </a:solidFill>
+                          <a:latin typeface="Arial"/>
+                        </a:rPr>
+                        <a:t>the aperture encloses the footprint over every field of the solve</a:t>
+                      </a:r>
+                    </a:p>
+                  </a:txBody>
+                  <a:tcPr marL="54864" marR="54864" marT="18288" marB="18288">
+                    <a:solidFill>
+                      <a:srgbClr val="ECF1F6"/>
                     </a:solidFill>
                   </a:tcPr>
                 </a:tc>
@@ -13529,57 +13665,57 @@
                           </a:solidFill>
                           <a:latin typeface="Arial"/>
                         </a:rPr>
-                        <a:t>optimizer aperture sized at one field</a:t>
-                      </a:r>
-                    </a:p>
-                  </a:txBody>
-                  <a:tcPr marL="54864" marR="54864" marT="18288" marB="18288">
-                    <a:solidFill>
-                      <a:srgbClr val="ECF1F6"/>
-                    </a:solidFill>
-                  </a:tcPr>
-                </a:tc>
-                <a:tc>
-                  <a:txBody>
-                    <a:bodyPr wrap="square"/>
-                    <a:lstStyle/>
-                    <a:p>
-                      <a:r>
-                        <a:rPr sz="1100" b="0">
-                          <a:solidFill>
-                            <a:srgbClr val="282828"/>
-                          </a:solidFill>
-                          <a:latin typeface="Arial"/>
-                        </a:rPr>
-                        <a:t>the strip-edge fields lost every ray on M3 and were dropped by the solve</a:t>
-                      </a:r>
-                    </a:p>
-                  </a:txBody>
-                  <a:tcPr marL="54864" marR="54864" marT="18288" marB="18288">
-                    <a:solidFill>
-                      <a:srgbClr val="ECF1F6"/>
-                    </a:solidFill>
-                  </a:tcPr>
-                </a:tc>
-                <a:tc>
-                  <a:txBody>
-                    <a:bodyPr wrap="square"/>
-                    <a:lstStyle/>
-                    <a:p>
-                      <a:r>
-                        <a:rPr sz="1100" b="0">
-                          <a:solidFill>
-                            <a:srgbClr val="282828"/>
-                          </a:solidFill>
-                          <a:latin typeface="Arial"/>
-                        </a:rPr>
-                        <a:t>the aperture encloses the footprint over every field of the solve</a:t>
-                      </a:r>
-                    </a:p>
-                  </a:txBody>
-                  <a:tcPr marL="54864" marR="54864" marT="18288" marB="18288">
-                    <a:solidFill>
-                      <a:srgbClr val="ECF1F6"/>
+                        <a:t>stop aimed at the parent vertex</a:t>
+                      </a:r>
+                    </a:p>
+                  </a:txBody>
+                  <a:tcPr marL="54864" marR="54864" marT="18288" marB="18288">
+                    <a:solidFill>
+                      <a:srgbClr val="FFFFFF"/>
+                    </a:solidFill>
+                  </a:tcPr>
+                </a:tc>
+                <a:tc>
+                  <a:txBody>
+                    <a:bodyPr wrap="square"/>
+                    <a:lstStyle/>
+                    <a:p>
+                      <a:r>
+                        <a:rPr sz="1100" b="0">
+                          <a:solidFill>
+                            <a:srgbClr val="282828"/>
+                          </a:solidFill>
+                          <a:latin typeface="Arial"/>
+                        </a:rPr>
+                        <a:t>on an eccentric section the pupil sphere was placed 190 mm from the beam</a:t>
+                      </a:r>
+                    </a:p>
+                  </a:txBody>
+                  <a:tcPr marL="54864" marR="54864" marT="18288" marB="18288">
+                    <a:solidFill>
+                      <a:srgbClr val="FFFFFF"/>
+                    </a:solidFill>
+                  </a:tcPr>
+                </a:tc>
+                <a:tc>
+                  <a:txBody>
+                    <a:bodyPr wrap="square"/>
+                    <a:lstStyle/>
+                    <a:p>
+                      <a:r>
+                        <a:rPr sz="1100" b="0">
+                          <a:solidFill>
+                            <a:srgbClr val="282828"/>
+                          </a:solidFill>
+                          <a:latin typeface="Arial"/>
+                        </a:rPr>
+                        <a:t>the stop at the prescription's object-space stop point</a:t>
+                      </a:r>
+                    </a:p>
+                  </a:txBody>
+                  <a:tcPr marL="54864" marR="54864" marT="18288" marB="18288">
+                    <a:solidFill>
+                      <a:srgbClr val="FFFFFF"/>
                     </a:solidFill>
                   </a:tcPr>
                 </a:tc>
@@ -13597,74 +13733,6 @@
                           </a:solidFill>
                           <a:latin typeface="Arial"/>
                         </a:rPr>
-                        <a:t>stop aimed at the parent vertex</a:t>
-                      </a:r>
-                    </a:p>
-                  </a:txBody>
-                  <a:tcPr marL="54864" marR="54864" marT="18288" marB="18288">
-                    <a:solidFill>
-                      <a:srgbClr val="FFFFFF"/>
-                    </a:solidFill>
-                  </a:tcPr>
-                </a:tc>
-                <a:tc>
-                  <a:txBody>
-                    <a:bodyPr wrap="square"/>
-                    <a:lstStyle/>
-                    <a:p>
-                      <a:r>
-                        <a:rPr sz="1100" b="0">
-                          <a:solidFill>
-                            <a:srgbClr val="282828"/>
-                          </a:solidFill>
-                          <a:latin typeface="Arial"/>
-                        </a:rPr>
-                        <a:t>on an eccentric section the pupil sphere was placed 190 mm from the beam</a:t>
-                      </a:r>
-                    </a:p>
-                  </a:txBody>
-                  <a:tcPr marL="54864" marR="54864" marT="18288" marB="18288">
-                    <a:solidFill>
-                      <a:srgbClr val="FFFFFF"/>
-                    </a:solidFill>
-                  </a:tcPr>
-                </a:tc>
-                <a:tc>
-                  <a:txBody>
-                    <a:bodyPr wrap="square"/>
-                    <a:lstStyle/>
-                    <a:p>
-                      <a:r>
-                        <a:rPr sz="1100" b="0">
-                          <a:solidFill>
-                            <a:srgbClr val="282828"/>
-                          </a:solidFill>
-                          <a:latin typeface="Arial"/>
-                        </a:rPr>
-                        <a:t>the stop at the prescription's object-space stop point</a:t>
-                      </a:r>
-                    </a:p>
-                  </a:txBody>
-                  <a:tcPr marL="54864" marR="54864" marT="18288" marB="18288">
-                    <a:solidFill>
-                      <a:srgbClr val="FFFFFF"/>
-                    </a:solidFill>
-                  </a:tcPr>
-                </a:tc>
-              </a:tr>
-              <a:tr h="468630">
-                <a:tc>
-                  <a:txBody>
-                    <a:bodyPr wrap="square"/>
-                    <a:lstStyle/>
-                    <a:p>
-                      <a:r>
-                        <a:rPr sz="1100" b="0">
-                          <a:solidFill>
-                            <a:srgbClr val="282828"/>
-                          </a:solidFill>
-                          <a:latin typeface="Arial"/>
-                        </a:rPr>
                         <a:t>Zernike origin at the parent vertex</a:t>
                       </a:r>
                     </a:p>
@@ -13733,13 +13801,81 @@
                           </a:solidFill>
                           <a:latin typeface="Arial"/>
                         </a:rPr>
+                        <a:t>a grating never vignetted by its aperture</a:t>
+                      </a:r>
+                    </a:p>
+                  </a:txBody>
+                  <a:tcPr marL="54864" marR="54864" marT="18288" marB="18288">
+                    <a:solidFill>
+                      <a:srgbClr val="FFFFFF"/>
+                    </a:solidFill>
+                  </a:tcPr>
+                </a:tc>
+                <a:tc>
+                  <a:txBody>
+                    <a:bodyPr wrap="square"/>
+                    <a:lstStyle/>
+                    <a:p>
+                      <a:r>
+                        <a:rPr sz="1100" b="0">
+                          <a:solidFill>
+                            <a:srgbClr val="282828"/>
+                          </a:solidFill>
+                          <a:latin typeface="Arial"/>
+                        </a:rPr>
+                        <a:t>the 3k end-to-end deck passed 21 % of its center-field rays 154–213 mm from the grating's axis against a 154 mm declared aperture; four grating routines computed the aperture verdict and then overwrote it with an unrelated check</a:t>
+                      </a:r>
+                    </a:p>
+                  </a:txBody>
+                  <a:tcPr marL="54864" marR="54864" marT="18288" marB="18288">
+                    <a:solidFill>
+                      <a:srgbClr val="FFFFFF"/>
+                    </a:solidFill>
+                  </a:tcPr>
+                </a:tc>
+                <a:tc>
+                  <a:txBody>
+                    <a:bodyPr wrap="square"/>
+                    <a:lstStyle/>
+                    <a:p>
+                      <a:r>
+                        <a:rPr sz="1100" b="0">
+                          <a:solidFill>
+                            <a:srgbClr val="282828"/>
+                          </a:solidFill>
+                          <a:latin typeface="Arial"/>
+                        </a:rPr>
+                        <a:t>the verdict is kept; the 1.5k row moves by 0.01 px, the 3k row by 0.4 px of smile</a:t>
+                      </a:r>
+                    </a:p>
+                  </a:txBody>
+                  <a:tcPr marL="54864" marR="54864" marT="18288" marB="18288">
+                    <a:solidFill>
+                      <a:srgbClr val="FFFFFF"/>
+                    </a:solidFill>
+                  </a:tcPr>
+                </a:tc>
+              </a:tr>
+              <a:tr h="657225">
+                <a:tc>
+                  <a:txBody>
+                    <a:bodyPr wrap="square"/>
+                    <a:lstStyle/>
+                    <a:p>
+                      <a:r>
+                        <a:rPr sz="1100" b="0">
+                          <a:solidFill>
+                            <a:srgbClr val="282828"/>
+                          </a:solidFill>
+                          <a:latin typeface="Arial"/>
+                        </a:rPr>
                         <a:t>clearance check blind to a beam through a disc</a:t>
                       </a:r>
                     </a:p>
                   </a:txBody>
                   <a:tcPr marL="54864" marR="54864" marT="18288" marB="18288">
                     <a:solidFill>
-                      <a:srgbClr val="FFFFFF"/>
+                      <a:srgbClr val="ECF1F6"/>
                     </a:solidFill>
                   </a:tcPr>
                 </a:tc>
@@ -13761,7 +13897,7 @@
                   </a:txBody>
                   <a:tcPr marL="54864" marR="54864" marT="18288" marB="18288">
                     <a:solidFill>
-                      <a:srgbClr val="FFFFFF"/>
+                      <a:srgbClr val="ECF1F6"/>
                     </a:solidFill>
                   </a:tcPr>
                 </a:tc>
@@ -13783,7 +13919,7 @@
                   </a:txBody>
                   <a:tcPr marL="54864" marR="54864" marT="18288" marB="18288">
                     <a:solidFill>
-                      <a:srgbClr val="FFFFFF"/>
+                      <a:srgbClr val="ECF1F6"/>
                     </a:solidFill>
                   </a:tcPr>
                 </a:tc>
@@ -13800,7 +13936,7 @@
         </p:nvSpPr>
         <p:spPr>
           <a:xfrm>
-            <a:off x="411480" y="4256532"/>
+            <a:off x="411480" y="5290947"/>
             <a:ext cx="11368735" cy="274320"/>
           </a:xfrm>
           <a:prstGeom prst="rect">
@@ -13826,7 +13962,7 @@
                 </a:solidFill>
                 <a:latin typeface="Arial"/>
               </a:rPr>
-              <a:t>Tests: tFwdRoot (5), tAsphHook (3), tStopApStop (4), tFreeformPole (3), tSpectrometerRx/test_clearance_sees_a_beam_through_a_body.  Each passed every existing check (rays passed, solves converged, decks loaded); what exposed the first four was a section whose beam is 190 mm from its parent's vertex, the fifth a form whose stop sits in its own beams.</a:t>
+              <a:t>Tests: tFwdRoot (5), tAsphHook (3), tStopApStop (4), tFreeformPole (3), tGratingAperture (3), tSpectrometerRx/test_clearance_sees_a_beam_through_a_body.  Each passed every existing check; what exposed the first four was a section whose beam is 190 mm from its parent's vertex, the fifth a telescope whose cone overfills the spectrometer's stop, the sixth a form whose stop sits in its own beams.</a:t>
             </a:r>
           </a:p>
         </p:txBody>
@@ -17655,7 +17791,7 @@
                           </a:solidFill>
                           <a:latin typeface="Arial"/>
                         </a:rPr>
-                        <a:t>0.51 px</a:t>
+                        <a:t>0.50 px</a:t>
                       </a:r>
                     </a:p>
                   </a:txBody>
@@ -18439,7 +18575,7 @@
                           </a:solidFill>
                           <a:latin typeface="Arial"/>
                         </a:rPr>
-                        <a:t>100 % at every field</a:t>
+                        <a:t>99 % at every field</a:t>
                       </a:r>
                     </a:p>
                   </a:txBody>
@@ -18824,7 +18960,7 @@
                 </a:solidFill>
                 <a:latin typeface="Arial"/>
               </a:rPr>
-              <a:t>Spectrometer: dyson5_size.txt row D (130 mm), dyson5_jim_3a.txt; telescope: dyson5_tA_GM_1k5_bAs.txt; together: dyson5_t5f_GM_1k5_bAs.txt, 7 fields × 7 wavelengths.  No coatings, no tolerances in any column.  The 3k module's columns: slide 12.</a:t>
+              <a:t>Spectrometer: dyson5_size.txt row D (130 mm), dyson5_jim_3a.txt; telescope: dyson5_tA_GM_1k5_bAs.txt; together: dyson5_t5f_GM_1k5_bAs_ap.txt, 7 fields × 7 wavelengths.  No coatings, no tolerances in any column.  The 3k module's columns: slide 12.</a:t>
             </a:r>
           </a:p>
         </p:txBody>
@@ -18897,7 +19033,7 @@
                 </a:solidFill>
                 <a:latin typeface="Arial"/>
               </a:rPr>
-              <a:t>Three off-axis aspheres feeding a 130 mm silica Dyson: smile 0.51, keystone 0.01, CRF 1.22, SRF 2.20 px over the whole strip; every field admitted; clearances +39 mm inside the telescope, +0.38 mm overall</a:t>
+              <a:t>Three off-axis aspheres feeding a 130 mm silica Dyson: smile 0.50, keystone 0.01, CRF 1.22, SRF 2.20 px over the whole strip; 99 % of the light admitted at every field; clearances +39 mm inside the telescope, +0.38 mm overall</a:t>
             </a:r>
           </a:p>
         </p:txBody>
@@ -19011,7 +19147,7 @@
       </p:sp>
       <p:pic>
         <p:nvPicPr>
-          <p:cNvPr id="6" name="Picture 5" descr="dyson5_t5f_GM_1k5_bAs_maps_rc.png"/>
+          <p:cNvPr id="6" name="Picture 5" descr="dyson5_t5f_GM_1k5_bAs_ap_maps_rc.png"/>
           <p:cNvPicPr>
             <a:picLocks noChangeAspect="1"/>
           </p:cNvPicPr>
@@ -19106,7 +19242,7 @@
                 </a:solidFill>
                 <a:latin typeface="Arial"/>
               </a:rPr>
-              <a:t>Energy in one pixel end to end: 0.78–0.89 over the central third of the strip, 0.65 at ±9 mm, 0.30–0.48 at the strip ends (±13.5 mm); the spectrometer alone puts 1.00 in the pixel, the rest is the telescope's 8–14 µm blur.  Plate scale 327 mm at the center, 331 at the edge (330 specified).  Record dyson5_t5f_GM_1k5_bAs.txt; prescription dyson5_t5f_GM_1k5_bAs_e2e.in, 11 elements.</a:t>
+              <a:t>Energy in one pixel end to end: 0.78–0.89 over the central third of the strip, 0.65 at ±9 mm, 0.30–0.48 at the strip ends (±13.5 mm); the spectrometer alone puts 1.00 in the pixel, the rest is the telescope's 8–14 µm blur.  Plate scale 327 mm at the center, 331 at the edge (330 specified).  Record dyson5_t5f_GM_1k5_bAs_ap.txt (re-scored 2026-10-06 with the grating's aperture enforced; 1 % of the sky beam falls outside the grating); prescription dyson5_t5f_GM_1k5_bAs_e2e.in, 11 elements.</a:t>
             </a:r>
           </a:p>
         </p:txBody>

</xml_diff>

<commit_message>
deck_dyson_record: layouts re-rendered with vignetted rays stopped at the grating; the 3k footnote at Dave's placement
Co-Authored-By: Claude Fable 5.1 <noreply@anthropic.com>
</commit_message>
<xml_diff>
--- a/demo_session/deck_dyson_record.pptx
+++ b/demo_session/deck_dyson_record.pptx
@@ -5112,7 +5112,7 @@
                 </a:solidFill>
                 <a:latin typeface="Arial"/>
               </a:rPr>
-              <a:t> Dyson as the engine traces it (meters); the beam overfills the grating (E7), which clips 2–5 % of the light per field.</a:t>
+              <a:t> Dyson as the engine traces it (meters); the beam overfills the grating (E7), and the rays it clips end there.</a:t>
             </a:r>
           </a:p>
         </p:txBody>
@@ -5297,8 +5297,8 @@
         </p:nvSpPr>
         <p:spPr>
           <a:xfrm>
-            <a:off x="6400800" y="5835396"/>
-            <a:ext cx="5394960" cy="274320"/>
+            <a:off x="7772400" y="5833872"/>
+            <a:ext cx="4023360" cy="274320"/>
           </a:xfrm>
           <a:prstGeom prst="rect">
             <a:avLst/>

</xml_diff>

<commit_message>
deck_dyson_record: Dave's two 3k-slide placements (maps caption, footnote) folded from the kept edit copy
Co-Authored-By: Claude Fable 5.1 <noreply@anthropic.com>
</commit_message>
<xml_diff>
--- a/demo_session/deck_dyson_record.pptx
+++ b/demo_session/deck_dyson_record.pptx
@@ -5258,8 +5258,8 @@
         </p:nvSpPr>
         <p:spPr>
           <a:xfrm>
-            <a:off x="7543800" y="5239512"/>
-            <a:ext cx="4343400" cy="559307"/>
+            <a:off x="7772400" y="5239512"/>
+            <a:ext cx="4114800" cy="559307"/>
           </a:xfrm>
           <a:prstGeom prst="rect">
             <a:avLst/>
@@ -5297,7 +5297,7 @@
         </p:nvSpPr>
         <p:spPr>
           <a:xfrm>
-            <a:off x="7772400" y="5833872"/>
+            <a:off x="7882127" y="5833872"/>
             <a:ext cx="4023360" cy="274320"/>
           </a:xfrm>
           <a:prstGeom prst="rect">

</xml_diff>

<commit_message>
deck_dyson_record: final for sending -- DRAFT marker removed (the review statement appears), the title note at the re-scored 3k CRF
Co-Authored-By: Claude Fable 5.1 <noreply@anthropic.com>
</commit_message>
<xml_diff>
--- a/demo_session/deck_dyson_record.pptx
+++ b/demo_session/deck_dyson_record.pptx
@@ -3233,7 +3233,46 @@
                 </a:solidFill>
                 <a:latin typeface="Arial"/>
               </a:rPr>
-              <a:t>DRAFT for review, 2026-10-06.  The 1.5k module (1500 cross-track pixels, a 27 mm slit) has a spectrometer of record and a first telescope that together image at the pixel end to end: smile 0.50, keystone 0.01, CRF 1.22, SRF 2.20 pixels, every clearance positive; four such modules carry 6000 pixels in 6.6 kg of fused silica.  The telescope is not finished and the 3k module's resolution is not yet at the pixel level (CRF 4.2 pixels); the deck asks for help with both.</a:t>
+              <a:t>The 1.5k module has a spectrometer of record and a first telescope that together image at the pixel end to end: smile 0.50, keystone 0.01, CRF 1.22, SRF 2.20 pixels, every clearance positive; four such modules carry 6000 pixels in 6.6 kg of fused silica.  The telescope is not finished and the 3k module's resolution is not yet at the pixel level (CRF 4.0 pixels); the deck asks for help with both.</a:t>
+            </a:r>
+          </a:p>
+        </p:txBody>
+      </p:sp>
+      <p:sp>
+        <p:nvSpPr>
+          <p:cNvPr id="4" name="TextBox 3"/>
+          <p:cNvSpPr txBox="1"/>
+          <p:nvPr/>
+        </p:nvSpPr>
+        <p:spPr>
+          <a:xfrm>
+            <a:off x="813816" y="6309360"/>
+            <a:ext cx="10543032" cy="292608"/>
+          </a:xfrm>
+          <a:prstGeom prst="rect">
+            <a:avLst/>
+          </a:prstGeom>
+          <a:noFill/>
+        </p:spPr>
+        <p:txBody>
+          <a:bodyPr wrap="square">
+            <a:spAutoFit/>
+          </a:bodyPr>
+          <a:lstStyle/>
+          <a:p>
+            <a:pPr algn="ctr">
+              <a:spcAft>
+                <a:spcPts val="0"/>
+              </a:spcAft>
+            </a:pPr>
+            <a:r>
+              <a:rPr sz="950" b="0">
+                <a:solidFill>
+                  <a:srgbClr val="6E6E6E"/>
+                </a:solidFill>
+                <a:latin typeface="Arial"/>
+              </a:rPr>
+              <a:t>This document has been reviewed and determined not to contain export-controlled information</a:t>
             </a:r>
           </a:p>
         </p:txBody>

</xml_diff>

<commit_message>
deck_dyson_record: Dave's last 3k-slide placement (the bullets block to x 0.25, w 8.25) folded; edit copy synced to the final build
Co-Authored-By: Claude Fable 5.1 <noreply@anthropic.com>
</commit_message>
<xml_diff>
--- a/demo_session/deck_dyson_record.pptx
+++ b/demo_session/deck_dyson_record.pptx
@@ -5164,8 +5164,8 @@
         </p:nvSpPr>
         <p:spPr>
           <a:xfrm>
-            <a:off x="411480" y="5001768"/>
-            <a:ext cx="6675120" cy="274320"/>
+            <a:off x="228600" y="5001768"/>
+            <a:ext cx="7543800" cy="274320"/>
           </a:xfrm>
           <a:prstGeom prst="rect">
             <a:avLst/>

</xml_diff>